<commit_message>
Restyle cesarean slides: gray background, underline-only cards, larger small text
Co-Authored-By: Claude Opus 5.5 <noreply@anthropic.com>
Claude-Session: https://claude.ai/code/session_017AawXZuegeVsAfmgt6D2q5
</commit_message>
<xml_diff>
--- a/slides/⑤帝王切開.pptx
+++ b/slides/⑤帝王切開.pptx
@@ -111,7 +111,7 @@
   <p:extLst>
     <p:ext uri="{521415D9-36F7-43E2-AB2F-B90AF26B5E84}">
       <p14:sectionLst xmlns:p14="http://schemas.microsoft.com/office/powerpoint/2010/main">
-        <p14:section name="⑤ 帝王切開" id="{cfd0b04b-85c4-2972-f99e-ea90cc643a0e}">
+        <p14:section name="⑤ 帝王切開" id="{2a89da97-6e39-f401-fa6f-5359e217ebb6}">
           <p14:sldIdLst>
             <p14:sldId id="256"/>
             <p14:sldId id="257"/>
@@ -616,7 +616,7 @@
             <a:r>
               <a:rPr lang="en-US" dirty="0"/>
               <a:t>帝王切開を行う理由（適応）は、母体側・胎児側・分娩経過の3つに分けると整理しやすいです。
-母体側：前回帝王切開や子宮筋腫の手術歴があると、陣痛で子宮の傷が裂ける（子宮破裂）おそれがあります。前置胎盤は胎盤が出口をふさいでいるため経腟分娩ができません。
+母体側：前回帝王切開や子宮筋腫の手術歴があると、陣痛で子宮の傷が裂ける（子宮破裂）おそれがあります。前置胎盤は胎盤が出口をふさいでいるため経腟分娩ができません。重症の妊娠高血圧症候群やHELLP症候群も適応になります。
 胎児側：胎児機能不全（赤ちゃんが苦しいサイン）、逆子などの胎位異常、臍帯脱出、母子感染の予防などがあります。
 分娩経過：陣痛が来てもお産が進まない分娩停止や、赤ちゃんの頭が骨盤を通れない児頭骨盤不均衡などです。
 いずれも『経腟分娩より帝王切開の方が安全』と判断された場合に選択されます。</a:t>
@@ -971,7 +971,7 @@
     <p:bg>
       <p:bgPr>
         <a:solidFill>
-          <a:schemeClr val="bg1"/>
+          <a:schemeClr val="bg2"/>
         </a:solidFill>
       </p:bgPr>
     </p:bg>
@@ -1040,8 +1040,8 @@
         </p:nvSpPr>
         <p:spPr>
           <a:xfrm>
-            <a:off x="8321040" y="4773168"/>
-            <a:ext cx="365760" cy="228600"/>
+            <a:off x="8229600" y="4727448"/>
+            <a:ext cx="457200" cy="274320"/>
           </a:xfrm>
           <a:prstGeom prst="rect">
             <a:avLst/>
@@ -1056,7 +1056,7 @@
           <a:bodyPr/>
           <a:lstStyle>
             <a:lvl1pPr>
-              <a:defRPr sz="900">
+              <a:defRPr sz="1300">
                 <a:solidFill>
                   <a:schemeClr val="accent5"/>
                 </a:solidFill>
@@ -1110,8 +1110,8 @@
         </p:nvSpPr>
         <p:spPr>
           <a:xfrm>
-            <a:off x="8321040" y="4773168"/>
-            <a:ext cx="365760" cy="228600"/>
+            <a:off x="8229600" y="4727448"/>
+            <a:ext cx="457200" cy="274320"/>
           </a:xfrm>
           <a:prstGeom prst="rect">
             <a:avLst/>
@@ -1126,7 +1126,7 @@
           <a:bodyPr/>
           <a:lstStyle>
             <a:lvl1pPr>
-              <a:defRPr sz="900">
+              <a:defRPr sz="1300">
                 <a:solidFill>
                   <a:schemeClr val="accent5"/>
                 </a:solidFill>
@@ -1461,228 +1461,44 @@
       </p:sp>
       <p:sp>
         <p:nvSpPr>
-          <p:cNvPr id="3" name="def-card"/>
+          <p:cNvPr id="3" name="def-decor"/>
           <p:cNvSpPr/>
           <p:nvPr/>
         </p:nvSpPr>
         <p:spPr>
           <a:xfrm>
-            <a:off x="457200" y="1005840"/>
-            <a:ext cx="2743200" cy="3566160"/>
-          </a:xfrm>
-          <a:prstGeom prst="roundRect">
-            <a:avLst>
-              <a:gd name="adj" fmla="val 3333"/>
-            </a:avLst>
+            <a:off x="2331720" y="3611880"/>
+            <a:ext cx="822960" cy="822960"/>
+          </a:xfrm>
+          <a:prstGeom prst="ellipse">
+            <a:avLst/>
           </a:prstGeom>
           <a:solidFill>
-            <a:schemeClr val="bg2"/>
+            <a:schemeClr val="tx2">
+              <a:alpha val="5000"/>
+            </a:schemeClr>
           </a:solidFill>
           <a:ln/>
         </p:spPr>
       </p:sp>
       <p:sp>
         <p:nvSpPr>
-          <p:cNvPr id="4" name="Text 2"/>
-          <p:cNvSpPr txBox="1"/>
-          <p:nvPr/>
-        </p:nvSpPr>
-        <p:spPr>
-          <a:xfrm>
-            <a:off x="685800" y="1188720"/>
-            <a:ext cx="2286000" cy="274320"/>
-          </a:xfrm>
-          <a:prstGeom prst="rect">
-            <a:avLst/>
-          </a:prstGeom>
-          <a:noFill/>
-          <a:ln/>
-        </p:spPr>
-        <p:txBody>
-          <a:bodyPr wrap="square" lIns="0" tIns="0" rIns="0" bIns="0" rtlCol="0" anchor="ctr"/>
-          <a:lstStyle/>
-          <a:p>
-            <a:pPr indent="0" marL="0">
-              <a:buNone/>
-            </a:pPr>
-            <a:r>
-              <a:rPr lang="en-US" sz="1400" b="1" dirty="0">
-                <a:solidFill>
-                  <a:schemeClr val="tx2"/>
-                </a:solidFill>
-              </a:rPr>
-              <a:t>定義</a:t>
-            </a:r>
-            <a:endParaRPr lang="en-US" sz="1400" dirty="0"/>
-          </a:p>
-        </p:txBody>
-      </p:sp>
-      <p:sp>
-        <p:nvSpPr>
-          <p:cNvPr id="5" name="Text 3"/>
-          <p:cNvSpPr txBox="1"/>
-          <p:nvPr/>
-        </p:nvSpPr>
-        <p:spPr>
-          <a:xfrm>
-            <a:off x="685800" y="1508760"/>
-            <a:ext cx="2331720" cy="731520"/>
-          </a:xfrm>
-          <a:prstGeom prst="rect">
-            <a:avLst/>
-          </a:prstGeom>
-          <a:noFill/>
-          <a:ln/>
-        </p:spPr>
-        <p:txBody>
-          <a:bodyPr wrap="square" lIns="0" tIns="0" rIns="0" bIns="0" rtlCol="0" anchor="t"/>
-          <a:lstStyle/>
-          <a:p>
-            <a:pPr indent="0" marL="0">
-              <a:buNone/>
-            </a:pPr>
-            <a:r>
-              <a:rPr lang="en-US" sz="1500" b="1" dirty="0">
-                <a:solidFill>
-                  <a:schemeClr val="tx1"/>
-                </a:solidFill>
-              </a:rPr>
-              <a:t>お腹と子宮の壁を切開して、胎児を取り出す手術</a:t>
-            </a:r>
-            <a:endParaRPr lang="en-US" sz="1500" dirty="0"/>
-          </a:p>
-        </p:txBody>
-      </p:sp>
-      <p:sp>
-        <p:nvSpPr>
-          <p:cNvPr id="6" name="stat"/>
-          <p:cNvSpPr txBox="1"/>
-          <p:nvPr/>
-        </p:nvSpPr>
-        <p:spPr>
-          <a:xfrm>
-            <a:off x="685800" y="2514600"/>
-            <a:ext cx="2377440" cy="640080"/>
-          </a:xfrm>
-          <a:prstGeom prst="rect">
-            <a:avLst/>
-          </a:prstGeom>
-          <a:noFill/>
-          <a:ln/>
-        </p:spPr>
-        <p:txBody>
-          <a:bodyPr wrap="square" lIns="0" tIns="0" rIns="0" bIns="0" rtlCol="0" anchor="ctr"/>
-          <a:lstStyle/>
-          <a:p>
-            <a:pPr indent="0" marL="0">
-              <a:buNone/>
-            </a:pPr>
-            <a:r>
-              <a:rPr lang="en-US" sz="3000" b="1" dirty="0">
-                <a:solidFill>
-                  <a:schemeClr val="tx2"/>
-                </a:solidFill>
-              </a:rPr>
-              <a:t>約5人に1人</a:t>
-            </a:r>
-            <a:endParaRPr lang="en-US" sz="3000" dirty="0"/>
-          </a:p>
-        </p:txBody>
-      </p:sp>
-      <p:sp>
-        <p:nvSpPr>
-          <p:cNvPr id="7" name="Text 5"/>
-          <p:cNvSpPr txBox="1"/>
-          <p:nvPr/>
-        </p:nvSpPr>
-        <p:spPr>
-          <a:xfrm>
-            <a:off x="685800" y="3200400"/>
-            <a:ext cx="2331720" cy="731520"/>
-          </a:xfrm>
-          <a:prstGeom prst="rect">
-            <a:avLst/>
-          </a:prstGeom>
-          <a:noFill/>
-          <a:ln/>
-        </p:spPr>
-        <p:txBody>
-          <a:bodyPr wrap="square" lIns="0" tIns="0" rIns="0" bIns="0" rtlCol="0" anchor="t"/>
-          <a:lstStyle/>
-          <a:p>
-            <a:pPr indent="0" marL="0">
-              <a:buNone/>
-            </a:pPr>
-            <a:r>
-              <a:rPr lang="en-US" sz="1200" dirty="0">
-                <a:solidFill>
-                  <a:schemeClr val="tx1"/>
-                </a:solidFill>
-              </a:rPr>
-              <a:t>日本のお産のうち帝王切開で生まれる割合（約20%）。年々増加している</a:t>
-            </a:r>
-            <a:endParaRPr lang="en-US" sz="1200" dirty="0"/>
-          </a:p>
-        </p:txBody>
-      </p:sp>
-      <p:sp>
-        <p:nvSpPr>
-          <p:cNvPr id="8" name="Text 6"/>
-          <p:cNvSpPr txBox="1"/>
-          <p:nvPr/>
-        </p:nvSpPr>
-        <p:spPr>
-          <a:xfrm>
-            <a:off x="685800" y="3977640"/>
-            <a:ext cx="2331720" cy="457200"/>
-          </a:xfrm>
-          <a:prstGeom prst="rect">
-            <a:avLst/>
-          </a:prstGeom>
-          <a:noFill/>
-          <a:ln/>
-        </p:spPr>
-        <p:txBody>
-          <a:bodyPr wrap="square" lIns="0" tIns="0" rIns="0" bIns="0" rtlCol="0" anchor="t"/>
-          <a:lstStyle/>
-          <a:p>
-            <a:pPr indent="0" marL="0">
-              <a:buNone/>
-            </a:pPr>
-            <a:r>
-              <a:rPr lang="en-US" sz="1000" dirty="0">
-                <a:solidFill>
-                  <a:schemeClr val="accent5"/>
-                </a:solidFill>
-              </a:rPr>
-              <a:t>一般病院 約27%・診療所 約15%（2020年 医療施設調査）</a:t>
-            </a:r>
-            <a:endParaRPr lang="en-US" sz="1000" dirty="0"/>
-          </a:p>
-        </p:txBody>
-      </p:sp>
-      <p:sp>
-        <p:nvSpPr>
-          <p:cNvPr id="9" name="type-card-0"/>
+          <p:cNvPr id="4" name="def-rule"/>
           <p:cNvSpPr/>
           <p:nvPr/>
         </p:nvSpPr>
         <p:spPr>
           <a:xfrm>
-            <a:off x="3429000" y="1005840"/>
-            <a:ext cx="5257800" cy="1691640"/>
-          </a:xfrm>
-          <a:prstGeom prst="roundRect">
-            <a:avLst>
-              <a:gd name="adj" fmla="val 5405"/>
-            </a:avLst>
-          </a:prstGeom>
-          <a:solidFill>
-            <a:schemeClr val="bg1"/>
-          </a:solidFill>
+            <a:off x="457200" y="4526280"/>
+            <a:ext cx="2743200" cy="0"/>
+          </a:xfrm>
+          <a:prstGeom prst="line">
+            <a:avLst/>
+          </a:prstGeom>
+          <a:noFill/>
           <a:ln w="12700">
             <a:solidFill>
-              <a:srgbClr val="D9D9D9"/>
+              <a:srgbClr val="BFBFBF"/>
             </a:solidFill>
             <a:prstDash val="solid"/>
           </a:ln>
@@ -1690,27 +1506,246 @@
       </p:sp>
       <p:sp>
         <p:nvSpPr>
-          <p:cNvPr id="10" name="type-0-circle"/>
+          <p:cNvPr id="5" name="Text 3"/>
+          <p:cNvSpPr txBox="1"/>
+          <p:nvPr/>
+        </p:nvSpPr>
+        <p:spPr>
+          <a:xfrm>
+            <a:off x="457200" y="1005840"/>
+            <a:ext cx="2651760" cy="274320"/>
+          </a:xfrm>
+          <a:prstGeom prst="rect">
+            <a:avLst/>
+          </a:prstGeom>
+          <a:noFill/>
+          <a:ln/>
+        </p:spPr>
+        <p:txBody>
+          <a:bodyPr wrap="square" lIns="0" tIns="0" rIns="0" bIns="0" rtlCol="0" anchor="ctr"/>
+          <a:lstStyle/>
+          <a:p>
+            <a:pPr indent="0" marL="0">
+              <a:buNone/>
+            </a:pPr>
+            <a:r>
+              <a:rPr lang="en-US" sz="1400" b="1" dirty="0">
+                <a:solidFill>
+                  <a:schemeClr val="tx2"/>
+                </a:solidFill>
+              </a:rPr>
+              <a:t>定義</a:t>
+            </a:r>
+            <a:endParaRPr lang="en-US" sz="1400" dirty="0"/>
+          </a:p>
+        </p:txBody>
+      </p:sp>
+      <p:sp>
+        <p:nvSpPr>
+          <p:cNvPr id="6" name="Text 4"/>
+          <p:cNvSpPr txBox="1"/>
+          <p:nvPr/>
+        </p:nvSpPr>
+        <p:spPr>
+          <a:xfrm>
+            <a:off x="457200" y="1325880"/>
+            <a:ext cx="2651760" cy="731520"/>
+          </a:xfrm>
+          <a:prstGeom prst="rect">
+            <a:avLst/>
+          </a:prstGeom>
+          <a:noFill/>
+          <a:ln/>
+        </p:spPr>
+        <p:txBody>
+          <a:bodyPr wrap="square" lIns="0" tIns="0" rIns="0" bIns="0" rtlCol="0" anchor="t"/>
+          <a:lstStyle/>
+          <a:p>
+            <a:pPr indent="0" marL="0">
+              <a:buNone/>
+            </a:pPr>
+            <a:r>
+              <a:rPr lang="en-US" sz="1500" b="1" dirty="0">
+                <a:solidFill>
+                  <a:schemeClr val="tx1"/>
+                </a:solidFill>
+              </a:rPr>
+              <a:t>お腹と子宮の壁を切開して、胎児を取り出す手術</a:t>
+            </a:r>
+            <a:endParaRPr lang="en-US" sz="1500" dirty="0"/>
+          </a:p>
+        </p:txBody>
+      </p:sp>
+      <p:sp>
+        <p:nvSpPr>
+          <p:cNvPr id="7" name="stat"/>
+          <p:cNvSpPr txBox="1"/>
+          <p:nvPr/>
+        </p:nvSpPr>
+        <p:spPr>
+          <a:xfrm>
+            <a:off x="457200" y="2148840"/>
+            <a:ext cx="2651760" cy="548640"/>
+          </a:xfrm>
+          <a:prstGeom prst="rect">
+            <a:avLst/>
+          </a:prstGeom>
+          <a:noFill/>
+          <a:ln/>
+        </p:spPr>
+        <p:txBody>
+          <a:bodyPr wrap="square" lIns="0" tIns="0" rIns="0" bIns="0" rtlCol="0" anchor="ctr"/>
+          <a:lstStyle/>
+          <a:p>
+            <a:pPr indent="0" marL="0">
+              <a:buNone/>
+            </a:pPr>
+            <a:r>
+              <a:rPr lang="en-US" sz="3000" b="1" dirty="0">
+                <a:solidFill>
+                  <a:schemeClr val="tx2"/>
+                </a:solidFill>
+              </a:rPr>
+              <a:t>約5人に1人</a:t>
+            </a:r>
+            <a:endParaRPr lang="en-US" sz="3000" dirty="0"/>
+          </a:p>
+        </p:txBody>
+      </p:sp>
+      <p:sp>
+        <p:nvSpPr>
+          <p:cNvPr id="8" name="Text 6"/>
+          <p:cNvSpPr txBox="1"/>
+          <p:nvPr/>
+        </p:nvSpPr>
+        <p:spPr>
+          <a:xfrm>
+            <a:off x="457200" y="2743200"/>
+            <a:ext cx="2651760" cy="685800"/>
+          </a:xfrm>
+          <a:prstGeom prst="rect">
+            <a:avLst/>
+          </a:prstGeom>
+          <a:noFill/>
+          <a:ln/>
+        </p:spPr>
+        <p:txBody>
+          <a:bodyPr wrap="square" lIns="0" tIns="0" rIns="0" bIns="0" rtlCol="0" anchor="t"/>
+          <a:lstStyle/>
+          <a:p>
+            <a:pPr indent="0" marL="0">
+              <a:buNone/>
+            </a:pPr>
+            <a:r>
+              <a:rPr lang="en-US" sz="1200" dirty="0">
+                <a:solidFill>
+                  <a:schemeClr val="tx1"/>
+                </a:solidFill>
+              </a:rPr>
+              <a:t>日本のお産のうち帝王切開で生まれる割合（約20%）。年々増加している</a:t>
+            </a:r>
+            <a:endParaRPr lang="en-US" sz="1200" dirty="0"/>
+          </a:p>
+        </p:txBody>
+      </p:sp>
+      <p:sp>
+        <p:nvSpPr>
+          <p:cNvPr id="9" name="Text 7"/>
+          <p:cNvSpPr txBox="1"/>
+          <p:nvPr/>
+        </p:nvSpPr>
+        <p:spPr>
+          <a:xfrm>
+            <a:off x="457200" y="3520440"/>
+            <a:ext cx="2651760" cy="685800"/>
+          </a:xfrm>
+          <a:prstGeom prst="rect">
+            <a:avLst/>
+          </a:prstGeom>
+          <a:noFill/>
+          <a:ln/>
+        </p:spPr>
+        <p:txBody>
+          <a:bodyPr wrap="square" lIns="0" tIns="0" rIns="0" bIns="0" rtlCol="0" anchor="t"/>
+          <a:lstStyle/>
+          <a:p>
+            <a:pPr indent="0" marL="0">
+              <a:buNone/>
+            </a:pPr>
+            <a:r>
+              <a:rPr lang="en-US" sz="1300" dirty="0">
+                <a:solidFill>
+                  <a:schemeClr val="accent5"/>
+                </a:solidFill>
+              </a:rPr>
+              <a:t>一般病院 約27%・診療所 約15%</a:t>
+            </a:r>
+            <a:endParaRPr lang="en-US" sz="1300" dirty="0"/>
+          </a:p>
+          <a:p>
+            <a:pPr indent="0" marL="0">
+              <a:buNone/>
+            </a:pPr>
+            <a:r>
+              <a:rPr lang="en-US" sz="1300" dirty="0">
+                <a:solidFill>
+                  <a:schemeClr val="accent5"/>
+                </a:solidFill>
+              </a:rPr>
+              <a:t>（2020年 医療施設調査）</a:t>
+            </a:r>
+            <a:endParaRPr lang="en-US" sz="1300" dirty="0"/>
+          </a:p>
+        </p:txBody>
+      </p:sp>
+      <p:sp>
+        <p:nvSpPr>
+          <p:cNvPr id="10" name="type-0-decor"/>
           <p:cNvSpPr/>
           <p:nvPr/>
         </p:nvSpPr>
         <p:spPr>
           <a:xfrm>
-            <a:off x="3611880" y="1188720"/>
-            <a:ext cx="502920" cy="502920"/>
-          </a:xfrm>
-          <a:prstGeom prst="ellipse">
+            <a:off x="7818120" y="1737360"/>
+            <a:ext cx="822960" cy="822960"/>
+          </a:xfrm>
+          <a:prstGeom prst="triangle">
             <a:avLst/>
           </a:prstGeom>
           <a:solidFill>
-            <a:schemeClr val="accent4"/>
+            <a:schemeClr val="tx2">
+              <a:alpha val="5000"/>
+            </a:schemeClr>
           </a:solidFill>
           <a:ln/>
+        </p:spPr>
+      </p:sp>
+      <p:sp>
+        <p:nvSpPr>
+          <p:cNvPr id="11" name="type-0-rule"/>
+          <p:cNvSpPr/>
+          <p:nvPr/>
+        </p:nvSpPr>
+        <p:spPr>
+          <a:xfrm>
+            <a:off x="3520440" y="2651760"/>
+            <a:ext cx="5166360" cy="0"/>
+          </a:xfrm>
+          <a:prstGeom prst="line">
+            <a:avLst/>
+          </a:prstGeom>
+          <a:noFill/>
+          <a:ln w="12700">
+            <a:solidFill>
+              <a:srgbClr val="BFBFBF"/>
+            </a:solidFill>
+            <a:prstDash val="solid"/>
+          </a:ln>
         </p:spPr>
       </p:sp>
       <p:pic>
         <p:nvPicPr>
-          <p:cNvPr id="11" name="type-0-icon" descr="preencoded.png">    </p:cNvPr>
+          <p:cNvPr id="12" name="type-0-icon" descr="preencoded.png">    </p:cNvPr>
           <p:cNvPicPr>
             <a:picLocks noChangeAspect="1"/>
           </p:cNvPicPr>
@@ -1724,8 +1759,8 @@
         </p:blipFill>
         <p:spPr>
           <a:xfrm>
-            <a:off x="3732581" y="1309421"/>
-            <a:ext cx="261518" cy="261518"/>
+            <a:off x="3520440" y="1051560"/>
+            <a:ext cx="365760" cy="365760"/>
           </a:xfrm>
           <a:prstGeom prst="rect">
             <a:avLst/>
@@ -1734,14 +1769,14 @@
       </p:pic>
       <p:sp>
         <p:nvSpPr>
-          <p:cNvPr id="12" name="Text 9"/>
-          <p:cNvSpPr txBox="1"/>
-          <p:nvPr/>
-        </p:nvSpPr>
-        <p:spPr>
-          <a:xfrm>
-            <a:off x="4297680" y="1188720"/>
-            <a:ext cx="4206240" cy="365760"/>
+          <p:cNvPr id="13" name="Text 10"/>
+          <p:cNvSpPr txBox="1"/>
+          <p:nvPr/>
+        </p:nvSpPr>
+        <p:spPr>
+          <a:xfrm>
+            <a:off x="4023360" y="1005840"/>
+            <a:ext cx="4572000" cy="457200"/>
           </a:xfrm>
           <a:prstGeom prst="rect">
             <a:avLst/>
@@ -1770,14 +1805,14 @@
       </p:sp>
       <p:sp>
         <p:nvSpPr>
-          <p:cNvPr id="13" name="Text 10"/>
-          <p:cNvSpPr txBox="1"/>
-          <p:nvPr/>
-        </p:nvSpPr>
-        <p:spPr>
-          <a:xfrm>
-            <a:off x="4297680" y="1600200"/>
-            <a:ext cx="4251960" cy="1005840"/>
+          <p:cNvPr id="14" name="Text 11"/>
+          <p:cNvSpPr txBox="1"/>
+          <p:nvPr/>
+        </p:nvSpPr>
+        <p:spPr>
+          <a:xfrm>
+            <a:off x="4023360" y="1508760"/>
+            <a:ext cx="4572000" cy="1051560"/>
           </a:xfrm>
           <a:prstGeom prst="rect">
             <a:avLst/>
@@ -1846,54 +1881,52 @@
       </p:sp>
       <p:sp>
         <p:nvSpPr>
-          <p:cNvPr id="14" name="type-card-1"/>
+          <p:cNvPr id="15" name="type-1-decor"/>
           <p:cNvSpPr/>
           <p:nvPr/>
         </p:nvSpPr>
         <p:spPr>
           <a:xfrm>
-            <a:off x="3429000" y="2880360"/>
-            <a:ext cx="5257800" cy="1691640"/>
-          </a:xfrm>
-          <a:prstGeom prst="roundRect">
-            <a:avLst>
-              <a:gd name="adj" fmla="val 5405"/>
-            </a:avLst>
+            <a:off x="7818120" y="3611880"/>
+            <a:ext cx="822960" cy="822960"/>
+          </a:xfrm>
+          <a:prstGeom prst="rect">
+            <a:avLst/>
           </a:prstGeom>
           <a:solidFill>
-            <a:schemeClr val="bg1"/>
+            <a:schemeClr val="tx2">
+              <a:alpha val="5000"/>
+            </a:schemeClr>
           </a:solidFill>
+          <a:ln/>
+        </p:spPr>
+      </p:sp>
+      <p:sp>
+        <p:nvSpPr>
+          <p:cNvPr id="16" name="type-1-rule"/>
+          <p:cNvSpPr/>
+          <p:nvPr/>
+        </p:nvSpPr>
+        <p:spPr>
+          <a:xfrm>
+            <a:off x="3520440" y="4526280"/>
+            <a:ext cx="5166360" cy="0"/>
+          </a:xfrm>
+          <a:prstGeom prst="line">
+            <a:avLst/>
+          </a:prstGeom>
+          <a:noFill/>
           <a:ln w="12700">
             <a:solidFill>
-              <a:srgbClr val="D9D9D9"/>
+              <a:srgbClr val="BFBFBF"/>
             </a:solidFill>
             <a:prstDash val="solid"/>
           </a:ln>
         </p:spPr>
       </p:sp>
-      <p:sp>
-        <p:nvSpPr>
-          <p:cNvPr id="15" name="type-1-circle"/>
-          <p:cNvSpPr/>
-          <p:nvPr/>
-        </p:nvSpPr>
-        <p:spPr>
-          <a:xfrm>
-            <a:off x="3611880" y="3063240"/>
-            <a:ext cx="502920" cy="502920"/>
-          </a:xfrm>
-          <a:prstGeom prst="ellipse">
-            <a:avLst/>
-          </a:prstGeom>
-          <a:solidFill>
-            <a:schemeClr val="bg2"/>
-          </a:solidFill>
-          <a:ln/>
-        </p:spPr>
-      </p:sp>
       <p:pic>
         <p:nvPicPr>
-          <p:cNvPr id="16" name="type-1-icon" descr="preencoded.png">    </p:cNvPr>
+          <p:cNvPr id="17" name="type-1-icon" descr="preencoded.png">    </p:cNvPr>
           <p:cNvPicPr>
             <a:picLocks noChangeAspect="1"/>
           </p:cNvPicPr>
@@ -1907,8 +1940,8 @@
         </p:blipFill>
         <p:spPr>
           <a:xfrm>
-            <a:off x="3732581" y="3183941"/>
-            <a:ext cx="261518" cy="261518"/>
+            <a:off x="3520440" y="2926080"/>
+            <a:ext cx="365760" cy="365760"/>
           </a:xfrm>
           <a:prstGeom prst="rect">
             <a:avLst/>
@@ -1917,14 +1950,14 @@
       </p:pic>
       <p:sp>
         <p:nvSpPr>
-          <p:cNvPr id="17" name="Text 13"/>
-          <p:cNvSpPr txBox="1"/>
-          <p:nvPr/>
-        </p:nvSpPr>
-        <p:spPr>
-          <a:xfrm>
-            <a:off x="4297680" y="3063240"/>
-            <a:ext cx="4206240" cy="365760"/>
+          <p:cNvPr id="18" name="Text 14"/>
+          <p:cNvSpPr txBox="1"/>
+          <p:nvPr/>
+        </p:nvSpPr>
+        <p:spPr>
+          <a:xfrm>
+            <a:off x="4023360" y="2880360"/>
+            <a:ext cx="4572000" cy="457200"/>
           </a:xfrm>
           <a:prstGeom prst="rect">
             <a:avLst/>
@@ -1953,14 +1986,14 @@
       </p:sp>
       <p:sp>
         <p:nvSpPr>
-          <p:cNvPr id="18" name="Text 14"/>
-          <p:cNvSpPr txBox="1"/>
-          <p:nvPr/>
-        </p:nvSpPr>
-        <p:spPr>
-          <a:xfrm>
-            <a:off x="4297680" y="3474720"/>
-            <a:ext cx="4251960" cy="1005840"/>
+          <p:cNvPr id="19" name="Text 15"/>
+          <p:cNvSpPr txBox="1"/>
+          <p:nvPr/>
+        </p:nvSpPr>
+        <p:spPr>
+          <a:xfrm>
+            <a:off x="4023360" y="3383280"/>
+            <a:ext cx="4572000" cy="1051560"/>
           </a:xfrm>
           <a:prstGeom prst="rect">
             <a:avLst/>
@@ -2029,14 +2062,14 @@
       </p:sp>
       <p:sp>
         <p:nvSpPr>
-          <p:cNvPr id="19" name="source"/>
-          <p:cNvSpPr txBox="1"/>
-          <p:nvPr/>
-        </p:nvSpPr>
-        <p:spPr>
-          <a:xfrm>
-            <a:off x="457200" y="4773168"/>
-            <a:ext cx="7680960" cy="228600"/>
+          <p:cNvPr id="20" name="source"/>
+          <p:cNvSpPr txBox="1"/>
+          <p:nvPr/>
+        </p:nvSpPr>
+        <p:spPr>
+          <a:xfrm>
+            <a:off x="457200" y="4727448"/>
+            <a:ext cx="7680960" cy="274320"/>
           </a:xfrm>
           <a:prstGeom prst="rect">
             <a:avLst/>
@@ -2052,14 +2085,14 @@
               <a:buNone/>
             </a:pPr>
             <a:r>
-              <a:rPr lang="en-US" sz="900" dirty="0">
+              <a:rPr lang="en-US" sz="1300" dirty="0">
                 <a:solidFill>
                   <a:schemeClr val="accent5"/>
                 </a:solidFill>
               </a:rPr>
               <a:t>参考：産婦人科診療ガイドライン 産科編2023／病気がみえる vol.10 産科</a:t>
             </a:r>
-            <a:endParaRPr lang="en-US" sz="900" dirty="0"/>
+            <a:endParaRPr lang="en-US" sz="1300" dirty="0"/>
           </a:p>
         </p:txBody>
       </p:sp>
@@ -2075,8 +2108,8 @@
         </p:nvSpPr>
         <p:spPr>
           <a:xfrm>
-            <a:off x="8321040" y="4773168"/>
-            <a:ext cx="365760" cy="228600"/>
+            <a:off x="8229600" y="4727448"/>
+            <a:ext cx="457200" cy="274320"/>
           </a:xfrm>
           <a:prstGeom prst="rect">
             <a:avLst/>
@@ -2091,7 +2124,7 @@
           <a:bodyPr/>
           <a:lstStyle>
             <a:lvl1pPr>
-              <a:defRPr sz="900">
+              <a:defRPr sz="1300">
                 <a:solidFill>
                   <a:schemeClr val="accent5"/>
                 </a:solidFill>
@@ -2173,49 +2206,47 @@
       </p:sp>
       <p:sp>
         <p:nvSpPr>
-          <p:cNvPr id="3" name="indic-card-0"/>
+          <p:cNvPr id="3" name="indic-0-decor"/>
           <p:cNvSpPr/>
           <p:nvPr/>
         </p:nvSpPr>
         <p:spPr>
           <a:xfrm>
-            <a:off x="457200" y="1005840"/>
-            <a:ext cx="2560320" cy="2926080"/>
-          </a:xfrm>
-          <a:prstGeom prst="roundRect">
-            <a:avLst>
-              <a:gd name="adj" fmla="val 3571"/>
-            </a:avLst>
+            <a:off x="2148840" y="3017520"/>
+            <a:ext cx="822960" cy="822960"/>
+          </a:xfrm>
+          <a:prstGeom prst="ellipse">
+            <a:avLst/>
           </a:prstGeom>
           <a:solidFill>
-            <a:schemeClr val="bg1"/>
+            <a:schemeClr val="tx2">
+              <a:alpha val="5000"/>
+            </a:schemeClr>
           </a:solidFill>
+          <a:ln/>
+        </p:spPr>
+      </p:sp>
+      <p:sp>
+        <p:nvSpPr>
+          <p:cNvPr id="4" name="indic-0-rule"/>
+          <p:cNvSpPr/>
+          <p:nvPr/>
+        </p:nvSpPr>
+        <p:spPr>
+          <a:xfrm>
+            <a:off x="457200" y="3931920"/>
+            <a:ext cx="2560320" cy="0"/>
+          </a:xfrm>
+          <a:prstGeom prst="line">
+            <a:avLst/>
+          </a:prstGeom>
+          <a:noFill/>
           <a:ln w="12700">
             <a:solidFill>
-              <a:srgbClr val="D9D9D9"/>
+              <a:srgbClr val="BFBFBF"/>
             </a:solidFill>
             <a:prstDash val="solid"/>
           </a:ln>
-        </p:spPr>
-      </p:sp>
-      <p:sp>
-        <p:nvSpPr>
-          <p:cNvPr id="4" name="indic-0-circle"/>
-          <p:cNvSpPr/>
-          <p:nvPr/>
-        </p:nvSpPr>
-        <p:spPr>
-          <a:xfrm>
-            <a:off x="640080" y="1143000"/>
-            <a:ext cx="502920" cy="502920"/>
-          </a:xfrm>
-          <a:prstGeom prst="ellipse">
-            <a:avLst/>
-          </a:prstGeom>
-          <a:solidFill>
-            <a:schemeClr val="bg2"/>
-          </a:solidFill>
-          <a:ln/>
         </p:spPr>
       </p:sp>
       <p:pic>
@@ -2234,8 +2265,8 @@
         </p:blipFill>
         <p:spPr>
           <a:xfrm>
-            <a:off x="760781" y="1263701"/>
-            <a:ext cx="261518" cy="261518"/>
+            <a:off x="457200" y="1051560"/>
+            <a:ext cx="384048" cy="384048"/>
           </a:xfrm>
           <a:prstGeom prst="rect">
             <a:avLst/>
@@ -2250,8 +2281,8 @@
         </p:nvSpPr>
         <p:spPr>
           <a:xfrm>
-            <a:off x="1234440" y="1143000"/>
-            <a:ext cx="1691640" cy="502920"/>
+            <a:off x="960120" y="1005840"/>
+            <a:ext cx="2057400" cy="475488"/>
           </a:xfrm>
           <a:prstGeom prst="rect">
             <a:avLst/>
@@ -2286,8 +2317,8 @@
         </p:nvSpPr>
         <p:spPr>
           <a:xfrm>
-            <a:off x="640080" y="1783080"/>
-            <a:ext cx="2240280" cy="2057400"/>
+            <a:off x="457200" y="1645920"/>
+            <a:ext cx="2560320" cy="2194560"/>
           </a:xfrm>
           <a:prstGeom prst="rect">
             <a:avLst/>
@@ -2392,49 +2423,47 @@
       </p:sp>
       <p:sp>
         <p:nvSpPr>
-          <p:cNvPr id="8" name="indic-card-1"/>
+          <p:cNvPr id="8" name="indic-1-decor"/>
           <p:cNvSpPr/>
           <p:nvPr/>
         </p:nvSpPr>
         <p:spPr>
           <a:xfrm>
-            <a:off x="3291840" y="1005840"/>
-            <a:ext cx="2560320" cy="2926080"/>
-          </a:xfrm>
-          <a:prstGeom prst="roundRect">
-            <a:avLst>
-              <a:gd name="adj" fmla="val 3571"/>
-            </a:avLst>
+            <a:off x="4983480" y="3017520"/>
+            <a:ext cx="822960" cy="822960"/>
+          </a:xfrm>
+          <a:prstGeom prst="triangle">
+            <a:avLst/>
           </a:prstGeom>
           <a:solidFill>
-            <a:schemeClr val="bg1"/>
+            <a:schemeClr val="tx2">
+              <a:alpha val="5000"/>
+            </a:schemeClr>
           </a:solidFill>
+          <a:ln/>
+        </p:spPr>
+      </p:sp>
+      <p:sp>
+        <p:nvSpPr>
+          <p:cNvPr id="9" name="indic-1-rule"/>
+          <p:cNvSpPr/>
+          <p:nvPr/>
+        </p:nvSpPr>
+        <p:spPr>
+          <a:xfrm>
+            <a:off x="3291840" y="3931920"/>
+            <a:ext cx="2560320" cy="0"/>
+          </a:xfrm>
+          <a:prstGeom prst="line">
+            <a:avLst/>
+          </a:prstGeom>
+          <a:noFill/>
           <a:ln w="12700">
             <a:solidFill>
-              <a:srgbClr val="D9D9D9"/>
+              <a:srgbClr val="BFBFBF"/>
             </a:solidFill>
             <a:prstDash val="solid"/>
           </a:ln>
-        </p:spPr>
-      </p:sp>
-      <p:sp>
-        <p:nvSpPr>
-          <p:cNvPr id="9" name="indic-1-circle"/>
-          <p:cNvSpPr/>
-          <p:nvPr/>
-        </p:nvSpPr>
-        <p:spPr>
-          <a:xfrm>
-            <a:off x="3474720" y="1143000"/>
-            <a:ext cx="502920" cy="502920"/>
-          </a:xfrm>
-          <a:prstGeom prst="ellipse">
-            <a:avLst/>
-          </a:prstGeom>
-          <a:solidFill>
-            <a:schemeClr val="accent4"/>
-          </a:solidFill>
-          <a:ln/>
         </p:spPr>
       </p:sp>
       <p:pic>
@@ -2453,8 +2482,8 @@
         </p:blipFill>
         <p:spPr>
           <a:xfrm>
-            <a:off x="3595421" y="1263701"/>
-            <a:ext cx="261518" cy="261518"/>
+            <a:off x="3291840" y="1051560"/>
+            <a:ext cx="384048" cy="384048"/>
           </a:xfrm>
           <a:prstGeom prst="rect">
             <a:avLst/>
@@ -2469,8 +2498,8 @@
         </p:nvSpPr>
         <p:spPr>
           <a:xfrm>
-            <a:off x="4069080" y="1143000"/>
-            <a:ext cx="1691640" cy="502920"/>
+            <a:off x="3794760" y="1005840"/>
+            <a:ext cx="2057400" cy="475488"/>
           </a:xfrm>
           <a:prstGeom prst="rect">
             <a:avLst/>
@@ -2505,8 +2534,8 @@
         </p:nvSpPr>
         <p:spPr>
           <a:xfrm>
-            <a:off x="3474720" y="1783080"/>
-            <a:ext cx="2240280" cy="2057400"/>
+            <a:off x="3291840" y="1645920"/>
+            <a:ext cx="2560320" cy="2194560"/>
           </a:xfrm>
           <a:prstGeom prst="rect">
             <a:avLst/>
@@ -2611,49 +2640,47 @@
       </p:sp>
       <p:sp>
         <p:nvSpPr>
-          <p:cNvPr id="13" name="indic-card-2"/>
+          <p:cNvPr id="13" name="indic-2-decor"/>
           <p:cNvSpPr/>
           <p:nvPr/>
         </p:nvSpPr>
         <p:spPr>
           <a:xfrm>
-            <a:off x="6126480" y="1005840"/>
-            <a:ext cx="2560320" cy="2926080"/>
-          </a:xfrm>
-          <a:prstGeom prst="roundRect">
-            <a:avLst>
-              <a:gd name="adj" fmla="val 3571"/>
-            </a:avLst>
+            <a:off x="7818120" y="3017520"/>
+            <a:ext cx="822960" cy="822960"/>
+          </a:xfrm>
+          <a:prstGeom prst="rect">
+            <a:avLst/>
           </a:prstGeom>
           <a:solidFill>
-            <a:schemeClr val="bg1"/>
+            <a:schemeClr val="tx2">
+              <a:alpha val="5000"/>
+            </a:schemeClr>
           </a:solidFill>
+          <a:ln/>
+        </p:spPr>
+      </p:sp>
+      <p:sp>
+        <p:nvSpPr>
+          <p:cNvPr id="14" name="indic-2-rule"/>
+          <p:cNvSpPr/>
+          <p:nvPr/>
+        </p:nvSpPr>
+        <p:spPr>
+          <a:xfrm>
+            <a:off x="6126480" y="3931920"/>
+            <a:ext cx="2560320" cy="0"/>
+          </a:xfrm>
+          <a:prstGeom prst="line">
+            <a:avLst/>
+          </a:prstGeom>
+          <a:noFill/>
           <a:ln w="12700">
             <a:solidFill>
-              <a:srgbClr val="D9D9D9"/>
+              <a:srgbClr val="BFBFBF"/>
             </a:solidFill>
             <a:prstDash val="solid"/>
           </a:ln>
-        </p:spPr>
-      </p:sp>
-      <p:sp>
-        <p:nvSpPr>
-          <p:cNvPr id="14" name="indic-2-circle"/>
-          <p:cNvSpPr/>
-          <p:nvPr/>
-        </p:nvSpPr>
-        <p:spPr>
-          <a:xfrm>
-            <a:off x="6309360" y="1143000"/>
-            <a:ext cx="502920" cy="502920"/>
-          </a:xfrm>
-          <a:prstGeom prst="ellipse">
-            <a:avLst/>
-          </a:prstGeom>
-          <a:solidFill>
-            <a:schemeClr val="accent6"/>
-          </a:solidFill>
-          <a:ln/>
         </p:spPr>
       </p:sp>
       <p:pic>
@@ -2672,8 +2699,8 @@
         </p:blipFill>
         <p:spPr>
           <a:xfrm>
-            <a:off x="6430061" y="1263701"/>
-            <a:ext cx="261518" cy="261518"/>
+            <a:off x="6126480" y="1051560"/>
+            <a:ext cx="384048" cy="384048"/>
           </a:xfrm>
           <a:prstGeom prst="rect">
             <a:avLst/>
@@ -2688,8 +2715,8 @@
         </p:nvSpPr>
         <p:spPr>
           <a:xfrm>
-            <a:off x="6903720" y="1143000"/>
-            <a:ext cx="1691640" cy="502920"/>
+            <a:off x="6629400" y="1005840"/>
+            <a:ext cx="2057400" cy="475488"/>
           </a:xfrm>
           <a:prstGeom prst="rect">
             <a:avLst/>
@@ -2724,8 +2751,8 @@
         </p:nvSpPr>
         <p:spPr>
           <a:xfrm>
-            <a:off x="6309360" y="1783080"/>
-            <a:ext cx="2240280" cy="2057400"/>
+            <a:off x="6126480" y="1645920"/>
+            <a:ext cx="2560320" cy="2194560"/>
           </a:xfrm>
           <a:prstGeom prst="rect">
             <a:avLst/>
@@ -2810,51 +2837,9 @@
           </a:p>
         </p:txBody>
       </p:sp>
-      <p:sp>
-        <p:nvSpPr>
-          <p:cNvPr id="18" name="indic-callout"/>
-          <p:cNvSpPr/>
-          <p:nvPr/>
-        </p:nvSpPr>
-        <p:spPr>
-          <a:xfrm>
-            <a:off x="457200" y="4114800"/>
-            <a:ext cx="8229600" cy="548640"/>
-          </a:xfrm>
-          <a:prstGeom prst="roundRect">
-            <a:avLst>
-              <a:gd name="adj" fmla="val 13333"/>
-            </a:avLst>
-          </a:prstGeom>
-          <a:solidFill>
-            <a:schemeClr val="bg2"/>
-          </a:solidFill>
-          <a:ln/>
-        </p:spPr>
-      </p:sp>
-      <p:sp>
-        <p:nvSpPr>
-          <p:cNvPr id="19" name="indic-callout-circle"/>
-          <p:cNvSpPr/>
-          <p:nvPr/>
-        </p:nvSpPr>
-        <p:spPr>
-          <a:xfrm>
-            <a:off x="594360" y="4187952"/>
-            <a:ext cx="402336" cy="402336"/>
-          </a:xfrm>
-          <a:prstGeom prst="ellipse">
-            <a:avLst/>
-          </a:prstGeom>
-          <a:solidFill>
-            <a:schemeClr val="accent1"/>
-          </a:solidFill>
-          <a:ln/>
-        </p:spPr>
-      </p:sp>
       <p:pic>
         <p:nvPicPr>
-          <p:cNvPr id="20" name="indic-callout-icon" descr="preencoded.png">    </p:cNvPr>
+          <p:cNvPr id="18" name="indic-callout-icon" descr="preencoded.png">    </p:cNvPr>
           <p:cNvPicPr>
             <a:picLocks noChangeAspect="1"/>
           </p:cNvPicPr>
@@ -2868,8 +2853,8 @@
         </p:blipFill>
         <p:spPr>
           <a:xfrm>
-            <a:off x="690921" y="4284513"/>
-            <a:ext cx="209215" cy="209215"/>
+            <a:off x="457200" y="4133088"/>
+            <a:ext cx="384048" cy="384048"/>
           </a:xfrm>
           <a:prstGeom prst="rect">
             <a:avLst/>
@@ -2878,14 +2863,14 @@
       </p:pic>
       <p:sp>
         <p:nvSpPr>
-          <p:cNvPr id="21" name="Text 15"/>
-          <p:cNvSpPr txBox="1"/>
-          <p:nvPr/>
-        </p:nvSpPr>
-        <p:spPr>
-          <a:xfrm>
-            <a:off x="1143000" y="4114800"/>
-            <a:ext cx="7406640" cy="548640"/>
+          <p:cNvPr id="19" name="Text 13"/>
+          <p:cNvSpPr txBox="1"/>
+          <p:nvPr/>
+        </p:nvSpPr>
+        <p:spPr>
+          <a:xfrm>
+            <a:off x="960120" y="4069080"/>
+            <a:ext cx="7726680" cy="512064"/>
           </a:xfrm>
           <a:prstGeom prst="rect">
             <a:avLst/>
@@ -2914,14 +2899,14 @@
       </p:sp>
       <p:sp>
         <p:nvSpPr>
-          <p:cNvPr id="22" name="source"/>
-          <p:cNvSpPr txBox="1"/>
-          <p:nvPr/>
-        </p:nvSpPr>
-        <p:spPr>
-          <a:xfrm>
-            <a:off x="457200" y="4773168"/>
-            <a:ext cx="7680960" cy="228600"/>
+          <p:cNvPr id="20" name="source"/>
+          <p:cNvSpPr txBox="1"/>
+          <p:nvPr/>
+        </p:nvSpPr>
+        <p:spPr>
+          <a:xfrm>
+            <a:off x="457200" y="4727448"/>
+            <a:ext cx="7680960" cy="274320"/>
           </a:xfrm>
           <a:prstGeom prst="rect">
             <a:avLst/>
@@ -2937,14 +2922,14 @@
               <a:buNone/>
             </a:pPr>
             <a:r>
-              <a:rPr lang="en-US" sz="900" dirty="0">
+              <a:rPr lang="en-US" sz="1300" dirty="0">
                 <a:solidFill>
                   <a:schemeClr val="accent5"/>
                 </a:solidFill>
               </a:rPr>
               <a:t>参考：産婦人科診療ガイドライン 産科編2023／病気がみえる vol.10 産科</a:t>
             </a:r>
-            <a:endParaRPr lang="en-US" sz="900" dirty="0"/>
+            <a:endParaRPr lang="en-US" sz="1300" dirty="0"/>
           </a:p>
         </p:txBody>
       </p:sp>
@@ -2960,8 +2945,8 @@
         </p:nvSpPr>
         <p:spPr>
           <a:xfrm>
-            <a:off x="8321040" y="4773168"/>
-            <a:ext cx="365760" cy="228600"/>
+            <a:off x="8229600" y="4727448"/>
+            <a:ext cx="457200" cy="274320"/>
           </a:xfrm>
           <a:prstGeom prst="rect">
             <a:avLst/>
@@ -2976,7 +2961,7 @@
           <a:bodyPr/>
           <a:lstStyle>
             <a:lvl1pPr>
-              <a:defRPr sz="900">
+              <a:defRPr sz="1300">
                 <a:solidFill>
                   <a:schemeClr val="accent5"/>
                 </a:solidFill>
@@ -3073,7 +3058,7 @@
           <a:noFill/>
           <a:ln w="25400">
             <a:solidFill>
-              <a:srgbClr val="D9D9D9"/>
+              <a:srgbClr val="BFBFBF"/>
             </a:solidFill>
             <a:prstDash val="solid"/>
           </a:ln>
@@ -3094,7 +3079,7 @@
             <a:avLst/>
           </a:prstGeom>
           <a:solidFill>
-            <a:schemeClr val="bg2"/>
+            <a:schemeClr val="tx2"/>
           </a:solidFill>
           <a:ln/>
         </p:spPr>
@@ -3126,7 +3111,7 @@
             <a:r>
               <a:rPr lang="en-US" sz="1800" b="1" dirty="0">
                 <a:solidFill>
-                  <a:schemeClr val="tx2"/>
+                  <a:schemeClr val="bg1"/>
                 </a:solidFill>
               </a:rPr>
               <a:t>1</a:t>
@@ -3222,7 +3207,7 @@
             <a:avLst/>
           </a:prstGeom>
           <a:solidFill>
-            <a:schemeClr val="bg2"/>
+            <a:schemeClr val="tx2"/>
           </a:solidFill>
           <a:ln/>
         </p:spPr>
@@ -3254,7 +3239,7 @@
             <a:r>
               <a:rPr lang="en-US" sz="1800" b="1" dirty="0">
                 <a:solidFill>
-                  <a:schemeClr val="tx2"/>
+                  <a:schemeClr val="bg1"/>
                 </a:solidFill>
               </a:rPr>
               <a:t>2</a:t>
@@ -3350,7 +3335,7 @@
             <a:avLst/>
           </a:prstGeom>
           <a:solidFill>
-            <a:schemeClr val="bg2"/>
+            <a:schemeClr val="tx2"/>
           </a:solidFill>
           <a:ln/>
         </p:spPr>
@@ -3382,7 +3367,7 @@
             <a:r>
               <a:rPr lang="en-US" sz="1800" b="1" dirty="0">
                 <a:solidFill>
-                  <a:schemeClr val="tx2"/>
+                  <a:schemeClr val="bg1"/>
                 </a:solidFill>
               </a:rPr>
               <a:t>3</a:t>
@@ -3478,7 +3463,7 @@
             <a:avLst/>
           </a:prstGeom>
           <a:solidFill>
-            <a:schemeClr val="accent1"/>
+            <a:schemeClr val="accent3"/>
           </a:solidFill>
           <a:ln/>
         </p:spPr>
@@ -3606,7 +3591,7 @@
             <a:avLst/>
           </a:prstGeom>
           <a:solidFill>
-            <a:schemeClr val="bg2"/>
+            <a:schemeClr val="tx2"/>
           </a:solidFill>
           <a:ln/>
         </p:spPr>
@@ -3638,7 +3623,7 @@
             <a:r>
               <a:rPr lang="en-US" sz="1800" b="1" dirty="0">
                 <a:solidFill>
-                  <a:schemeClr val="tx2"/>
+                  <a:schemeClr val="bg1"/>
                 </a:solidFill>
               </a:rPr>
               <a:t>5</a:t>
@@ -3734,7 +3719,7 @@
             <a:avLst/>
           </a:prstGeom>
           <a:solidFill>
-            <a:schemeClr val="bg2"/>
+            <a:schemeClr val="tx2"/>
           </a:solidFill>
           <a:ln/>
         </p:spPr>
@@ -3766,7 +3751,7 @@
             <a:r>
               <a:rPr lang="en-US" sz="1800" b="1" dirty="0">
                 <a:solidFill>
-                  <a:schemeClr val="tx2"/>
+                  <a:schemeClr val="bg1"/>
                 </a:solidFill>
               </a:rPr>
               <a:t>6</a:t>
@@ -3849,44 +3834,47 @@
       </p:sp>
       <p:sp>
         <p:nvSpPr>
-          <p:cNvPr id="28" name="flow-box-0"/>
+          <p:cNvPr id="28" name="flow-box-0-decor"/>
           <p:cNvSpPr/>
           <p:nvPr/>
         </p:nvSpPr>
         <p:spPr>
           <a:xfrm>
-            <a:off x="457200" y="2743200"/>
-            <a:ext cx="3977640" cy="1920240"/>
-          </a:xfrm>
-          <a:prstGeom prst="roundRect">
-            <a:avLst>
-              <a:gd name="adj" fmla="val 4762"/>
-            </a:avLst>
+            <a:off x="3566160" y="3611880"/>
+            <a:ext cx="822960" cy="822960"/>
+          </a:xfrm>
+          <a:prstGeom prst="ellipse">
+            <a:avLst/>
           </a:prstGeom>
           <a:solidFill>
-            <a:schemeClr val="accent6"/>
+            <a:schemeClr val="tx2">
+              <a:alpha val="5000"/>
+            </a:schemeClr>
           </a:solidFill>
           <a:ln/>
         </p:spPr>
       </p:sp>
       <p:sp>
         <p:nvSpPr>
-          <p:cNvPr id="29" name="flow-box-0-circle"/>
+          <p:cNvPr id="29" name="flow-box-0-rule"/>
           <p:cNvSpPr/>
           <p:nvPr/>
         </p:nvSpPr>
         <p:spPr>
           <a:xfrm>
-            <a:off x="640080" y="2880360"/>
-            <a:ext cx="411480" cy="411480"/>
-          </a:xfrm>
-          <a:prstGeom prst="ellipse">
-            <a:avLst/>
-          </a:prstGeom>
-          <a:solidFill>
-            <a:schemeClr val="bg1"/>
-          </a:solidFill>
-          <a:ln/>
+            <a:off x="457200" y="4526280"/>
+            <a:ext cx="3977640" cy="0"/>
+          </a:xfrm>
+          <a:prstGeom prst="line">
+            <a:avLst/>
+          </a:prstGeom>
+          <a:noFill/>
+          <a:ln w="12700">
+            <a:solidFill>
+              <a:srgbClr val="BFBFBF"/>
+            </a:solidFill>
+            <a:prstDash val="solid"/>
+          </a:ln>
         </p:spPr>
       </p:sp>
       <p:pic>
@@ -3905,8 +3893,8 @@
         </p:blipFill>
         <p:spPr>
           <a:xfrm>
-            <a:off x="738835" y="2979115"/>
-            <a:ext cx="213970" cy="213970"/>
+            <a:off x="457200" y="2743200"/>
+            <a:ext cx="365760" cy="365760"/>
           </a:xfrm>
           <a:prstGeom prst="rect">
             <a:avLst/>
@@ -3921,8 +3909,8 @@
         </p:nvSpPr>
         <p:spPr>
           <a:xfrm>
-            <a:off x="1188720" y="2880360"/>
-            <a:ext cx="3017520" cy="411480"/>
+            <a:off x="960120" y="2715768"/>
+            <a:ext cx="3383280" cy="420624"/>
           </a:xfrm>
           <a:prstGeom prst="rect">
             <a:avLst/>
@@ -3957,8 +3945,8 @@
         </p:nvSpPr>
         <p:spPr>
           <a:xfrm>
-            <a:off x="685800" y="3401568"/>
-            <a:ext cx="3566160" cy="1188720"/>
+            <a:off x="457200" y="3246120"/>
+            <a:ext cx="3840480" cy="1188720"/>
           </a:xfrm>
           <a:prstGeom prst="rect">
             <a:avLst/>
@@ -4032,44 +4020,47 @@
       </p:sp>
       <p:sp>
         <p:nvSpPr>
-          <p:cNvPr id="33" name="flow-box-1"/>
+          <p:cNvPr id="33" name="flow-box-1-decor"/>
           <p:cNvSpPr/>
           <p:nvPr/>
         </p:nvSpPr>
         <p:spPr>
           <a:xfrm>
-            <a:off x="4709160" y="2743200"/>
-            <a:ext cx="3977640" cy="1920240"/>
-          </a:xfrm>
-          <a:prstGeom prst="roundRect">
-            <a:avLst>
-              <a:gd name="adj" fmla="val 4762"/>
-            </a:avLst>
+            <a:off x="7818120" y="3611880"/>
+            <a:ext cx="822960" cy="822960"/>
+          </a:xfrm>
+          <a:prstGeom prst="triangle">
+            <a:avLst/>
           </a:prstGeom>
           <a:solidFill>
-            <a:schemeClr val="accent6"/>
+            <a:schemeClr val="tx2">
+              <a:alpha val="5000"/>
+            </a:schemeClr>
           </a:solidFill>
           <a:ln/>
         </p:spPr>
       </p:sp>
       <p:sp>
         <p:nvSpPr>
-          <p:cNvPr id="34" name="flow-box-1-circle"/>
+          <p:cNvPr id="34" name="flow-box-1-rule"/>
           <p:cNvSpPr/>
           <p:nvPr/>
         </p:nvSpPr>
         <p:spPr>
           <a:xfrm>
-            <a:off x="4892040" y="2880360"/>
-            <a:ext cx="411480" cy="411480"/>
-          </a:xfrm>
-          <a:prstGeom prst="ellipse">
-            <a:avLst/>
-          </a:prstGeom>
-          <a:solidFill>
-            <a:schemeClr val="bg1"/>
-          </a:solidFill>
-          <a:ln/>
+            <a:off x="4709160" y="4526280"/>
+            <a:ext cx="3977640" cy="0"/>
+          </a:xfrm>
+          <a:prstGeom prst="line">
+            <a:avLst/>
+          </a:prstGeom>
+          <a:noFill/>
+          <a:ln w="12700">
+            <a:solidFill>
+              <a:srgbClr val="BFBFBF"/>
+            </a:solidFill>
+            <a:prstDash val="solid"/>
+          </a:ln>
         </p:spPr>
       </p:sp>
       <p:pic>
@@ -4088,8 +4079,8 @@
         </p:blipFill>
         <p:spPr>
           <a:xfrm>
-            <a:off x="4990795" y="2979115"/>
-            <a:ext cx="213970" cy="213970"/>
+            <a:off x="4709160" y="2743200"/>
+            <a:ext cx="365760" cy="365760"/>
           </a:xfrm>
           <a:prstGeom prst="rect">
             <a:avLst/>
@@ -4104,8 +4095,8 @@
         </p:nvSpPr>
         <p:spPr>
           <a:xfrm>
-            <a:off x="5440680" y="2880360"/>
-            <a:ext cx="3017520" cy="411480"/>
+            <a:off x="5212080" y="2715768"/>
+            <a:ext cx="3383280" cy="420624"/>
           </a:xfrm>
           <a:prstGeom prst="rect">
             <a:avLst/>
@@ -4140,8 +4131,8 @@
         </p:nvSpPr>
         <p:spPr>
           <a:xfrm>
-            <a:off x="4937760" y="3401568"/>
-            <a:ext cx="3566160" cy="1188720"/>
+            <a:off x="4709160" y="3246120"/>
+            <a:ext cx="3840480" cy="1188720"/>
           </a:xfrm>
           <a:prstGeom prst="rect">
             <a:avLst/>
@@ -4221,8 +4212,8 @@
         </p:nvSpPr>
         <p:spPr>
           <a:xfrm>
-            <a:off x="457200" y="4773168"/>
-            <a:ext cx="7680960" cy="228600"/>
+            <a:off x="457200" y="4727448"/>
+            <a:ext cx="7680960" cy="274320"/>
           </a:xfrm>
           <a:prstGeom prst="rect">
             <a:avLst/>
@@ -4238,14 +4229,14 @@
               <a:buNone/>
             </a:pPr>
             <a:r>
-              <a:rPr lang="en-US" sz="900" dirty="0">
+              <a:rPr lang="en-US" sz="1300" dirty="0">
                 <a:solidFill>
                   <a:schemeClr val="accent5"/>
                 </a:solidFill>
               </a:rPr>
               <a:t>参考：病気がみえる vol.10 産科／産婦人科診療ガイドライン 産科編2023</a:t>
             </a:r>
-            <a:endParaRPr lang="en-US" sz="900" dirty="0"/>
+            <a:endParaRPr lang="en-US" sz="1300" dirty="0"/>
           </a:p>
         </p:txBody>
       </p:sp>
@@ -4261,8 +4252,8 @@
         </p:nvSpPr>
         <p:spPr>
           <a:xfrm>
-            <a:off x="8321040" y="4773168"/>
-            <a:ext cx="365760" cy="228600"/>
+            <a:off x="8229600" y="4727448"/>
+            <a:ext cx="457200" cy="274320"/>
           </a:xfrm>
           <a:prstGeom prst="rect">
             <a:avLst/>
@@ -4277,7 +4268,7 @@
           <a:bodyPr/>
           <a:lstStyle>
             <a:lvl1pPr>
-              <a:defRPr sz="900">
+              <a:defRPr sz="1300">
                 <a:solidFill>
                   <a:schemeClr val="accent5"/>
                 </a:solidFill>
@@ -4393,29 +4384,9 @@
           </a:p>
         </p:txBody>
       </p:sp>
-      <p:sp>
-        <p:nvSpPr>
-          <p:cNvPr id="4" name="comp-0-circle"/>
-          <p:cNvSpPr/>
-          <p:nvPr/>
-        </p:nvSpPr>
-        <p:spPr>
-          <a:xfrm>
-            <a:off x="457200" y="1417320"/>
-            <a:ext cx="457200" cy="457200"/>
-          </a:xfrm>
-          <a:prstGeom prst="ellipse">
-            <a:avLst/>
-          </a:prstGeom>
-          <a:solidFill>
-            <a:schemeClr val="bg2"/>
-          </a:solidFill>
-          <a:ln/>
-        </p:spPr>
-      </p:sp>
       <p:pic>
         <p:nvPicPr>
-          <p:cNvPr id="5" name="comp-0-icon" descr="preencoded.png">    </p:cNvPr>
+          <p:cNvPr id="4" name="comp-0-icon" descr="preencoded.png">    </p:cNvPr>
           <p:cNvPicPr>
             <a:picLocks noChangeAspect="1"/>
           </p:cNvPicPr>
@@ -4429,8 +4400,8 @@
         </p:blipFill>
         <p:spPr>
           <a:xfrm>
-            <a:off x="566928" y="1527048"/>
-            <a:ext cx="237744" cy="237744"/>
+            <a:off x="502920" y="1435608"/>
+            <a:ext cx="365760" cy="365760"/>
           </a:xfrm>
           <a:prstGeom prst="rect">
             <a:avLst/>
@@ -4439,7 +4410,7 @@
       </p:pic>
       <p:sp>
         <p:nvSpPr>
-          <p:cNvPr id="6" name="Text 3"/>
+          <p:cNvPr id="5" name="Text 2"/>
           <p:cNvSpPr txBox="1"/>
           <p:nvPr/>
         </p:nvSpPr>
@@ -4475,7 +4446,7 @@
       </p:sp>
       <p:sp>
         <p:nvSpPr>
-          <p:cNvPr id="7" name="Text 4"/>
+          <p:cNvPr id="6" name="Text 3"/>
           <p:cNvSpPr txBox="1"/>
           <p:nvPr/>
         </p:nvSpPr>
@@ -4509,29 +4480,9 @@
           </a:p>
         </p:txBody>
       </p:sp>
-      <p:sp>
-        <p:nvSpPr>
-          <p:cNvPr id="8" name="comp-1-circle"/>
-          <p:cNvSpPr/>
-          <p:nvPr/>
-        </p:nvSpPr>
-        <p:spPr>
-          <a:xfrm>
-            <a:off x="457200" y="2240280"/>
-            <a:ext cx="457200" cy="457200"/>
-          </a:xfrm>
-          <a:prstGeom prst="ellipse">
-            <a:avLst/>
-          </a:prstGeom>
-          <a:solidFill>
-            <a:schemeClr val="bg2"/>
-          </a:solidFill>
-          <a:ln/>
-        </p:spPr>
-      </p:sp>
       <p:pic>
         <p:nvPicPr>
-          <p:cNvPr id="9" name="comp-1-icon" descr="preencoded.png">    </p:cNvPr>
+          <p:cNvPr id="7" name="comp-1-icon" descr="preencoded.png">    </p:cNvPr>
           <p:cNvPicPr>
             <a:picLocks noChangeAspect="1"/>
           </p:cNvPicPr>
@@ -4545,8 +4496,8 @@
         </p:blipFill>
         <p:spPr>
           <a:xfrm>
-            <a:off x="566928" y="2350008"/>
-            <a:ext cx="237744" cy="237744"/>
+            <a:off x="502920" y="2258568"/>
+            <a:ext cx="365760" cy="365760"/>
           </a:xfrm>
           <a:prstGeom prst="rect">
             <a:avLst/>
@@ -4555,7 +4506,7 @@
       </p:pic>
       <p:sp>
         <p:nvSpPr>
-          <p:cNvPr id="10" name="Text 6"/>
+          <p:cNvPr id="8" name="Text 4"/>
           <p:cNvSpPr txBox="1"/>
           <p:nvPr/>
         </p:nvSpPr>
@@ -4591,7 +4542,7 @@
       </p:sp>
       <p:sp>
         <p:nvSpPr>
-          <p:cNvPr id="11" name="Text 7"/>
+          <p:cNvPr id="9" name="Text 5"/>
           <p:cNvSpPr txBox="1"/>
           <p:nvPr/>
         </p:nvSpPr>
@@ -4625,29 +4576,9 @@
           </a:p>
         </p:txBody>
       </p:sp>
-      <p:sp>
-        <p:nvSpPr>
-          <p:cNvPr id="12" name="comp-2-circle"/>
-          <p:cNvSpPr/>
-          <p:nvPr/>
-        </p:nvSpPr>
-        <p:spPr>
-          <a:xfrm>
-            <a:off x="457200" y="3063240"/>
-            <a:ext cx="457200" cy="457200"/>
-          </a:xfrm>
-          <a:prstGeom prst="ellipse">
-            <a:avLst/>
-          </a:prstGeom>
-          <a:solidFill>
-            <a:schemeClr val="bg2"/>
-          </a:solidFill>
-          <a:ln/>
-        </p:spPr>
-      </p:sp>
       <p:pic>
         <p:nvPicPr>
-          <p:cNvPr id="13" name="comp-2-icon" descr="preencoded.png">    </p:cNvPr>
+          <p:cNvPr id="10" name="comp-2-icon" descr="preencoded.png">    </p:cNvPr>
           <p:cNvPicPr>
             <a:picLocks noChangeAspect="1"/>
           </p:cNvPicPr>
@@ -4661,8 +4592,8 @@
         </p:blipFill>
         <p:spPr>
           <a:xfrm>
-            <a:off x="566928" y="3172968"/>
-            <a:ext cx="237744" cy="237744"/>
+            <a:off x="502920" y="3081528"/>
+            <a:ext cx="365760" cy="365760"/>
           </a:xfrm>
           <a:prstGeom prst="rect">
             <a:avLst/>
@@ -4671,7 +4602,7 @@
       </p:pic>
       <p:sp>
         <p:nvSpPr>
-          <p:cNvPr id="14" name="Text 9"/>
+          <p:cNvPr id="11" name="Text 6"/>
           <p:cNvSpPr txBox="1"/>
           <p:nvPr/>
         </p:nvSpPr>
@@ -4707,7 +4638,7 @@
       </p:sp>
       <p:sp>
         <p:nvSpPr>
-          <p:cNvPr id="15" name="Text 10"/>
+          <p:cNvPr id="12" name="Text 7"/>
           <p:cNvSpPr txBox="1"/>
           <p:nvPr/>
         </p:nvSpPr>
@@ -4741,29 +4672,9 @@
           </a:p>
         </p:txBody>
       </p:sp>
-      <p:sp>
-        <p:nvSpPr>
-          <p:cNvPr id="16" name="comp-3-circle"/>
-          <p:cNvSpPr/>
-          <p:nvPr/>
-        </p:nvSpPr>
-        <p:spPr>
-          <a:xfrm>
-            <a:off x="457200" y="3886200"/>
-            <a:ext cx="457200" cy="457200"/>
-          </a:xfrm>
-          <a:prstGeom prst="ellipse">
-            <a:avLst/>
-          </a:prstGeom>
-          <a:solidFill>
-            <a:schemeClr val="bg2"/>
-          </a:solidFill>
-          <a:ln/>
-        </p:spPr>
-      </p:sp>
       <p:pic>
         <p:nvPicPr>
-          <p:cNvPr id="17" name="comp-3-icon" descr="preencoded.png">    </p:cNvPr>
+          <p:cNvPr id="13" name="comp-3-icon" descr="preencoded.png">    </p:cNvPr>
           <p:cNvPicPr>
             <a:picLocks noChangeAspect="1"/>
           </p:cNvPicPr>
@@ -4777,8 +4688,8 @@
         </p:blipFill>
         <p:spPr>
           <a:xfrm>
-            <a:off x="566928" y="3995928"/>
-            <a:ext cx="237744" cy="237744"/>
+            <a:off x="502920" y="3904488"/>
+            <a:ext cx="365760" cy="365760"/>
           </a:xfrm>
           <a:prstGeom prst="rect">
             <a:avLst/>
@@ -4787,7 +4698,7 @@
       </p:pic>
       <p:sp>
         <p:nvSpPr>
-          <p:cNvPr id="18" name="Text 12"/>
+          <p:cNvPr id="14" name="Text 8"/>
           <p:cNvSpPr txBox="1"/>
           <p:nvPr/>
         </p:nvSpPr>
@@ -4823,7 +4734,7 @@
       </p:sp>
       <p:sp>
         <p:nvSpPr>
-          <p:cNvPr id="19" name="Text 13"/>
+          <p:cNvPr id="15" name="Text 9"/>
           <p:cNvSpPr txBox="1"/>
           <p:nvPr/>
         </p:nvSpPr>
@@ -4859,25 +4770,156 @@
       </p:sp>
       <p:sp>
         <p:nvSpPr>
-          <p:cNvPr id="20" name="next-card"/>
+          <p:cNvPr id="16" name="next-decor"/>
           <p:cNvSpPr/>
           <p:nvPr/>
         </p:nvSpPr>
         <p:spPr>
           <a:xfrm>
+            <a:off x="7818120" y="2468880"/>
+            <a:ext cx="822960" cy="822960"/>
+          </a:xfrm>
+          <a:prstGeom prst="ellipse">
+            <a:avLst/>
+          </a:prstGeom>
+          <a:solidFill>
+            <a:schemeClr val="tx2">
+              <a:alpha val="5000"/>
+            </a:schemeClr>
+          </a:solidFill>
+          <a:ln/>
+        </p:spPr>
+      </p:sp>
+      <p:sp>
+        <p:nvSpPr>
+          <p:cNvPr id="17" name="next-rule"/>
+          <p:cNvSpPr/>
+          <p:nvPr/>
+        </p:nvSpPr>
+        <p:spPr>
+          <a:xfrm>
+            <a:off x="5303520" y="3383280"/>
+            <a:ext cx="3383280" cy="0"/>
+          </a:xfrm>
+          <a:prstGeom prst="line">
+            <a:avLst/>
+          </a:prstGeom>
+          <a:noFill/>
+          <a:ln w="12700">
+            <a:solidFill>
+              <a:srgbClr val="BFBFBF"/>
+            </a:solidFill>
+            <a:prstDash val="solid"/>
+          </a:ln>
+        </p:spPr>
+      </p:sp>
+      <p:sp>
+        <p:nvSpPr>
+          <p:cNvPr id="18" name="Text 12"/>
+          <p:cNvSpPr txBox="1"/>
+          <p:nvPr/>
+        </p:nvSpPr>
+        <p:spPr>
+          <a:xfrm>
             <a:off x="5303520" y="1005840"/>
-            <a:ext cx="3383280" cy="2331720"/>
-          </a:xfrm>
-          <a:prstGeom prst="roundRect">
-            <a:avLst>
-              <a:gd name="adj" fmla="val 3922"/>
-            </a:avLst>
-          </a:prstGeom>
-          <a:solidFill>
-            <a:schemeClr val="bg2"/>
-          </a:solidFill>
-          <a:ln/>
-        </p:spPr>
+            <a:ext cx="3383280" cy="320040"/>
+          </a:xfrm>
+          <a:prstGeom prst="rect">
+            <a:avLst/>
+          </a:prstGeom>
+          <a:noFill/>
+          <a:ln/>
+        </p:spPr>
+        <p:txBody>
+          <a:bodyPr wrap="square" lIns="0" tIns="0" rIns="0" bIns="0" rtlCol="0" anchor="ctr"/>
+          <a:lstStyle/>
+          <a:p>
+            <a:pPr indent="0" marL="0">
+              <a:buNone/>
+            </a:pPr>
+            <a:r>
+              <a:rPr lang="en-US" sz="1600" b="1" dirty="0">
+                <a:solidFill>
+                  <a:schemeClr val="tx2"/>
+                </a:solidFill>
+              </a:rPr>
+              <a:t>次回の妊娠への影響</a:t>
+            </a:r>
+            <a:endParaRPr lang="en-US" sz="1600" dirty="0"/>
+          </a:p>
+        </p:txBody>
+      </p:sp>
+      <p:sp>
+        <p:nvSpPr>
+          <p:cNvPr id="19" name="stat"/>
+          <p:cNvSpPr txBox="1"/>
+          <p:nvPr/>
+        </p:nvSpPr>
+        <p:spPr>
+          <a:xfrm>
+            <a:off x="5303520" y="1371600"/>
+            <a:ext cx="3383280" cy="548640"/>
+          </a:xfrm>
+          <a:prstGeom prst="rect">
+            <a:avLst/>
+          </a:prstGeom>
+          <a:noFill/>
+          <a:ln/>
+        </p:spPr>
+        <p:txBody>
+          <a:bodyPr wrap="square" lIns="0" tIns="0" rIns="0" bIns="0" rtlCol="0" anchor="ctr"/>
+          <a:lstStyle/>
+          <a:p>
+            <a:pPr indent="0" marL="0">
+              <a:buNone/>
+            </a:pPr>
+            <a:r>
+              <a:rPr lang="en-US" sz="3200" b="1" dirty="0">
+                <a:solidFill>
+                  <a:schemeClr val="accent3"/>
+                </a:solidFill>
+              </a:rPr>
+              <a:t>約0.5〜1%</a:t>
+            </a:r>
+            <a:endParaRPr lang="en-US" sz="3200" dirty="0"/>
+          </a:p>
+        </p:txBody>
+      </p:sp>
+      <p:sp>
+        <p:nvSpPr>
+          <p:cNvPr id="20" name="Text 14"/>
+          <p:cNvSpPr txBox="1"/>
+          <p:nvPr/>
+        </p:nvSpPr>
+        <p:spPr>
+          <a:xfrm>
+            <a:off x="5303520" y="1920240"/>
+            <a:ext cx="3291840" cy="457200"/>
+          </a:xfrm>
+          <a:prstGeom prst="rect">
+            <a:avLst/>
+          </a:prstGeom>
+          <a:noFill/>
+          <a:ln/>
+        </p:spPr>
+        <p:txBody>
+          <a:bodyPr wrap="square" lIns="0" tIns="0" rIns="0" bIns="0" rtlCol="0" anchor="t"/>
+          <a:lstStyle/>
+          <a:p>
+            <a:pPr indent="0" marL="0">
+              <a:buNone/>
+            </a:pPr>
+            <a:r>
+              <a:rPr lang="en-US" sz="1300" dirty="0">
+                <a:solidFill>
+                  <a:schemeClr val="tx1"/>
+                </a:solidFill>
+              </a:rPr>
+              <a:t>帝王切開後に経腟分娩を試みた時（TOLAC）の子宮破裂</a:t>
+            </a:r>
+            <a:endParaRPr lang="en-US" sz="1300" dirty="0"/>
+          </a:p>
+        </p:txBody>
       </p:sp>
       <p:sp>
         <p:nvSpPr>
@@ -4887,116 +4929,8 @@
         </p:nvSpPr>
         <p:spPr>
           <a:xfrm>
-            <a:off x="5486400" y="1143000"/>
-            <a:ext cx="3017520" cy="320040"/>
-          </a:xfrm>
-          <a:prstGeom prst="rect">
-            <a:avLst/>
-          </a:prstGeom>
-          <a:noFill/>
-          <a:ln/>
-        </p:spPr>
-        <p:txBody>
-          <a:bodyPr wrap="square" lIns="0" tIns="0" rIns="0" bIns="0" rtlCol="0" anchor="ctr"/>
-          <a:lstStyle/>
-          <a:p>
-            <a:pPr indent="0" marL="0">
-              <a:buNone/>
-            </a:pPr>
-            <a:r>
-              <a:rPr lang="en-US" sz="1600" b="1" dirty="0">
-                <a:solidFill>
-                  <a:schemeClr val="tx2"/>
-                </a:solidFill>
-              </a:rPr>
-              <a:t>次回の妊娠への影響</a:t>
-            </a:r>
-            <a:endParaRPr lang="en-US" sz="1600" dirty="0"/>
-          </a:p>
-        </p:txBody>
-      </p:sp>
-      <p:sp>
-        <p:nvSpPr>
-          <p:cNvPr id="22" name="stat"/>
-          <p:cNvSpPr txBox="1"/>
-          <p:nvPr/>
-        </p:nvSpPr>
-        <p:spPr>
-          <a:xfrm>
-            <a:off x="5486400" y="1508760"/>
-            <a:ext cx="3017520" cy="548640"/>
-          </a:xfrm>
-          <a:prstGeom prst="rect">
-            <a:avLst/>
-          </a:prstGeom>
-          <a:noFill/>
-          <a:ln/>
-        </p:spPr>
-        <p:txBody>
-          <a:bodyPr wrap="square" lIns="0" tIns="0" rIns="0" bIns="0" rtlCol="0" anchor="ctr"/>
-          <a:lstStyle/>
-          <a:p>
-            <a:pPr indent="0" marL="0">
-              <a:buNone/>
-            </a:pPr>
-            <a:r>
-              <a:rPr lang="en-US" sz="3200" b="1" dirty="0">
-                <a:solidFill>
-                  <a:schemeClr val="accent3"/>
-                </a:solidFill>
-              </a:rPr>
-              <a:t>約0.5〜1%</a:t>
-            </a:r>
-            <a:endParaRPr lang="en-US" sz="3200" dirty="0"/>
-          </a:p>
-        </p:txBody>
-      </p:sp>
-      <p:sp>
-        <p:nvSpPr>
-          <p:cNvPr id="23" name="Text 17"/>
-          <p:cNvSpPr txBox="1"/>
-          <p:nvPr/>
-        </p:nvSpPr>
-        <p:spPr>
-          <a:xfrm>
-            <a:off x="5486400" y="2057400"/>
-            <a:ext cx="3017520" cy="411480"/>
-          </a:xfrm>
-          <a:prstGeom prst="rect">
-            <a:avLst/>
-          </a:prstGeom>
-          <a:noFill/>
-          <a:ln/>
-        </p:spPr>
-        <p:txBody>
-          <a:bodyPr wrap="square" lIns="0" tIns="0" rIns="0" bIns="0" rtlCol="0" anchor="t"/>
-          <a:lstStyle/>
-          <a:p>
-            <a:pPr indent="0" marL="0">
-              <a:buNone/>
-            </a:pPr>
-            <a:r>
-              <a:rPr lang="en-US" sz="1100" dirty="0">
-                <a:solidFill>
-                  <a:schemeClr val="tx1"/>
-                </a:solidFill>
-              </a:rPr>
-              <a:t>帝王切開後に経腟分娩を試みた時（TOLAC）の子宮破裂</a:t>
-            </a:r>
-            <a:endParaRPr lang="en-US" sz="1100" dirty="0"/>
-          </a:p>
-        </p:txBody>
-      </p:sp>
-      <p:sp>
-        <p:nvSpPr>
-          <p:cNvPr id="24" name="Text 18"/>
-          <p:cNvSpPr txBox="1"/>
-          <p:nvPr/>
-        </p:nvSpPr>
-        <p:spPr>
-          <a:xfrm>
-            <a:off x="5486400" y="2560320"/>
-            <a:ext cx="3017520" cy="685800"/>
+            <a:off x="5303520" y="2514600"/>
+            <a:ext cx="3291840" cy="731520"/>
           </a:xfrm>
           <a:prstGeom prst="rect">
             <a:avLst/>
@@ -5047,49 +4981,52 @@
       </p:sp>
       <p:sp>
         <p:nvSpPr>
-          <p:cNvPr id="25" name="neonate-card"/>
+          <p:cNvPr id="22" name="neonate-decor"/>
           <p:cNvSpPr/>
           <p:nvPr/>
         </p:nvSpPr>
         <p:spPr>
           <a:xfrm>
-            <a:off x="5303520" y="3520440"/>
-            <a:ext cx="3383280" cy="1097280"/>
-          </a:xfrm>
-          <a:prstGeom prst="roundRect">
-            <a:avLst>
-              <a:gd name="adj" fmla="val 8333"/>
-            </a:avLst>
+            <a:off x="7818120" y="3611880"/>
+            <a:ext cx="822960" cy="822960"/>
+          </a:xfrm>
+          <a:prstGeom prst="triangle">
+            <a:avLst/>
           </a:prstGeom>
           <a:solidFill>
-            <a:schemeClr val="accent4"/>
+            <a:schemeClr val="tx2">
+              <a:alpha val="5000"/>
+            </a:schemeClr>
           </a:solidFill>
           <a:ln/>
         </p:spPr>
       </p:sp>
       <p:sp>
         <p:nvSpPr>
-          <p:cNvPr id="26" name="neonate-circle"/>
+          <p:cNvPr id="23" name="neonate-rule"/>
           <p:cNvSpPr/>
           <p:nvPr/>
         </p:nvSpPr>
         <p:spPr>
           <a:xfrm>
-            <a:off x="5486400" y="3657600"/>
-            <a:ext cx="384048" cy="384048"/>
-          </a:xfrm>
-          <a:prstGeom prst="ellipse">
-            <a:avLst/>
-          </a:prstGeom>
-          <a:solidFill>
-            <a:schemeClr val="bg1"/>
-          </a:solidFill>
-          <a:ln/>
+            <a:off x="5303520" y="4526280"/>
+            <a:ext cx="3383280" cy="0"/>
+          </a:xfrm>
+          <a:prstGeom prst="line">
+            <a:avLst/>
+          </a:prstGeom>
+          <a:noFill/>
+          <a:ln w="12700">
+            <a:solidFill>
+              <a:srgbClr val="BFBFBF"/>
+            </a:solidFill>
+            <a:prstDash val="solid"/>
+          </a:ln>
         </p:spPr>
       </p:sp>
       <p:pic>
         <p:nvPicPr>
-          <p:cNvPr id="27" name="neonate-icon" descr="preencoded.png">    </p:cNvPr>
+          <p:cNvPr id="24" name="neonate-icon" descr="preencoded.png">    </p:cNvPr>
           <p:cNvPicPr>
             <a:picLocks noChangeAspect="1"/>
           </p:cNvPicPr>
@@ -5103,8 +5040,8 @@
         </p:blipFill>
         <p:spPr>
           <a:xfrm>
-            <a:off x="5578572" y="3749772"/>
-            <a:ext cx="199705" cy="199705"/>
+            <a:off x="5303520" y="3602736"/>
+            <a:ext cx="329184" cy="329184"/>
           </a:xfrm>
           <a:prstGeom prst="rect">
             <a:avLst/>
@@ -5113,14 +5050,14 @@
       </p:pic>
       <p:sp>
         <p:nvSpPr>
-          <p:cNvPr id="28" name="Text 21"/>
-          <p:cNvSpPr txBox="1"/>
-          <p:nvPr/>
-        </p:nvSpPr>
-        <p:spPr>
-          <a:xfrm>
-            <a:off x="5989320" y="3657600"/>
-            <a:ext cx="2606040" cy="384048"/>
+          <p:cNvPr id="25" name="Text 18"/>
+          <p:cNvSpPr txBox="1"/>
+          <p:nvPr/>
+        </p:nvSpPr>
+        <p:spPr>
+          <a:xfrm>
+            <a:off x="5760720" y="3566160"/>
+            <a:ext cx="2926080" cy="402336"/>
           </a:xfrm>
           <a:prstGeom prst="rect">
             <a:avLst/>
@@ -5149,14 +5086,14 @@
       </p:sp>
       <p:sp>
         <p:nvSpPr>
-          <p:cNvPr id="29" name="Text 22"/>
-          <p:cNvSpPr txBox="1"/>
-          <p:nvPr/>
-        </p:nvSpPr>
-        <p:spPr>
-          <a:xfrm>
-            <a:off x="5486400" y="4096512"/>
-            <a:ext cx="3063240" cy="457200"/>
+          <p:cNvPr id="26" name="Text 19"/>
+          <p:cNvSpPr txBox="1"/>
+          <p:nvPr/>
+        </p:nvSpPr>
+        <p:spPr>
+          <a:xfrm>
+            <a:off x="5303520" y="4005072"/>
+            <a:ext cx="3291840" cy="457200"/>
           </a:xfrm>
           <a:prstGeom prst="rect">
             <a:avLst/>
@@ -5185,14 +5122,14 @@
       </p:sp>
       <p:sp>
         <p:nvSpPr>
-          <p:cNvPr id="30" name="source"/>
-          <p:cNvSpPr txBox="1"/>
-          <p:nvPr/>
-        </p:nvSpPr>
-        <p:spPr>
-          <a:xfrm>
-            <a:off x="457200" y="4773168"/>
-            <a:ext cx="7680960" cy="228600"/>
+          <p:cNvPr id="27" name="source"/>
+          <p:cNvSpPr txBox="1"/>
+          <p:nvPr/>
+        </p:nvSpPr>
+        <p:spPr>
+          <a:xfrm>
+            <a:off x="457200" y="4727448"/>
+            <a:ext cx="7680960" cy="274320"/>
           </a:xfrm>
           <a:prstGeom prst="rect">
             <a:avLst/>
@@ -5208,14 +5145,14 @@
               <a:buNone/>
             </a:pPr>
             <a:r>
-              <a:rPr lang="en-US" sz="900" dirty="0">
+              <a:rPr lang="en-US" sz="1300" dirty="0">
                 <a:solidFill>
                   <a:schemeClr val="accent5"/>
                 </a:solidFill>
               </a:rPr>
               <a:t>参考：産婦人科診療ガイドライン 産科編2023／病気がみえる vol.10 産科</a:t>
             </a:r>
-            <a:endParaRPr lang="en-US" sz="900" dirty="0"/>
+            <a:endParaRPr lang="en-US" sz="1300" dirty="0"/>
           </a:p>
         </p:txBody>
       </p:sp>
@@ -5231,8 +5168,8 @@
         </p:nvSpPr>
         <p:spPr>
           <a:xfrm>
-            <a:off x="8321040" y="4773168"/>
-            <a:ext cx="365760" cy="228600"/>
+            <a:off x="8229600" y="4727448"/>
+            <a:ext cx="457200" cy="274320"/>
           </a:xfrm>
           <a:prstGeom prst="rect">
             <a:avLst/>
@@ -5247,7 +5184,7 @@
           <a:bodyPr/>
           <a:lstStyle>
             <a:lvl1pPr>
-              <a:defRPr sz="900">
+              <a:defRPr sz="1300">
                 <a:solidFill>
                   <a:schemeClr val="accent5"/>
                 </a:solidFill>
@@ -5327,51 +5264,9 @@
           </a:p>
         </p:txBody>
       </p:sp>
-      <p:sp>
-        <p:nvSpPr>
-          <p:cNvPr id="3" name="fetal-banner"/>
-          <p:cNvSpPr/>
-          <p:nvPr/>
-        </p:nvSpPr>
-        <p:spPr>
-          <a:xfrm>
-            <a:off x="457200" y="960120"/>
-            <a:ext cx="8229600" cy="731520"/>
-          </a:xfrm>
-          <a:prstGeom prst="roundRect">
-            <a:avLst>
-              <a:gd name="adj" fmla="val 12500"/>
-            </a:avLst>
-          </a:prstGeom>
-          <a:solidFill>
-            <a:schemeClr val="bg2"/>
-          </a:solidFill>
-          <a:ln/>
-        </p:spPr>
-      </p:sp>
-      <p:sp>
-        <p:nvSpPr>
-          <p:cNvPr id="4" name="fetal-banner-circle"/>
-          <p:cNvSpPr/>
-          <p:nvPr/>
-        </p:nvSpPr>
-        <p:spPr>
-          <a:xfrm>
-            <a:off x="621792" y="1078992"/>
-            <a:ext cx="493776" cy="493776"/>
-          </a:xfrm>
-          <a:prstGeom prst="ellipse">
-            <a:avLst/>
-          </a:prstGeom>
-          <a:solidFill>
-            <a:schemeClr val="accent1"/>
-          </a:solidFill>
-          <a:ln/>
-        </p:spPr>
-      </p:sp>
       <p:pic>
         <p:nvPicPr>
-          <p:cNvPr id="5" name="fetal-banner-icon" descr="preencoded.png">    </p:cNvPr>
+          <p:cNvPr id="3" name="fetal-banner-icon" descr="preencoded.png">    </p:cNvPr>
           <p:cNvPicPr>
             <a:picLocks noChangeAspect="1"/>
           </p:cNvPicPr>
@@ -5385,8 +5280,8 @@
         </p:blipFill>
         <p:spPr>
           <a:xfrm>
-            <a:off x="740298" y="1197498"/>
-            <a:ext cx="256764" cy="256764"/>
+            <a:off x="457200" y="1051560"/>
+            <a:ext cx="411480" cy="411480"/>
           </a:xfrm>
           <a:prstGeom prst="rect">
             <a:avLst/>
@@ -5395,14 +5290,14 @@
       </p:pic>
       <p:sp>
         <p:nvSpPr>
-          <p:cNvPr id="6" name="Text 3"/>
-          <p:cNvSpPr txBox="1"/>
-          <p:nvPr/>
-        </p:nvSpPr>
-        <p:spPr>
-          <a:xfrm>
-            <a:off x="1280160" y="987552"/>
-            <a:ext cx="7315200" cy="676656"/>
+          <p:cNvPr id="4" name="Text 1"/>
+          <p:cNvSpPr txBox="1"/>
+          <p:nvPr/>
+        </p:nvSpPr>
+        <p:spPr>
+          <a:xfrm>
+            <a:off x="1005840" y="941832"/>
+            <a:ext cx="7680960" cy="658368"/>
           </a:xfrm>
           <a:prstGeom prst="rect">
             <a:avLst/>
@@ -5432,7 +5327,7 @@
               <a:buNone/>
             </a:pPr>
             <a:r>
-              <a:rPr lang="en-US" sz="1200" dirty="0">
+              <a:rPr lang="en-US" sz="1300" dirty="0">
                 <a:solidFill>
                   <a:schemeClr val="tx1"/>
                 </a:solidFill>
@@ -5445,26 +5340,22 @@
       </p:sp>
       <p:sp>
         <p:nvSpPr>
-          <p:cNvPr id="7" name="fetal-card-0"/>
+          <p:cNvPr id="5" name="fetal-banner-rule"/>
           <p:cNvSpPr/>
           <p:nvPr/>
         </p:nvSpPr>
         <p:spPr>
           <a:xfrm>
-            <a:off x="457200" y="1874520"/>
-            <a:ext cx="2560320" cy="2194560"/>
-          </a:xfrm>
-          <a:prstGeom prst="roundRect">
-            <a:avLst>
-              <a:gd name="adj" fmla="val 4167"/>
-            </a:avLst>
-          </a:prstGeom>
-          <a:solidFill>
-            <a:schemeClr val="bg1"/>
-          </a:solidFill>
+            <a:off x="457200" y="1691640"/>
+            <a:ext cx="8229600" cy="0"/>
+          </a:xfrm>
+          <a:prstGeom prst="line">
+            <a:avLst/>
+          </a:prstGeom>
+          <a:noFill/>
           <a:ln w="12700">
             <a:solidFill>
-              <a:srgbClr val="D9D9D9"/>
+              <a:srgbClr val="BFBFBF"/>
             </a:solidFill>
             <a:prstDash val="solid"/>
           </a:ln>
@@ -5472,27 +5363,52 @@
       </p:sp>
       <p:sp>
         <p:nvSpPr>
-          <p:cNvPr id="8" name="fetal-0-circle"/>
+          <p:cNvPr id="6" name="fetal-0-decor"/>
           <p:cNvSpPr/>
           <p:nvPr/>
         </p:nvSpPr>
         <p:spPr>
           <a:xfrm>
-            <a:off x="640080" y="2011680"/>
-            <a:ext cx="457200" cy="457200"/>
+            <a:off x="2148840" y="3154680"/>
+            <a:ext cx="822960" cy="822960"/>
           </a:xfrm>
           <a:prstGeom prst="ellipse">
             <a:avLst/>
           </a:prstGeom>
           <a:solidFill>
-            <a:schemeClr val="accent4"/>
+            <a:schemeClr val="tx2">
+              <a:alpha val="5000"/>
+            </a:schemeClr>
           </a:solidFill>
           <a:ln/>
+        </p:spPr>
+      </p:sp>
+      <p:sp>
+        <p:nvSpPr>
+          <p:cNvPr id="7" name="fetal-0-rule"/>
+          <p:cNvSpPr/>
+          <p:nvPr/>
+        </p:nvSpPr>
+        <p:spPr>
+          <a:xfrm>
+            <a:off x="457200" y="4069080"/>
+            <a:ext cx="2560320" cy="0"/>
+          </a:xfrm>
+          <a:prstGeom prst="line">
+            <a:avLst/>
+          </a:prstGeom>
+          <a:noFill/>
+          <a:ln w="12700">
+            <a:solidFill>
+              <a:srgbClr val="BFBFBF"/>
+            </a:solidFill>
+            <a:prstDash val="solid"/>
+          </a:ln>
         </p:spPr>
       </p:sp>
       <p:pic>
         <p:nvPicPr>
-          <p:cNvPr id="9" name="fetal-0-icon" descr="preencoded.png">    </p:cNvPr>
+          <p:cNvPr id="8" name="fetal-0-icon" descr="preencoded.png">    </p:cNvPr>
           <p:cNvPicPr>
             <a:picLocks noChangeAspect="1"/>
           </p:cNvPicPr>
@@ -5506,8 +5422,8 @@
         </p:blipFill>
         <p:spPr>
           <a:xfrm>
-            <a:off x="749808" y="2121408"/>
-            <a:ext cx="237744" cy="237744"/>
+            <a:off x="457200" y="1920240"/>
+            <a:ext cx="365760" cy="365760"/>
           </a:xfrm>
           <a:prstGeom prst="rect">
             <a:avLst/>
@@ -5516,50 +5432,50 @@
       </p:pic>
       <p:sp>
         <p:nvSpPr>
+          <p:cNvPr id="9" name="Text 5"/>
+          <p:cNvSpPr txBox="1"/>
+          <p:nvPr/>
+        </p:nvSpPr>
+        <p:spPr>
+          <a:xfrm>
+            <a:off x="932688" y="1874520"/>
+            <a:ext cx="2084832" cy="457200"/>
+          </a:xfrm>
+          <a:prstGeom prst="rect">
+            <a:avLst/>
+          </a:prstGeom>
+          <a:noFill/>
+          <a:ln/>
+        </p:spPr>
+        <p:txBody>
+          <a:bodyPr wrap="square" lIns="0" tIns="0" rIns="0" bIns="0" rtlCol="0" anchor="ctr"/>
+          <a:lstStyle/>
+          <a:p>
+            <a:pPr indent="0" marL="0">
+              <a:buNone/>
+            </a:pPr>
+            <a:r>
+              <a:rPr lang="en-US" sz="1500" b="1" dirty="0">
+                <a:solidFill>
+                  <a:schemeClr val="tx2"/>
+                </a:solidFill>
+              </a:rPr>
+              <a:t>横隔膜ヘルニア</a:t>
+            </a:r>
+            <a:endParaRPr lang="en-US" sz="1500" dirty="0"/>
+          </a:p>
+        </p:txBody>
+      </p:sp>
+      <p:sp>
+        <p:nvSpPr>
           <p:cNvPr id="10" name="Text 6"/>
           <p:cNvSpPr txBox="1"/>
           <p:nvPr/>
         </p:nvSpPr>
         <p:spPr>
           <a:xfrm>
-            <a:off x="1188720" y="2011680"/>
-            <a:ext cx="1737360" cy="457200"/>
-          </a:xfrm>
-          <a:prstGeom prst="rect">
-            <a:avLst/>
-          </a:prstGeom>
-          <a:noFill/>
-          <a:ln/>
-        </p:spPr>
-        <p:txBody>
-          <a:bodyPr wrap="square" lIns="0" tIns="0" rIns="0" bIns="0" rtlCol="0" anchor="ctr"/>
-          <a:lstStyle/>
-          <a:p>
-            <a:pPr indent="0" marL="0">
-              <a:buNone/>
-            </a:pPr>
-            <a:r>
-              <a:rPr lang="en-US" sz="1500" b="1" dirty="0">
-                <a:solidFill>
-                  <a:schemeClr val="tx2"/>
-                </a:solidFill>
-              </a:rPr>
-              <a:t>横隔膜ヘルニア</a:t>
-            </a:r>
-            <a:endParaRPr lang="en-US" sz="1500" dirty="0"/>
-          </a:p>
-        </p:txBody>
-      </p:sp>
-      <p:sp>
-        <p:nvSpPr>
-          <p:cNvPr id="11" name="Text 7"/>
-          <p:cNvSpPr txBox="1"/>
-          <p:nvPr/>
-        </p:nvSpPr>
-        <p:spPr>
-          <a:xfrm>
-            <a:off x="640080" y="2606040"/>
-            <a:ext cx="2240280" cy="1371600"/>
+            <a:off x="457200" y="2423160"/>
+            <a:ext cx="2560320" cy="1554480"/>
           </a:xfrm>
           <a:prstGeom prst="rect">
             <a:avLst/>
@@ -5628,54 +5544,52 @@
       </p:sp>
       <p:sp>
         <p:nvSpPr>
-          <p:cNvPr id="12" name="fetal-card-1"/>
+          <p:cNvPr id="11" name="fetal-1-decor"/>
           <p:cNvSpPr/>
           <p:nvPr/>
         </p:nvSpPr>
         <p:spPr>
           <a:xfrm>
-            <a:off x="3291840" y="1874520"/>
-            <a:ext cx="2560320" cy="2194560"/>
-          </a:xfrm>
-          <a:prstGeom prst="roundRect">
-            <a:avLst>
-              <a:gd name="adj" fmla="val 4167"/>
-            </a:avLst>
+            <a:off x="4983480" y="3154680"/>
+            <a:ext cx="822960" cy="822960"/>
+          </a:xfrm>
+          <a:prstGeom prst="triangle">
+            <a:avLst/>
           </a:prstGeom>
           <a:solidFill>
-            <a:schemeClr val="bg1"/>
+            <a:schemeClr val="tx2">
+              <a:alpha val="5000"/>
+            </a:schemeClr>
           </a:solidFill>
+          <a:ln/>
+        </p:spPr>
+      </p:sp>
+      <p:sp>
+        <p:nvSpPr>
+          <p:cNvPr id="12" name="fetal-1-rule"/>
+          <p:cNvSpPr/>
+          <p:nvPr/>
+        </p:nvSpPr>
+        <p:spPr>
+          <a:xfrm>
+            <a:off x="3291840" y="4069080"/>
+            <a:ext cx="2560320" cy="0"/>
+          </a:xfrm>
+          <a:prstGeom prst="line">
+            <a:avLst/>
+          </a:prstGeom>
+          <a:noFill/>
           <a:ln w="12700">
             <a:solidFill>
-              <a:srgbClr val="D9D9D9"/>
+              <a:srgbClr val="BFBFBF"/>
             </a:solidFill>
             <a:prstDash val="solid"/>
           </a:ln>
         </p:spPr>
       </p:sp>
-      <p:sp>
-        <p:nvSpPr>
-          <p:cNvPr id="13" name="fetal-1-circle"/>
-          <p:cNvSpPr/>
-          <p:nvPr/>
-        </p:nvSpPr>
-        <p:spPr>
-          <a:xfrm>
-            <a:off x="3474720" y="2011680"/>
-            <a:ext cx="457200" cy="457200"/>
-          </a:xfrm>
-          <a:prstGeom prst="ellipse">
-            <a:avLst/>
-          </a:prstGeom>
-          <a:solidFill>
-            <a:schemeClr val="bg2"/>
-          </a:solidFill>
-          <a:ln/>
-        </p:spPr>
-      </p:sp>
       <p:pic>
         <p:nvPicPr>
-          <p:cNvPr id="14" name="fetal-1-icon" descr="preencoded.png">    </p:cNvPr>
+          <p:cNvPr id="13" name="fetal-1-icon" descr="preencoded.png">    </p:cNvPr>
           <p:cNvPicPr>
             <a:picLocks noChangeAspect="1"/>
           </p:cNvPicPr>
@@ -5689,8 +5603,8 @@
         </p:blipFill>
         <p:spPr>
           <a:xfrm>
-            <a:off x="3584448" y="2121408"/>
-            <a:ext cx="237744" cy="237744"/>
+            <a:off x="3291840" y="1920240"/>
+            <a:ext cx="365760" cy="365760"/>
           </a:xfrm>
           <a:prstGeom prst="rect">
             <a:avLst/>
@@ -5699,50 +5613,50 @@
       </p:pic>
       <p:sp>
         <p:nvSpPr>
+          <p:cNvPr id="14" name="Text 9"/>
+          <p:cNvSpPr txBox="1"/>
+          <p:nvPr/>
+        </p:nvSpPr>
+        <p:spPr>
+          <a:xfrm>
+            <a:off x="3767328" y="1874520"/>
+            <a:ext cx="2084832" cy="457200"/>
+          </a:xfrm>
+          <a:prstGeom prst="rect">
+            <a:avLst/>
+          </a:prstGeom>
+          <a:noFill/>
+          <a:ln/>
+        </p:spPr>
+        <p:txBody>
+          <a:bodyPr wrap="square" lIns="0" tIns="0" rIns="0" bIns="0" rtlCol="0" anchor="ctr"/>
+          <a:lstStyle/>
+          <a:p>
+            <a:pPr indent="0" marL="0">
+              <a:buNone/>
+            </a:pPr>
+            <a:r>
+              <a:rPr lang="en-US" sz="1500" b="1" dirty="0">
+                <a:solidFill>
+                  <a:schemeClr val="tx2"/>
+                </a:solidFill>
+              </a:rPr>
+              <a:t>肺動脈閉鎖・VSD</a:t>
+            </a:r>
+            <a:endParaRPr lang="en-US" sz="1500" dirty="0"/>
+          </a:p>
+        </p:txBody>
+      </p:sp>
+      <p:sp>
+        <p:nvSpPr>
           <p:cNvPr id="15" name="Text 10"/>
           <p:cNvSpPr txBox="1"/>
           <p:nvPr/>
         </p:nvSpPr>
         <p:spPr>
           <a:xfrm>
-            <a:off x="4023360" y="2011680"/>
-            <a:ext cx="1737360" cy="457200"/>
-          </a:xfrm>
-          <a:prstGeom prst="rect">
-            <a:avLst/>
-          </a:prstGeom>
-          <a:noFill/>
-          <a:ln/>
-        </p:spPr>
-        <p:txBody>
-          <a:bodyPr wrap="square" lIns="0" tIns="0" rIns="0" bIns="0" rtlCol="0" anchor="ctr"/>
-          <a:lstStyle/>
-          <a:p>
-            <a:pPr indent="0" marL="0">
-              <a:buNone/>
-            </a:pPr>
-            <a:r>
-              <a:rPr lang="en-US" sz="1500" b="1" dirty="0">
-                <a:solidFill>
-                  <a:schemeClr val="tx2"/>
-                </a:solidFill>
-              </a:rPr>
-              <a:t>肺動脈閉鎖・VSD</a:t>
-            </a:r>
-            <a:endParaRPr lang="en-US" sz="1500" dirty="0"/>
-          </a:p>
-        </p:txBody>
-      </p:sp>
-      <p:sp>
-        <p:nvSpPr>
-          <p:cNvPr id="16" name="Text 11"/>
-          <p:cNvSpPr txBox="1"/>
-          <p:nvPr/>
-        </p:nvSpPr>
-        <p:spPr>
-          <a:xfrm>
-            <a:off x="3474720" y="2606040"/>
-            <a:ext cx="2240280" cy="1371600"/>
+            <a:off x="3291840" y="2423160"/>
+            <a:ext cx="2560320" cy="1554480"/>
           </a:xfrm>
           <a:prstGeom prst="rect">
             <a:avLst/>
@@ -5811,54 +5725,52 @@
       </p:sp>
       <p:sp>
         <p:nvSpPr>
-          <p:cNvPr id="17" name="fetal-card-2"/>
+          <p:cNvPr id="16" name="fetal-2-decor"/>
           <p:cNvSpPr/>
           <p:nvPr/>
         </p:nvSpPr>
         <p:spPr>
           <a:xfrm>
-            <a:off x="6126480" y="1874520"/>
-            <a:ext cx="2560320" cy="2194560"/>
-          </a:xfrm>
-          <a:prstGeom prst="roundRect">
-            <a:avLst>
-              <a:gd name="adj" fmla="val 4167"/>
-            </a:avLst>
+            <a:off x="7818120" y="3154680"/>
+            <a:ext cx="822960" cy="822960"/>
+          </a:xfrm>
+          <a:prstGeom prst="rect">
+            <a:avLst/>
           </a:prstGeom>
           <a:solidFill>
-            <a:schemeClr val="bg1"/>
+            <a:schemeClr val="tx2">
+              <a:alpha val="5000"/>
+            </a:schemeClr>
           </a:solidFill>
+          <a:ln/>
+        </p:spPr>
+      </p:sp>
+      <p:sp>
+        <p:nvSpPr>
+          <p:cNvPr id="17" name="fetal-2-rule"/>
+          <p:cNvSpPr/>
+          <p:nvPr/>
+        </p:nvSpPr>
+        <p:spPr>
+          <a:xfrm>
+            <a:off x="6126480" y="4069080"/>
+            <a:ext cx="2560320" cy="0"/>
+          </a:xfrm>
+          <a:prstGeom prst="line">
+            <a:avLst/>
+          </a:prstGeom>
+          <a:noFill/>
           <a:ln w="12700">
             <a:solidFill>
-              <a:srgbClr val="D9D9D9"/>
+              <a:srgbClr val="BFBFBF"/>
             </a:solidFill>
             <a:prstDash val="solid"/>
           </a:ln>
         </p:spPr>
       </p:sp>
-      <p:sp>
-        <p:nvSpPr>
-          <p:cNvPr id="18" name="fetal-2-circle"/>
-          <p:cNvSpPr/>
-          <p:nvPr/>
-        </p:nvSpPr>
-        <p:spPr>
-          <a:xfrm>
-            <a:off x="6309360" y="2011680"/>
-            <a:ext cx="457200" cy="457200"/>
-          </a:xfrm>
-          <a:prstGeom prst="ellipse">
-            <a:avLst/>
-          </a:prstGeom>
-          <a:solidFill>
-            <a:schemeClr val="accent6"/>
-          </a:solidFill>
-          <a:ln/>
-        </p:spPr>
-      </p:sp>
       <p:pic>
         <p:nvPicPr>
-          <p:cNvPr id="19" name="fetal-2-icon" descr="preencoded.png">    </p:cNvPr>
+          <p:cNvPr id="18" name="fetal-2-icon" descr="preencoded.png">    </p:cNvPr>
           <p:cNvPicPr>
             <a:picLocks noChangeAspect="1"/>
           </p:cNvPicPr>
@@ -5872,8 +5784,8 @@
         </p:blipFill>
         <p:spPr>
           <a:xfrm>
-            <a:off x="6419088" y="2121408"/>
-            <a:ext cx="237744" cy="237744"/>
+            <a:off x="6126480" y="1920240"/>
+            <a:ext cx="365760" cy="365760"/>
           </a:xfrm>
           <a:prstGeom prst="rect">
             <a:avLst/>
@@ -5882,50 +5794,50 @@
       </p:pic>
       <p:sp>
         <p:nvSpPr>
+          <p:cNvPr id="19" name="Text 13"/>
+          <p:cNvSpPr txBox="1"/>
+          <p:nvPr/>
+        </p:nvSpPr>
+        <p:spPr>
+          <a:xfrm>
+            <a:off x="6601968" y="1874520"/>
+            <a:ext cx="2084832" cy="457200"/>
+          </a:xfrm>
+          <a:prstGeom prst="rect">
+            <a:avLst/>
+          </a:prstGeom>
+          <a:noFill/>
+          <a:ln/>
+        </p:spPr>
+        <p:txBody>
+          <a:bodyPr wrap="square" lIns="0" tIns="0" rIns="0" bIns="0" rtlCol="0" anchor="ctr"/>
+          <a:lstStyle/>
+          <a:p>
+            <a:pPr indent="0" marL="0">
+              <a:buNone/>
+            </a:pPr>
+            <a:r>
+              <a:rPr lang="en-US" sz="1500" b="1" dirty="0">
+                <a:solidFill>
+                  <a:schemeClr val="tx2"/>
+                </a:solidFill>
+              </a:rPr>
+              <a:t>十二指腸閉鎖</a:t>
+            </a:r>
+            <a:endParaRPr lang="en-US" sz="1500" dirty="0"/>
+          </a:p>
+        </p:txBody>
+      </p:sp>
+      <p:sp>
+        <p:nvSpPr>
           <p:cNvPr id="20" name="Text 14"/>
           <p:cNvSpPr txBox="1"/>
           <p:nvPr/>
         </p:nvSpPr>
         <p:spPr>
           <a:xfrm>
-            <a:off x="6858000" y="2011680"/>
-            <a:ext cx="1737360" cy="457200"/>
-          </a:xfrm>
-          <a:prstGeom prst="rect">
-            <a:avLst/>
-          </a:prstGeom>
-          <a:noFill/>
-          <a:ln/>
-        </p:spPr>
-        <p:txBody>
-          <a:bodyPr wrap="square" lIns="0" tIns="0" rIns="0" bIns="0" rtlCol="0" anchor="ctr"/>
-          <a:lstStyle/>
-          <a:p>
-            <a:pPr indent="0" marL="0">
-              <a:buNone/>
-            </a:pPr>
-            <a:r>
-              <a:rPr lang="en-US" sz="1500" b="1" dirty="0">
-                <a:solidFill>
-                  <a:schemeClr val="tx2"/>
-                </a:solidFill>
-              </a:rPr>
-              <a:t>十二指腸閉鎖</a:t>
-            </a:r>
-            <a:endParaRPr lang="en-US" sz="1500" dirty="0"/>
-          </a:p>
-        </p:txBody>
-      </p:sp>
-      <p:sp>
-        <p:nvSpPr>
-          <p:cNvPr id="21" name="Text 15"/>
-          <p:cNvSpPr txBox="1"/>
-          <p:nvPr/>
-        </p:nvSpPr>
-        <p:spPr>
-          <a:xfrm>
-            <a:off x="6309360" y="2606040"/>
-            <a:ext cx="2240280" cy="1371600"/>
+            <a:off x="6126480" y="2423160"/>
+            <a:ext cx="2560320" cy="1554480"/>
           </a:xfrm>
           <a:prstGeom prst="rect">
             <a:avLst/>
@@ -5976,13 +5888,13 @@
       </p:sp>
       <p:sp>
         <p:nvSpPr>
-          <p:cNvPr id="22" name="Text 16"/>
-          <p:cNvSpPr txBox="1"/>
-          <p:nvPr/>
-        </p:nvSpPr>
-        <p:spPr>
-          <a:xfrm>
-            <a:off x="457200" y="4224528"/>
+          <p:cNvPr id="21" name="Text 15"/>
+          <p:cNvSpPr txBox="1"/>
+          <p:nvPr/>
+        </p:nvSpPr>
+        <p:spPr>
+          <a:xfrm>
+            <a:off x="457200" y="4187952"/>
             <a:ext cx="8229600" cy="411480"/>
           </a:xfrm>
           <a:prstGeom prst="rect">
@@ -6023,14 +5935,14 @@
       </p:sp>
       <p:sp>
         <p:nvSpPr>
-          <p:cNvPr id="23" name="source"/>
-          <p:cNvSpPr txBox="1"/>
-          <p:nvPr/>
-        </p:nvSpPr>
-        <p:spPr>
-          <a:xfrm>
-            <a:off x="457200" y="4773168"/>
-            <a:ext cx="7680960" cy="228600"/>
+          <p:cNvPr id="22" name="source"/>
+          <p:cNvSpPr txBox="1"/>
+          <p:nvPr/>
+        </p:nvSpPr>
+        <p:spPr>
+          <a:xfrm>
+            <a:off x="457200" y="4727448"/>
+            <a:ext cx="7680960" cy="274320"/>
           </a:xfrm>
           <a:prstGeom prst="rect">
             <a:avLst/>
@@ -6046,14 +5958,14 @@
               <a:buNone/>
             </a:pPr>
             <a:r>
-              <a:rPr lang="en-US" sz="900" dirty="0">
+              <a:rPr lang="en-US" sz="1300" dirty="0">
                 <a:solidFill>
                   <a:schemeClr val="accent5"/>
                 </a:solidFill>
               </a:rPr>
-              <a:t>参考：産婦人科診療ガイドライン 産科編2023／新生児先天性横隔膜ヘルニア診療ガイドライン</a:t>
-            </a:r>
-            <a:endParaRPr lang="en-US" sz="900" dirty="0"/>
+              <a:t>参考：産婦人科診療ガイドライン 産科編2023／先天性横隔膜ヘルニア診療ガイドライン</a:t>
+            </a:r>
+            <a:endParaRPr lang="en-US" sz="1300" dirty="0"/>
           </a:p>
         </p:txBody>
       </p:sp>
@@ -6069,8 +5981,8 @@
         </p:nvSpPr>
         <p:spPr>
           <a:xfrm>
-            <a:off x="8321040" y="4773168"/>
-            <a:ext cx="365760" cy="228600"/>
+            <a:off x="8229600" y="4727448"/>
+            <a:ext cx="457200" cy="274320"/>
           </a:xfrm>
           <a:prstGeom prst="rect">
             <a:avLst/>
@@ -6085,7 +5997,7 @@
           <a:bodyPr/>
           <a:lstStyle>
             <a:lvl1pPr>
-              <a:defRPr sz="900">
+              <a:defRPr sz="1300">
                 <a:solidFill>
                   <a:schemeClr val="accent5"/>
                 </a:solidFill>
@@ -6124,7 +6036,7 @@
         <a:srgbClr val="7A2048"/>
       </a:dk2>
       <a:lt2>
-        <a:srgbClr val="FBEAF0"/>
+        <a:srgbClr val="EFEFEF"/>
       </a:lt2>
       <a:accent1>
         <a:srgbClr val="7A2048"/>
@@ -6136,13 +6048,13 @@
         <a:srgbClr val="C0392B"/>
       </a:accent3>
       <a:accent4>
-        <a:srgbClr val="E6F2F2"/>
+        <a:srgbClr val="4D4D4D"/>
       </a:accent4>
       <a:accent5>
-        <a:srgbClr val="6B6B6B"/>
+        <a:srgbClr val="666666"/>
       </a:accent5>
       <a:accent6>
-        <a:srgbClr val="F3F3F3"/>
+        <a:srgbClr val="BFBFBF"/>
       </a:accent6>
       <a:hlink>
         <a:srgbClr val="1F7A7A"/>

</xml_diff>

<commit_message>
Remove image icons from cesarean slides
Co-Authored-By: Claude Opus 5.5 <noreply@anthropic.com>
Claude-Session: https://claude.ai/code/session_017AawXZuegeVsAfmgt6D2q5
</commit_message>
<xml_diff>
--- a/slides/⑤帝王切開.pptx
+++ b/slides/⑤帝王切開.pptx
@@ -111,7 +111,7 @@
   <p:extLst>
     <p:ext uri="{521415D9-36F7-43E2-AB2F-B90AF26B5E84}">
       <p14:sectionLst xmlns:p14="http://schemas.microsoft.com/office/powerpoint/2010/main">
-        <p14:section name="⑤ 帝王切開" id="{2a89da97-6e39-f401-fa6f-5359e217ebb6}">
+        <p14:section name="⑤ 帝王切開" id="{f4ef19ac-ab88-4234-e32f-2ad6a38099fc}">
           <p14:sldIdLst>
             <p14:sldId id="256"/>
             <p14:sldId id="257"/>
@@ -1743,40 +1743,16 @@
           </a:ln>
         </p:spPr>
       </p:sp>
-      <p:pic>
-        <p:nvPicPr>
-          <p:cNvPr id="12" name="type-0-icon" descr="preencoded.png">    </p:cNvPr>
-          <p:cNvPicPr>
-            <a:picLocks noChangeAspect="1"/>
-          </p:cNvPicPr>
-          <p:nvPr/>
-        </p:nvPicPr>
-        <p:blipFill>
-          <a:blip r:embed="rId1"/>
-          <a:stretch>
-            <a:fillRect/>
-          </a:stretch>
-        </p:blipFill>
-        <p:spPr>
-          <a:xfrm>
-            <a:off x="3520440" y="1051560"/>
-            <a:ext cx="365760" cy="365760"/>
-          </a:xfrm>
-          <a:prstGeom prst="rect">
-            <a:avLst/>
-          </a:prstGeom>
-        </p:spPr>
-      </p:pic>
-      <p:sp>
-        <p:nvSpPr>
-          <p:cNvPr id="13" name="Text 10"/>
-          <p:cNvSpPr txBox="1"/>
-          <p:nvPr/>
-        </p:nvSpPr>
-        <p:spPr>
-          <a:xfrm>
-            <a:off x="4023360" y="1005840"/>
-            <a:ext cx="4572000" cy="457200"/>
+      <p:sp>
+        <p:nvSpPr>
+          <p:cNvPr id="12" name="Text 10"/>
+          <p:cNvSpPr txBox="1"/>
+          <p:nvPr/>
+        </p:nvSpPr>
+        <p:spPr>
+          <a:xfrm>
+            <a:off x="3520440" y="1005840"/>
+            <a:ext cx="5074920" cy="457200"/>
           </a:xfrm>
           <a:prstGeom prst="rect">
             <a:avLst/>
@@ -1805,14 +1781,14 @@
       </p:sp>
       <p:sp>
         <p:nvSpPr>
-          <p:cNvPr id="14" name="Text 11"/>
-          <p:cNvSpPr txBox="1"/>
-          <p:nvPr/>
-        </p:nvSpPr>
-        <p:spPr>
-          <a:xfrm>
-            <a:off x="4023360" y="1508760"/>
-            <a:ext cx="4572000" cy="1051560"/>
+          <p:cNvPr id="13" name="Text 11"/>
+          <p:cNvSpPr txBox="1"/>
+          <p:nvPr/>
+        </p:nvSpPr>
+        <p:spPr>
+          <a:xfrm>
+            <a:off x="3520440" y="1508760"/>
+            <a:ext cx="5074920" cy="1051560"/>
           </a:xfrm>
           <a:prstGeom prst="rect">
             <a:avLst/>
@@ -1881,7 +1857,7 @@
       </p:sp>
       <p:sp>
         <p:nvSpPr>
-          <p:cNvPr id="15" name="type-1-decor"/>
+          <p:cNvPr id="14" name="type-1-decor"/>
           <p:cNvSpPr/>
           <p:nvPr/>
         </p:nvSpPr>
@@ -1903,7 +1879,7 @@
       </p:sp>
       <p:sp>
         <p:nvSpPr>
-          <p:cNvPr id="16" name="type-1-rule"/>
+          <p:cNvPr id="15" name="type-1-rule"/>
           <p:cNvSpPr/>
           <p:nvPr/>
         </p:nvSpPr>
@@ -1924,40 +1900,16 @@
           </a:ln>
         </p:spPr>
       </p:sp>
-      <p:pic>
-        <p:nvPicPr>
-          <p:cNvPr id="17" name="type-1-icon" descr="preencoded.png">    </p:cNvPr>
-          <p:cNvPicPr>
-            <a:picLocks noChangeAspect="1"/>
-          </p:cNvPicPr>
-          <p:nvPr/>
-        </p:nvPicPr>
-        <p:blipFill>
-          <a:blip r:embed="rId2"/>
-          <a:stretch>
-            <a:fillRect/>
-          </a:stretch>
-        </p:blipFill>
-        <p:spPr>
-          <a:xfrm>
-            <a:off x="3520440" y="2926080"/>
-            <a:ext cx="365760" cy="365760"/>
-          </a:xfrm>
-          <a:prstGeom prst="rect">
-            <a:avLst/>
-          </a:prstGeom>
-        </p:spPr>
-      </p:pic>
-      <p:sp>
-        <p:nvSpPr>
-          <p:cNvPr id="18" name="Text 14"/>
-          <p:cNvSpPr txBox="1"/>
-          <p:nvPr/>
-        </p:nvSpPr>
-        <p:spPr>
-          <a:xfrm>
-            <a:off x="4023360" y="2880360"/>
-            <a:ext cx="4572000" cy="457200"/>
+      <p:sp>
+        <p:nvSpPr>
+          <p:cNvPr id="16" name="Text 14"/>
+          <p:cNvSpPr txBox="1"/>
+          <p:nvPr/>
+        </p:nvSpPr>
+        <p:spPr>
+          <a:xfrm>
+            <a:off x="3520440" y="2880360"/>
+            <a:ext cx="5074920" cy="457200"/>
           </a:xfrm>
           <a:prstGeom prst="rect">
             <a:avLst/>
@@ -1986,14 +1938,14 @@
       </p:sp>
       <p:sp>
         <p:nvSpPr>
-          <p:cNvPr id="19" name="Text 15"/>
-          <p:cNvSpPr txBox="1"/>
-          <p:nvPr/>
-        </p:nvSpPr>
-        <p:spPr>
-          <a:xfrm>
-            <a:off x="4023360" y="3383280"/>
-            <a:ext cx="4572000" cy="1051560"/>
+          <p:cNvPr id="17" name="Text 15"/>
+          <p:cNvSpPr txBox="1"/>
+          <p:nvPr/>
+        </p:nvSpPr>
+        <p:spPr>
+          <a:xfrm>
+            <a:off x="3520440" y="3383280"/>
+            <a:ext cx="5074920" cy="1051560"/>
           </a:xfrm>
           <a:prstGeom prst="rect">
             <a:avLst/>
@@ -2062,7 +2014,7 @@
       </p:sp>
       <p:sp>
         <p:nvSpPr>
-          <p:cNvPr id="20" name="source"/>
+          <p:cNvPr id="18" name="source"/>
           <p:cNvSpPr txBox="1"/>
           <p:nvPr/>
         </p:nvSpPr>
@@ -2249,40 +2201,16 @@
           </a:ln>
         </p:spPr>
       </p:sp>
-      <p:pic>
-        <p:nvPicPr>
-          <p:cNvPr id="5" name="indic-0-icon" descr="preencoded.png">    </p:cNvPr>
-          <p:cNvPicPr>
-            <a:picLocks noChangeAspect="1"/>
-          </p:cNvPicPr>
-          <p:nvPr/>
-        </p:nvPicPr>
-        <p:blipFill>
-          <a:blip r:embed="rId1"/>
-          <a:stretch>
-            <a:fillRect/>
-          </a:stretch>
-        </p:blipFill>
-        <p:spPr>
-          <a:xfrm>
-            <a:off x="457200" y="1051560"/>
-            <a:ext cx="384048" cy="384048"/>
-          </a:xfrm>
-          <a:prstGeom prst="rect">
-            <a:avLst/>
-          </a:prstGeom>
-        </p:spPr>
-      </p:pic>
-      <p:sp>
-        <p:nvSpPr>
-          <p:cNvPr id="6" name="Text 3"/>
-          <p:cNvSpPr txBox="1"/>
-          <p:nvPr/>
-        </p:nvSpPr>
-        <p:spPr>
-          <a:xfrm>
-            <a:off x="960120" y="1005840"/>
-            <a:ext cx="2057400" cy="475488"/>
+      <p:sp>
+        <p:nvSpPr>
+          <p:cNvPr id="5" name="Text 3"/>
+          <p:cNvSpPr txBox="1"/>
+          <p:nvPr/>
+        </p:nvSpPr>
+        <p:spPr>
+          <a:xfrm>
+            <a:off x="457200" y="1005840"/>
+            <a:ext cx="2560320" cy="475488"/>
           </a:xfrm>
           <a:prstGeom prst="rect">
             <a:avLst/>
@@ -2311,7 +2239,7 @@
       </p:sp>
       <p:sp>
         <p:nvSpPr>
-          <p:cNvPr id="7" name="Text 4"/>
+          <p:cNvPr id="6" name="Text 4"/>
           <p:cNvSpPr txBox="1"/>
           <p:nvPr/>
         </p:nvSpPr>
@@ -2423,7 +2351,7 @@
       </p:sp>
       <p:sp>
         <p:nvSpPr>
-          <p:cNvPr id="8" name="indic-1-decor"/>
+          <p:cNvPr id="7" name="indic-1-decor"/>
           <p:cNvSpPr/>
           <p:nvPr/>
         </p:nvSpPr>
@@ -2445,7 +2373,7 @@
       </p:sp>
       <p:sp>
         <p:nvSpPr>
-          <p:cNvPr id="9" name="indic-1-rule"/>
+          <p:cNvPr id="8" name="indic-1-rule"/>
           <p:cNvSpPr/>
           <p:nvPr/>
         </p:nvSpPr>
@@ -2466,40 +2394,16 @@
           </a:ln>
         </p:spPr>
       </p:sp>
-      <p:pic>
-        <p:nvPicPr>
-          <p:cNvPr id="10" name="indic-1-icon" descr="preencoded.png">    </p:cNvPr>
-          <p:cNvPicPr>
-            <a:picLocks noChangeAspect="1"/>
-          </p:cNvPicPr>
-          <p:nvPr/>
-        </p:nvPicPr>
-        <p:blipFill>
-          <a:blip r:embed="rId2"/>
-          <a:stretch>
-            <a:fillRect/>
-          </a:stretch>
-        </p:blipFill>
-        <p:spPr>
-          <a:xfrm>
-            <a:off x="3291840" y="1051560"/>
-            <a:ext cx="384048" cy="384048"/>
-          </a:xfrm>
-          <a:prstGeom prst="rect">
-            <a:avLst/>
-          </a:prstGeom>
-        </p:spPr>
-      </p:pic>
-      <p:sp>
-        <p:nvSpPr>
-          <p:cNvPr id="11" name="Text 7"/>
-          <p:cNvSpPr txBox="1"/>
-          <p:nvPr/>
-        </p:nvSpPr>
-        <p:spPr>
-          <a:xfrm>
-            <a:off x="3794760" y="1005840"/>
-            <a:ext cx="2057400" cy="475488"/>
+      <p:sp>
+        <p:nvSpPr>
+          <p:cNvPr id="9" name="Text 7"/>
+          <p:cNvSpPr txBox="1"/>
+          <p:nvPr/>
+        </p:nvSpPr>
+        <p:spPr>
+          <a:xfrm>
+            <a:off x="3291840" y="1005840"/>
+            <a:ext cx="2560320" cy="475488"/>
           </a:xfrm>
           <a:prstGeom prst="rect">
             <a:avLst/>
@@ -2528,7 +2432,7 @@
       </p:sp>
       <p:sp>
         <p:nvSpPr>
-          <p:cNvPr id="12" name="Text 8"/>
+          <p:cNvPr id="10" name="Text 8"/>
           <p:cNvSpPr txBox="1"/>
           <p:nvPr/>
         </p:nvSpPr>
@@ -2640,7 +2544,7 @@
       </p:sp>
       <p:sp>
         <p:nvSpPr>
-          <p:cNvPr id="13" name="indic-2-decor"/>
+          <p:cNvPr id="11" name="indic-2-decor"/>
           <p:cNvSpPr/>
           <p:nvPr/>
         </p:nvSpPr>
@@ -2662,7 +2566,7 @@
       </p:sp>
       <p:sp>
         <p:nvSpPr>
-          <p:cNvPr id="14" name="indic-2-rule"/>
+          <p:cNvPr id="12" name="indic-2-rule"/>
           <p:cNvSpPr/>
           <p:nvPr/>
         </p:nvSpPr>
@@ -2683,40 +2587,16 @@
           </a:ln>
         </p:spPr>
       </p:sp>
-      <p:pic>
-        <p:nvPicPr>
-          <p:cNvPr id="15" name="indic-2-icon" descr="preencoded.png">    </p:cNvPr>
-          <p:cNvPicPr>
-            <a:picLocks noChangeAspect="1"/>
-          </p:cNvPicPr>
-          <p:nvPr/>
-        </p:nvPicPr>
-        <p:blipFill>
-          <a:blip r:embed="rId3"/>
-          <a:stretch>
-            <a:fillRect/>
-          </a:stretch>
-        </p:blipFill>
-        <p:spPr>
-          <a:xfrm>
-            <a:off x="6126480" y="1051560"/>
-            <a:ext cx="384048" cy="384048"/>
-          </a:xfrm>
-          <a:prstGeom prst="rect">
-            <a:avLst/>
-          </a:prstGeom>
-        </p:spPr>
-      </p:pic>
-      <p:sp>
-        <p:nvSpPr>
-          <p:cNvPr id="16" name="Text 11"/>
-          <p:cNvSpPr txBox="1"/>
-          <p:nvPr/>
-        </p:nvSpPr>
-        <p:spPr>
-          <a:xfrm>
-            <a:off x="6629400" y="1005840"/>
-            <a:ext cx="2057400" cy="475488"/>
+      <p:sp>
+        <p:nvSpPr>
+          <p:cNvPr id="13" name="Text 11"/>
+          <p:cNvSpPr txBox="1"/>
+          <p:nvPr/>
+        </p:nvSpPr>
+        <p:spPr>
+          <a:xfrm>
+            <a:off x="6126480" y="1005840"/>
+            <a:ext cx="2560320" cy="475488"/>
           </a:xfrm>
           <a:prstGeom prst="rect">
             <a:avLst/>
@@ -2745,7 +2625,7 @@
       </p:sp>
       <p:sp>
         <p:nvSpPr>
-          <p:cNvPr id="17" name="Text 12"/>
+          <p:cNvPr id="14" name="Text 12"/>
           <p:cNvSpPr txBox="1"/>
           <p:nvPr/>
         </p:nvSpPr>
@@ -2837,40 +2717,16 @@
           </a:p>
         </p:txBody>
       </p:sp>
-      <p:pic>
-        <p:nvPicPr>
-          <p:cNvPr id="18" name="indic-callout-icon" descr="preencoded.png">    </p:cNvPr>
-          <p:cNvPicPr>
-            <a:picLocks noChangeAspect="1"/>
-          </p:cNvPicPr>
-          <p:nvPr/>
-        </p:nvPicPr>
-        <p:blipFill>
-          <a:blip r:embed="rId4"/>
-          <a:stretch>
-            <a:fillRect/>
-          </a:stretch>
-        </p:blipFill>
-        <p:spPr>
-          <a:xfrm>
-            <a:off x="457200" y="4133088"/>
-            <a:ext cx="384048" cy="384048"/>
-          </a:xfrm>
-          <a:prstGeom prst="rect">
-            <a:avLst/>
-          </a:prstGeom>
-        </p:spPr>
-      </p:pic>
-      <p:sp>
-        <p:nvSpPr>
-          <p:cNvPr id="19" name="Text 13"/>
-          <p:cNvSpPr txBox="1"/>
-          <p:nvPr/>
-        </p:nvSpPr>
-        <p:spPr>
-          <a:xfrm>
-            <a:off x="960120" y="4069080"/>
-            <a:ext cx="7726680" cy="512064"/>
+      <p:sp>
+        <p:nvSpPr>
+          <p:cNvPr id="15" name="Text 13"/>
+          <p:cNvSpPr txBox="1"/>
+          <p:nvPr/>
+        </p:nvSpPr>
+        <p:spPr>
+          <a:xfrm>
+            <a:off x="457200" y="4069080"/>
+            <a:ext cx="8229600" cy="512064"/>
           </a:xfrm>
           <a:prstGeom prst="rect">
             <a:avLst/>
@@ -2899,7 +2755,7 @@
       </p:sp>
       <p:sp>
         <p:nvSpPr>
-          <p:cNvPr id="20" name="source"/>
+          <p:cNvPr id="16" name="source"/>
           <p:cNvSpPr txBox="1"/>
           <p:nvPr/>
         </p:nvSpPr>
@@ -3877,40 +3733,16 @@
           </a:ln>
         </p:spPr>
       </p:sp>
-      <p:pic>
-        <p:nvPicPr>
-          <p:cNvPr id="30" name="flow-box-0-icon" descr="preencoded.png">    </p:cNvPr>
-          <p:cNvPicPr>
-            <a:picLocks noChangeAspect="1"/>
-          </p:cNvPicPr>
-          <p:nvPr/>
-        </p:nvPicPr>
-        <p:blipFill>
-          <a:blip r:embed="rId1"/>
-          <a:stretch>
-            <a:fillRect/>
-          </a:stretch>
-        </p:blipFill>
-        <p:spPr>
-          <a:xfrm>
-            <a:off x="457200" y="2743200"/>
-            <a:ext cx="365760" cy="365760"/>
-          </a:xfrm>
-          <a:prstGeom prst="rect">
-            <a:avLst/>
-          </a:prstGeom>
-        </p:spPr>
-      </p:pic>
-      <p:sp>
-        <p:nvSpPr>
-          <p:cNvPr id="31" name="Text 28"/>
-          <p:cNvSpPr txBox="1"/>
-          <p:nvPr/>
-        </p:nvSpPr>
-        <p:spPr>
-          <a:xfrm>
-            <a:off x="960120" y="2715768"/>
-            <a:ext cx="3383280" cy="420624"/>
+      <p:sp>
+        <p:nvSpPr>
+          <p:cNvPr id="30" name="Text 28"/>
+          <p:cNvSpPr txBox="1"/>
+          <p:nvPr/>
+        </p:nvSpPr>
+        <p:spPr>
+          <a:xfrm>
+            <a:off x="457200" y="2715768"/>
+            <a:ext cx="3886200" cy="420624"/>
           </a:xfrm>
           <a:prstGeom prst="rect">
             <a:avLst/>
@@ -3939,7 +3771,7 @@
       </p:sp>
       <p:sp>
         <p:nvSpPr>
-          <p:cNvPr id="32" name="Text 29"/>
+          <p:cNvPr id="31" name="Text 29"/>
           <p:cNvSpPr txBox="1"/>
           <p:nvPr/>
         </p:nvSpPr>
@@ -4020,7 +3852,7 @@
       </p:sp>
       <p:sp>
         <p:nvSpPr>
-          <p:cNvPr id="33" name="flow-box-1-decor"/>
+          <p:cNvPr id="32" name="flow-box-1-decor"/>
           <p:cNvSpPr/>
           <p:nvPr/>
         </p:nvSpPr>
@@ -4042,7 +3874,7 @@
       </p:sp>
       <p:sp>
         <p:nvSpPr>
-          <p:cNvPr id="34" name="flow-box-1-rule"/>
+          <p:cNvPr id="33" name="flow-box-1-rule"/>
           <p:cNvSpPr/>
           <p:nvPr/>
         </p:nvSpPr>
@@ -4063,40 +3895,16 @@
           </a:ln>
         </p:spPr>
       </p:sp>
-      <p:pic>
-        <p:nvPicPr>
-          <p:cNvPr id="35" name="flow-box-1-icon" descr="preencoded.png">    </p:cNvPr>
-          <p:cNvPicPr>
-            <a:picLocks noChangeAspect="1"/>
-          </p:cNvPicPr>
-          <p:nvPr/>
-        </p:nvPicPr>
-        <p:blipFill>
-          <a:blip r:embed="rId2"/>
-          <a:stretch>
-            <a:fillRect/>
-          </a:stretch>
-        </p:blipFill>
-        <p:spPr>
-          <a:xfrm>
-            <a:off x="4709160" y="2743200"/>
-            <a:ext cx="365760" cy="365760"/>
-          </a:xfrm>
-          <a:prstGeom prst="rect">
-            <a:avLst/>
-          </a:prstGeom>
-        </p:spPr>
-      </p:pic>
-      <p:sp>
-        <p:nvSpPr>
-          <p:cNvPr id="36" name="Text 32"/>
-          <p:cNvSpPr txBox="1"/>
-          <p:nvPr/>
-        </p:nvSpPr>
-        <p:spPr>
-          <a:xfrm>
-            <a:off x="5212080" y="2715768"/>
-            <a:ext cx="3383280" cy="420624"/>
+      <p:sp>
+        <p:nvSpPr>
+          <p:cNvPr id="34" name="Text 32"/>
+          <p:cNvSpPr txBox="1"/>
+          <p:nvPr/>
+        </p:nvSpPr>
+        <p:spPr>
+          <a:xfrm>
+            <a:off x="4709160" y="2715768"/>
+            <a:ext cx="3886200" cy="420624"/>
           </a:xfrm>
           <a:prstGeom prst="rect">
             <a:avLst/>
@@ -4125,7 +3933,7 @@
       </p:sp>
       <p:sp>
         <p:nvSpPr>
-          <p:cNvPr id="37" name="Text 33"/>
+          <p:cNvPr id="35" name="Text 33"/>
           <p:cNvSpPr txBox="1"/>
           <p:nvPr/>
         </p:nvSpPr>
@@ -4206,7 +4014,7 @@
       </p:sp>
       <p:sp>
         <p:nvSpPr>
-          <p:cNvPr id="38" name="source"/>
+          <p:cNvPr id="36" name="source"/>
           <p:cNvSpPr txBox="1"/>
           <p:nvPr/>
         </p:nvSpPr>
@@ -4384,40 +4192,16 @@
           </a:p>
         </p:txBody>
       </p:sp>
-      <p:pic>
-        <p:nvPicPr>
-          <p:cNvPr id="4" name="comp-0-icon" descr="preencoded.png">    </p:cNvPr>
-          <p:cNvPicPr>
-            <a:picLocks noChangeAspect="1"/>
-          </p:cNvPicPr>
-          <p:nvPr/>
-        </p:nvPicPr>
-        <p:blipFill>
-          <a:blip r:embed="rId1"/>
-          <a:stretch>
-            <a:fillRect/>
-          </a:stretch>
-        </p:blipFill>
-        <p:spPr>
-          <a:xfrm>
-            <a:off x="502920" y="1435608"/>
-            <a:ext cx="365760" cy="365760"/>
-          </a:xfrm>
-          <a:prstGeom prst="rect">
-            <a:avLst/>
-          </a:prstGeom>
-        </p:spPr>
-      </p:pic>
-      <p:sp>
-        <p:nvSpPr>
-          <p:cNvPr id="5" name="Text 2"/>
-          <p:cNvSpPr txBox="1"/>
-          <p:nvPr/>
-        </p:nvSpPr>
-        <p:spPr>
-          <a:xfrm>
-            <a:off x="1097280" y="1380744"/>
-            <a:ext cx="3840480" cy="274320"/>
+      <p:sp>
+        <p:nvSpPr>
+          <p:cNvPr id="4" name="Text 2"/>
+          <p:cNvSpPr txBox="1"/>
+          <p:nvPr/>
+        </p:nvSpPr>
+        <p:spPr>
+          <a:xfrm>
+            <a:off x="457200" y="1380744"/>
+            <a:ext cx="4480560" cy="274320"/>
           </a:xfrm>
           <a:prstGeom prst="rect">
             <a:avLst/>
@@ -4446,14 +4230,14 @@
       </p:sp>
       <p:sp>
         <p:nvSpPr>
-          <p:cNvPr id="6" name="Text 3"/>
-          <p:cNvSpPr txBox="1"/>
-          <p:nvPr/>
-        </p:nvSpPr>
-        <p:spPr>
-          <a:xfrm>
-            <a:off x="1097280" y="1664208"/>
-            <a:ext cx="3886200" cy="457200"/>
+          <p:cNvPr id="5" name="Text 3"/>
+          <p:cNvSpPr txBox="1"/>
+          <p:nvPr/>
+        </p:nvSpPr>
+        <p:spPr>
+          <a:xfrm>
+            <a:off x="457200" y="1664208"/>
+            <a:ext cx="4526280" cy="457200"/>
           </a:xfrm>
           <a:prstGeom prst="rect">
             <a:avLst/>
@@ -4480,40 +4264,16 @@
           </a:p>
         </p:txBody>
       </p:sp>
-      <p:pic>
-        <p:nvPicPr>
-          <p:cNvPr id="7" name="comp-1-icon" descr="preencoded.png">    </p:cNvPr>
-          <p:cNvPicPr>
-            <a:picLocks noChangeAspect="1"/>
-          </p:cNvPicPr>
-          <p:nvPr/>
-        </p:nvPicPr>
-        <p:blipFill>
-          <a:blip r:embed="rId2"/>
-          <a:stretch>
-            <a:fillRect/>
-          </a:stretch>
-        </p:blipFill>
-        <p:spPr>
-          <a:xfrm>
-            <a:off x="502920" y="2258568"/>
-            <a:ext cx="365760" cy="365760"/>
-          </a:xfrm>
-          <a:prstGeom prst="rect">
-            <a:avLst/>
-          </a:prstGeom>
-        </p:spPr>
-      </p:pic>
-      <p:sp>
-        <p:nvSpPr>
-          <p:cNvPr id="8" name="Text 4"/>
-          <p:cNvSpPr txBox="1"/>
-          <p:nvPr/>
-        </p:nvSpPr>
-        <p:spPr>
-          <a:xfrm>
-            <a:off x="1097280" y="2203704"/>
-            <a:ext cx="3840480" cy="274320"/>
+      <p:sp>
+        <p:nvSpPr>
+          <p:cNvPr id="6" name="Text 4"/>
+          <p:cNvSpPr txBox="1"/>
+          <p:nvPr/>
+        </p:nvSpPr>
+        <p:spPr>
+          <a:xfrm>
+            <a:off x="457200" y="2203704"/>
+            <a:ext cx="4480560" cy="274320"/>
           </a:xfrm>
           <a:prstGeom prst="rect">
             <a:avLst/>
@@ -4542,14 +4302,14 @@
       </p:sp>
       <p:sp>
         <p:nvSpPr>
-          <p:cNvPr id="9" name="Text 5"/>
-          <p:cNvSpPr txBox="1"/>
-          <p:nvPr/>
-        </p:nvSpPr>
-        <p:spPr>
-          <a:xfrm>
-            <a:off x="1097280" y="2487168"/>
-            <a:ext cx="3886200" cy="457200"/>
+          <p:cNvPr id="7" name="Text 5"/>
+          <p:cNvSpPr txBox="1"/>
+          <p:nvPr/>
+        </p:nvSpPr>
+        <p:spPr>
+          <a:xfrm>
+            <a:off x="457200" y="2487168"/>
+            <a:ext cx="4526280" cy="457200"/>
           </a:xfrm>
           <a:prstGeom prst="rect">
             <a:avLst/>
@@ -4576,40 +4336,16 @@
           </a:p>
         </p:txBody>
       </p:sp>
-      <p:pic>
-        <p:nvPicPr>
-          <p:cNvPr id="10" name="comp-2-icon" descr="preencoded.png">    </p:cNvPr>
-          <p:cNvPicPr>
-            <a:picLocks noChangeAspect="1"/>
-          </p:cNvPicPr>
-          <p:nvPr/>
-        </p:nvPicPr>
-        <p:blipFill>
-          <a:blip r:embed="rId3"/>
-          <a:stretch>
-            <a:fillRect/>
-          </a:stretch>
-        </p:blipFill>
-        <p:spPr>
-          <a:xfrm>
-            <a:off x="502920" y="3081528"/>
-            <a:ext cx="365760" cy="365760"/>
-          </a:xfrm>
-          <a:prstGeom prst="rect">
-            <a:avLst/>
-          </a:prstGeom>
-        </p:spPr>
-      </p:pic>
-      <p:sp>
-        <p:nvSpPr>
-          <p:cNvPr id="11" name="Text 6"/>
-          <p:cNvSpPr txBox="1"/>
-          <p:nvPr/>
-        </p:nvSpPr>
-        <p:spPr>
-          <a:xfrm>
-            <a:off x="1097280" y="3026664"/>
-            <a:ext cx="3840480" cy="274320"/>
+      <p:sp>
+        <p:nvSpPr>
+          <p:cNvPr id="8" name="Text 6"/>
+          <p:cNvSpPr txBox="1"/>
+          <p:nvPr/>
+        </p:nvSpPr>
+        <p:spPr>
+          <a:xfrm>
+            <a:off x="457200" y="3026664"/>
+            <a:ext cx="4480560" cy="274320"/>
           </a:xfrm>
           <a:prstGeom prst="rect">
             <a:avLst/>
@@ -4638,14 +4374,14 @@
       </p:sp>
       <p:sp>
         <p:nvSpPr>
-          <p:cNvPr id="12" name="Text 7"/>
-          <p:cNvSpPr txBox="1"/>
-          <p:nvPr/>
-        </p:nvSpPr>
-        <p:spPr>
-          <a:xfrm>
-            <a:off x="1097280" y="3310128"/>
-            <a:ext cx="3886200" cy="457200"/>
+          <p:cNvPr id="9" name="Text 7"/>
+          <p:cNvSpPr txBox="1"/>
+          <p:nvPr/>
+        </p:nvSpPr>
+        <p:spPr>
+          <a:xfrm>
+            <a:off x="457200" y="3310128"/>
+            <a:ext cx="4526280" cy="457200"/>
           </a:xfrm>
           <a:prstGeom prst="rect">
             <a:avLst/>
@@ -4672,40 +4408,16 @@
           </a:p>
         </p:txBody>
       </p:sp>
-      <p:pic>
-        <p:nvPicPr>
-          <p:cNvPr id="13" name="comp-3-icon" descr="preencoded.png">    </p:cNvPr>
-          <p:cNvPicPr>
-            <a:picLocks noChangeAspect="1"/>
-          </p:cNvPicPr>
-          <p:nvPr/>
-        </p:nvPicPr>
-        <p:blipFill>
-          <a:blip r:embed="rId4"/>
-          <a:stretch>
-            <a:fillRect/>
-          </a:stretch>
-        </p:blipFill>
-        <p:spPr>
-          <a:xfrm>
-            <a:off x="502920" y="3904488"/>
-            <a:ext cx="365760" cy="365760"/>
-          </a:xfrm>
-          <a:prstGeom prst="rect">
-            <a:avLst/>
-          </a:prstGeom>
-        </p:spPr>
-      </p:pic>
-      <p:sp>
-        <p:nvSpPr>
-          <p:cNvPr id="14" name="Text 8"/>
-          <p:cNvSpPr txBox="1"/>
-          <p:nvPr/>
-        </p:nvSpPr>
-        <p:spPr>
-          <a:xfrm>
-            <a:off x="1097280" y="3849624"/>
-            <a:ext cx="3840480" cy="274320"/>
+      <p:sp>
+        <p:nvSpPr>
+          <p:cNvPr id="10" name="Text 8"/>
+          <p:cNvSpPr txBox="1"/>
+          <p:nvPr/>
+        </p:nvSpPr>
+        <p:spPr>
+          <a:xfrm>
+            <a:off x="457200" y="3849624"/>
+            <a:ext cx="4480560" cy="274320"/>
           </a:xfrm>
           <a:prstGeom prst="rect">
             <a:avLst/>
@@ -4734,14 +4446,14 @@
       </p:sp>
       <p:sp>
         <p:nvSpPr>
-          <p:cNvPr id="15" name="Text 9"/>
-          <p:cNvSpPr txBox="1"/>
-          <p:nvPr/>
-        </p:nvSpPr>
-        <p:spPr>
-          <a:xfrm>
-            <a:off x="1097280" y="4133088"/>
-            <a:ext cx="3886200" cy="457200"/>
+          <p:cNvPr id="11" name="Text 9"/>
+          <p:cNvSpPr txBox="1"/>
+          <p:nvPr/>
+        </p:nvSpPr>
+        <p:spPr>
+          <a:xfrm>
+            <a:off x="457200" y="4133088"/>
+            <a:ext cx="4526280" cy="457200"/>
           </a:xfrm>
           <a:prstGeom prst="rect">
             <a:avLst/>
@@ -4770,7 +4482,7 @@
       </p:sp>
       <p:sp>
         <p:nvSpPr>
-          <p:cNvPr id="16" name="next-decor"/>
+          <p:cNvPr id="12" name="next-decor"/>
           <p:cNvSpPr/>
           <p:nvPr/>
         </p:nvSpPr>
@@ -4792,7 +4504,7 @@
       </p:sp>
       <p:sp>
         <p:nvSpPr>
-          <p:cNvPr id="17" name="next-rule"/>
+          <p:cNvPr id="13" name="next-rule"/>
           <p:cNvSpPr/>
           <p:nvPr/>
         </p:nvSpPr>
@@ -4815,7 +4527,7 @@
       </p:sp>
       <p:sp>
         <p:nvSpPr>
-          <p:cNvPr id="18" name="Text 12"/>
+          <p:cNvPr id="14" name="Text 12"/>
           <p:cNvSpPr txBox="1"/>
           <p:nvPr/>
         </p:nvSpPr>
@@ -4851,7 +4563,7 @@
       </p:sp>
       <p:sp>
         <p:nvSpPr>
-          <p:cNvPr id="19" name="stat"/>
+          <p:cNvPr id="15" name="stat"/>
           <p:cNvSpPr txBox="1"/>
           <p:nvPr/>
         </p:nvSpPr>
@@ -4887,7 +4599,7 @@
       </p:sp>
       <p:sp>
         <p:nvSpPr>
-          <p:cNvPr id="20" name="Text 14"/>
+          <p:cNvPr id="16" name="Text 14"/>
           <p:cNvSpPr txBox="1"/>
           <p:nvPr/>
         </p:nvSpPr>
@@ -4923,7 +4635,7 @@
       </p:sp>
       <p:sp>
         <p:nvSpPr>
-          <p:cNvPr id="21" name="Text 15"/>
+          <p:cNvPr id="17" name="Text 15"/>
           <p:cNvSpPr txBox="1"/>
           <p:nvPr/>
         </p:nvSpPr>
@@ -4981,7 +4693,7 @@
       </p:sp>
       <p:sp>
         <p:nvSpPr>
-          <p:cNvPr id="22" name="neonate-decor"/>
+          <p:cNvPr id="18" name="neonate-decor"/>
           <p:cNvSpPr/>
           <p:nvPr/>
         </p:nvSpPr>
@@ -5003,7 +4715,7 @@
       </p:sp>
       <p:sp>
         <p:nvSpPr>
-          <p:cNvPr id="23" name="neonate-rule"/>
+          <p:cNvPr id="19" name="neonate-rule"/>
           <p:cNvSpPr/>
           <p:nvPr/>
         </p:nvSpPr>
@@ -5024,40 +4736,16 @@
           </a:ln>
         </p:spPr>
       </p:sp>
-      <p:pic>
-        <p:nvPicPr>
-          <p:cNvPr id="24" name="neonate-icon" descr="preencoded.png">    </p:cNvPr>
-          <p:cNvPicPr>
-            <a:picLocks noChangeAspect="1"/>
-          </p:cNvPicPr>
-          <p:nvPr/>
-        </p:nvPicPr>
-        <p:blipFill>
-          <a:blip r:embed="rId5"/>
-          <a:stretch>
-            <a:fillRect/>
-          </a:stretch>
-        </p:blipFill>
-        <p:spPr>
-          <a:xfrm>
-            <a:off x="5303520" y="3602736"/>
-            <a:ext cx="329184" cy="329184"/>
-          </a:xfrm>
-          <a:prstGeom prst="rect">
-            <a:avLst/>
-          </a:prstGeom>
-        </p:spPr>
-      </p:pic>
-      <p:sp>
-        <p:nvSpPr>
-          <p:cNvPr id="25" name="Text 18"/>
-          <p:cNvSpPr txBox="1"/>
-          <p:nvPr/>
-        </p:nvSpPr>
-        <p:spPr>
-          <a:xfrm>
-            <a:off x="5760720" y="3566160"/>
-            <a:ext cx="2926080" cy="402336"/>
+      <p:sp>
+        <p:nvSpPr>
+          <p:cNvPr id="20" name="Text 18"/>
+          <p:cNvSpPr txBox="1"/>
+          <p:nvPr/>
+        </p:nvSpPr>
+        <p:spPr>
+          <a:xfrm>
+            <a:off x="5303520" y="3566160"/>
+            <a:ext cx="3383280" cy="402336"/>
           </a:xfrm>
           <a:prstGeom prst="rect">
             <a:avLst/>
@@ -5086,7 +4774,7 @@
       </p:sp>
       <p:sp>
         <p:nvSpPr>
-          <p:cNvPr id="26" name="Text 19"/>
+          <p:cNvPr id="21" name="Text 19"/>
           <p:cNvSpPr txBox="1"/>
           <p:nvPr/>
         </p:nvSpPr>
@@ -5122,7 +4810,7 @@
       </p:sp>
       <p:sp>
         <p:nvSpPr>
-          <p:cNvPr id="27" name="source"/>
+          <p:cNvPr id="22" name="source"/>
           <p:cNvSpPr txBox="1"/>
           <p:nvPr/>
         </p:nvSpPr>
@@ -5264,40 +4952,16 @@
           </a:p>
         </p:txBody>
       </p:sp>
-      <p:pic>
-        <p:nvPicPr>
-          <p:cNvPr id="3" name="fetal-banner-icon" descr="preencoded.png">    </p:cNvPr>
-          <p:cNvPicPr>
-            <a:picLocks noChangeAspect="1"/>
-          </p:cNvPicPr>
-          <p:nvPr/>
-        </p:nvPicPr>
-        <p:blipFill>
-          <a:blip r:embed="rId1"/>
-          <a:stretch>
-            <a:fillRect/>
-          </a:stretch>
-        </p:blipFill>
-        <p:spPr>
-          <a:xfrm>
-            <a:off x="457200" y="1051560"/>
-            <a:ext cx="411480" cy="411480"/>
-          </a:xfrm>
-          <a:prstGeom prst="rect">
-            <a:avLst/>
-          </a:prstGeom>
-        </p:spPr>
-      </p:pic>
-      <p:sp>
-        <p:nvSpPr>
-          <p:cNvPr id="4" name="Text 1"/>
-          <p:cNvSpPr txBox="1"/>
-          <p:nvPr/>
-        </p:nvSpPr>
-        <p:spPr>
-          <a:xfrm>
-            <a:off x="1005840" y="941832"/>
-            <a:ext cx="7680960" cy="658368"/>
+      <p:sp>
+        <p:nvSpPr>
+          <p:cNvPr id="3" name="Text 1"/>
+          <p:cNvSpPr txBox="1"/>
+          <p:nvPr/>
+        </p:nvSpPr>
+        <p:spPr>
+          <a:xfrm>
+            <a:off x="457200" y="941832"/>
+            <a:ext cx="8229600" cy="658368"/>
           </a:xfrm>
           <a:prstGeom prst="rect">
             <a:avLst/>
@@ -5340,7 +5004,7 @@
       </p:sp>
       <p:sp>
         <p:nvSpPr>
-          <p:cNvPr id="5" name="fetal-banner-rule"/>
+          <p:cNvPr id="4" name="fetal-banner-rule"/>
           <p:cNvSpPr/>
           <p:nvPr/>
         </p:nvSpPr>
@@ -5363,7 +5027,7 @@
       </p:sp>
       <p:sp>
         <p:nvSpPr>
-          <p:cNvPr id="6" name="fetal-0-decor"/>
+          <p:cNvPr id="5" name="fetal-0-decor"/>
           <p:cNvSpPr/>
           <p:nvPr/>
         </p:nvSpPr>
@@ -5385,7 +5049,7 @@
       </p:sp>
       <p:sp>
         <p:nvSpPr>
-          <p:cNvPr id="7" name="fetal-0-rule"/>
+          <p:cNvPr id="6" name="fetal-0-rule"/>
           <p:cNvSpPr/>
           <p:nvPr/>
         </p:nvSpPr>
@@ -5406,40 +5070,16 @@
           </a:ln>
         </p:spPr>
       </p:sp>
-      <p:pic>
-        <p:nvPicPr>
-          <p:cNvPr id="8" name="fetal-0-icon" descr="preencoded.png">    </p:cNvPr>
-          <p:cNvPicPr>
-            <a:picLocks noChangeAspect="1"/>
-          </p:cNvPicPr>
-          <p:nvPr/>
-        </p:nvPicPr>
-        <p:blipFill>
-          <a:blip r:embed="rId2"/>
-          <a:stretch>
-            <a:fillRect/>
-          </a:stretch>
-        </p:blipFill>
-        <p:spPr>
-          <a:xfrm>
-            <a:off x="457200" y="1920240"/>
-            <a:ext cx="365760" cy="365760"/>
-          </a:xfrm>
-          <a:prstGeom prst="rect">
-            <a:avLst/>
-          </a:prstGeom>
-        </p:spPr>
-      </p:pic>
-      <p:sp>
-        <p:nvSpPr>
-          <p:cNvPr id="9" name="Text 5"/>
-          <p:cNvSpPr txBox="1"/>
-          <p:nvPr/>
-        </p:nvSpPr>
-        <p:spPr>
-          <a:xfrm>
-            <a:off x="932688" y="1874520"/>
-            <a:ext cx="2084832" cy="457200"/>
+      <p:sp>
+        <p:nvSpPr>
+          <p:cNvPr id="7" name="Text 5"/>
+          <p:cNvSpPr txBox="1"/>
+          <p:nvPr/>
+        </p:nvSpPr>
+        <p:spPr>
+          <a:xfrm>
+            <a:off x="457200" y="1874520"/>
+            <a:ext cx="2560320" cy="457200"/>
           </a:xfrm>
           <a:prstGeom prst="rect">
             <a:avLst/>
@@ -5468,7 +5108,7 @@
       </p:sp>
       <p:sp>
         <p:nvSpPr>
-          <p:cNvPr id="10" name="Text 6"/>
+          <p:cNvPr id="8" name="Text 6"/>
           <p:cNvSpPr txBox="1"/>
           <p:nvPr/>
         </p:nvSpPr>
@@ -5544,7 +5184,7 @@
       </p:sp>
       <p:sp>
         <p:nvSpPr>
-          <p:cNvPr id="11" name="fetal-1-decor"/>
+          <p:cNvPr id="9" name="fetal-1-decor"/>
           <p:cNvSpPr/>
           <p:nvPr/>
         </p:nvSpPr>
@@ -5566,7 +5206,7 @@
       </p:sp>
       <p:sp>
         <p:nvSpPr>
-          <p:cNvPr id="12" name="fetal-1-rule"/>
+          <p:cNvPr id="10" name="fetal-1-rule"/>
           <p:cNvSpPr/>
           <p:nvPr/>
         </p:nvSpPr>
@@ -5587,40 +5227,16 @@
           </a:ln>
         </p:spPr>
       </p:sp>
-      <p:pic>
-        <p:nvPicPr>
-          <p:cNvPr id="13" name="fetal-1-icon" descr="preencoded.png">    </p:cNvPr>
-          <p:cNvPicPr>
-            <a:picLocks noChangeAspect="1"/>
-          </p:cNvPicPr>
-          <p:nvPr/>
-        </p:nvPicPr>
-        <p:blipFill>
-          <a:blip r:embed="rId3"/>
-          <a:stretch>
-            <a:fillRect/>
-          </a:stretch>
-        </p:blipFill>
-        <p:spPr>
-          <a:xfrm>
-            <a:off x="3291840" y="1920240"/>
-            <a:ext cx="365760" cy="365760"/>
-          </a:xfrm>
-          <a:prstGeom prst="rect">
-            <a:avLst/>
-          </a:prstGeom>
-        </p:spPr>
-      </p:pic>
-      <p:sp>
-        <p:nvSpPr>
-          <p:cNvPr id="14" name="Text 9"/>
-          <p:cNvSpPr txBox="1"/>
-          <p:nvPr/>
-        </p:nvSpPr>
-        <p:spPr>
-          <a:xfrm>
-            <a:off x="3767328" y="1874520"/>
-            <a:ext cx="2084832" cy="457200"/>
+      <p:sp>
+        <p:nvSpPr>
+          <p:cNvPr id="11" name="Text 9"/>
+          <p:cNvSpPr txBox="1"/>
+          <p:nvPr/>
+        </p:nvSpPr>
+        <p:spPr>
+          <a:xfrm>
+            <a:off x="3291840" y="1874520"/>
+            <a:ext cx="2560320" cy="457200"/>
           </a:xfrm>
           <a:prstGeom prst="rect">
             <a:avLst/>
@@ -5649,7 +5265,7 @@
       </p:sp>
       <p:sp>
         <p:nvSpPr>
-          <p:cNvPr id="15" name="Text 10"/>
+          <p:cNvPr id="12" name="Text 10"/>
           <p:cNvSpPr txBox="1"/>
           <p:nvPr/>
         </p:nvSpPr>
@@ -5725,7 +5341,7 @@
       </p:sp>
       <p:sp>
         <p:nvSpPr>
-          <p:cNvPr id="16" name="fetal-2-decor"/>
+          <p:cNvPr id="13" name="fetal-2-decor"/>
           <p:cNvSpPr/>
           <p:nvPr/>
         </p:nvSpPr>
@@ -5747,7 +5363,7 @@
       </p:sp>
       <p:sp>
         <p:nvSpPr>
-          <p:cNvPr id="17" name="fetal-2-rule"/>
+          <p:cNvPr id="14" name="fetal-2-rule"/>
           <p:cNvSpPr/>
           <p:nvPr/>
         </p:nvSpPr>
@@ -5768,40 +5384,16 @@
           </a:ln>
         </p:spPr>
       </p:sp>
-      <p:pic>
-        <p:nvPicPr>
-          <p:cNvPr id="18" name="fetal-2-icon" descr="preencoded.png">    </p:cNvPr>
-          <p:cNvPicPr>
-            <a:picLocks noChangeAspect="1"/>
-          </p:cNvPicPr>
-          <p:nvPr/>
-        </p:nvPicPr>
-        <p:blipFill>
-          <a:blip r:embed="rId4"/>
-          <a:stretch>
-            <a:fillRect/>
-          </a:stretch>
-        </p:blipFill>
-        <p:spPr>
-          <a:xfrm>
-            <a:off x="6126480" y="1920240"/>
-            <a:ext cx="365760" cy="365760"/>
-          </a:xfrm>
-          <a:prstGeom prst="rect">
-            <a:avLst/>
-          </a:prstGeom>
-        </p:spPr>
-      </p:pic>
-      <p:sp>
-        <p:nvSpPr>
-          <p:cNvPr id="19" name="Text 13"/>
-          <p:cNvSpPr txBox="1"/>
-          <p:nvPr/>
-        </p:nvSpPr>
-        <p:spPr>
-          <a:xfrm>
-            <a:off x="6601968" y="1874520"/>
-            <a:ext cx="2084832" cy="457200"/>
+      <p:sp>
+        <p:nvSpPr>
+          <p:cNvPr id="15" name="Text 13"/>
+          <p:cNvSpPr txBox="1"/>
+          <p:nvPr/>
+        </p:nvSpPr>
+        <p:spPr>
+          <a:xfrm>
+            <a:off x="6126480" y="1874520"/>
+            <a:ext cx="2560320" cy="457200"/>
           </a:xfrm>
           <a:prstGeom prst="rect">
             <a:avLst/>
@@ -5830,7 +5422,7 @@
       </p:sp>
       <p:sp>
         <p:nvSpPr>
-          <p:cNvPr id="20" name="Text 14"/>
+          <p:cNvPr id="16" name="Text 14"/>
           <p:cNvSpPr txBox="1"/>
           <p:nvPr/>
         </p:nvSpPr>
@@ -5888,7 +5480,7 @@
       </p:sp>
       <p:sp>
         <p:nvSpPr>
-          <p:cNvPr id="21" name="Text 15"/>
+          <p:cNvPr id="17" name="Text 15"/>
           <p:cNvSpPr txBox="1"/>
           <p:nvPr/>
         </p:nvSpPr>
@@ -5935,7 +5527,7 @@
       </p:sp>
       <p:sp>
         <p:nvSpPr>
-          <p:cNvPr id="22" name="source"/>
+          <p:cNvPr id="18" name="source"/>
           <p:cNvSpPr txBox="1"/>
           <p:nvPr/>
         </p:nvSpPr>

</xml_diff>

<commit_message>
Add shape-based diagrams to cesarean slides 1, 3, 4, 5
Co-Authored-By: Claude Opus 5.5 <noreply@anthropic.com>
Claude-Session: https://claude.ai/code/session_017AawXZuegeVsAfmgt6D2q5
</commit_message>
<xml_diff>
--- a/slides/⑤帝王切開.pptx
+++ b/slides/⑤帝王切開.pptx
@@ -111,7 +111,7 @@
   <p:extLst>
     <p:ext uri="{521415D9-36F7-43E2-AB2F-B90AF26B5E84}">
       <p14:sectionLst xmlns:p14="http://schemas.microsoft.com/office/powerpoint/2010/main">
-        <p14:section name="⑤ 帝王切開" id="{f4ef19ac-ab88-4234-e32f-2ad6a38099fc}">
+        <p14:section name="⑤ 帝王切開" id="{eba56d53-10e0-4721-bb42-8b4229815822}">
           <p14:sldIdLst>
             <p14:sldId id="256"/>
             <p14:sldId id="257"/>
@@ -708,7 +708,7 @@
             <a:r>
               <a:rPr lang="en-US" dirty="0"/>
               <a:t>手術の流れです。多くは脊髄くも膜下麻酔（下半身の麻酔）で行うため、お母さんは意識があり、生まれた直後の赤ちゃんの声を聞くことができます。一刻を争う超緊急の場合などは全身麻酔を選びますが、誤嚥や挿管困難、麻酔薬が胎盤を通って赤ちゃんが眠った状態で生まれる（sleeping baby）ことに注意が必要です。
-皮膚は下腹部の横切開（Pfannenstiel切開）が一般的で、急ぐ時や広い視野が必要な時は縦切開を選びます。子宮は子宮下部の横切開が標準で、縦切開に比べて次回妊娠時の子宮破裂が起こりにくいのが利点です。
+皮膚は下腹部の横切開（Pfannenstiel切開）が一般的で、急ぐ時や広い視野が必要な時は縦切開を選びます。子宮は子宮下部の横切開が標準で、縦切開に比べて次回妊娠時の子宮破裂が起こりにくいのが利点です。子宮体部を縦に切る古典的縦切開は、子宮下部が十分に伸びていない早産や横位などで選ばれますが、次回の子宮破裂のリスクが高くなります。
 執刀から赤ちゃんが出るまでは約5〜10分、その後胎盤を出し、子宮収縮薬で出血を抑えながら縫合して、手術全体ではおよそ1時間です。</a:t>
             </a:r>
             <a:endParaRPr lang="en-US" dirty="0"/>
@@ -889,7 +889,7 @@
             <a:r>
               <a:rPr lang="en-US" dirty="0"/>
               <a:t>最後に、今回の2症例のように胎児に先天性疾患がある場合の分娩についてです。
-胎児に病気があるからといって、必ず帝王切開になるわけではありません。分娩方法は基本的に通常の妊娠と同じく産科的な適応で決めます。大切なのは、出生直後から治療を始められるNICU・小児外科・小児循環器などがそろった周産期センターで、日時を決めて産む『計画分娩』です。
+胎児に病気があるからといって、必ず帝王切開になるわけではありません。分娩方法は基本的に通常の妊娠と同じく産科的な適応で決めます。大切なのは『どこで・いつ産むか』で、胎児診断がついたら、出生直後から治療を始められるNICU・小児外科・小児循環器などがそろった周産期センターへ紹介し、日時を決めて産む『計画分娩』とします（上の流れ）。
 横隔膜ヘルニアでは、生まれてすぐに挿管・人工呼吸管理が必要になるため、スタッフをそろえて計画分娩とし、施設によっては予定帝王切開を選びます。
 肺動脈閉鎖・VSDのような動脈管依存性の心疾患では、動脈管が閉じると状態が悪化するため、出生後すぐにプロスタグランジンE1製剤で動脈管を開いたままにします。
 十二指腸閉鎖では羊水過多になりやすく、早産や逆子、破水した時の臍帯脱出・胎盤早期剝離、産後の弛緩出血などに注意が必要で、結果として帝王切開になることもあります（⑥⑦⑧につなげる）。
@@ -1467,7 +1467,7 @@
         </p:nvSpPr>
         <p:spPr>
           <a:xfrm>
-            <a:off x="2331720" y="3611880"/>
+            <a:off x="2331720" y="1051560"/>
             <a:ext cx="822960" cy="822960"/>
           </a:xfrm>
           <a:prstGeom prst="ellipse">
@@ -1584,7 +1584,279 @@
         </p:nvSpPr>
         <p:spPr>
           <a:xfrm>
-            <a:off x="457200" y="2148840"/>
+            <a:off x="457200" y="2103120"/>
+            <a:ext cx="2651760" cy="502920"/>
+          </a:xfrm>
+          <a:prstGeom prst="rect">
+            <a:avLst/>
+          </a:prstGeom>
+          <a:noFill/>
+          <a:ln/>
+        </p:spPr>
+        <p:txBody>
+          <a:bodyPr wrap="square" lIns="0" tIns="0" rIns="0" bIns="0" rtlCol="0" anchor="ctr"/>
+          <a:lstStyle/>
+          <a:p>
+            <a:pPr indent="0" marL="0">
+              <a:buNone/>
+            </a:pPr>
+            <a:r>
+              <a:rPr lang="en-US" sz="3000" b="1" dirty="0">
+                <a:solidFill>
+                  <a:schemeClr val="tx2"/>
+                </a:solidFill>
+              </a:rPr>
+              <a:t>約5人に1人</a:t>
+            </a:r>
+            <a:endParaRPr lang="en-US" sz="3000" dirty="0"/>
+          </a:p>
+        </p:txBody>
+      </p:sp>
+      <p:sp>
+        <p:nvSpPr>
+          <p:cNvPr id="8" name="pict-0-head"/>
+          <p:cNvSpPr/>
+          <p:nvPr/>
+        </p:nvSpPr>
+        <p:spPr>
+          <a:xfrm>
+            <a:off x="530352" y="2679192"/>
+            <a:ext cx="155448" cy="155448"/>
+          </a:xfrm>
+          <a:prstGeom prst="ellipse">
+            <a:avLst/>
+          </a:prstGeom>
+          <a:solidFill>
+            <a:schemeClr val="tx2"/>
+          </a:solidFill>
+          <a:ln/>
+        </p:spPr>
+      </p:sp>
+      <p:sp>
+        <p:nvSpPr>
+          <p:cNvPr id="9" name="pict-0-body"/>
+          <p:cNvSpPr/>
+          <p:nvPr/>
+        </p:nvSpPr>
+        <p:spPr>
+          <a:xfrm>
+            <a:off x="475488" y="2862072"/>
+            <a:ext cx="265176" cy="265176"/>
+          </a:xfrm>
+          <a:prstGeom prst="round2SameRect">
+            <a:avLst/>
+          </a:prstGeom>
+          <a:solidFill>
+            <a:schemeClr val="tx2"/>
+          </a:solidFill>
+          <a:ln/>
+        </p:spPr>
+      </p:sp>
+      <p:sp>
+        <p:nvSpPr>
+          <p:cNvPr id="10" name="pict-1-head"/>
+          <p:cNvSpPr/>
+          <p:nvPr/>
+        </p:nvSpPr>
+        <p:spPr>
+          <a:xfrm>
+            <a:off x="941832" y="2679192"/>
+            <a:ext cx="155448" cy="155448"/>
+          </a:xfrm>
+          <a:prstGeom prst="ellipse">
+            <a:avLst/>
+          </a:prstGeom>
+          <a:solidFill>
+            <a:srgbClr val="A6A6A6"/>
+          </a:solidFill>
+          <a:ln/>
+        </p:spPr>
+      </p:sp>
+      <p:sp>
+        <p:nvSpPr>
+          <p:cNvPr id="11" name="pict-1-body"/>
+          <p:cNvSpPr/>
+          <p:nvPr/>
+        </p:nvSpPr>
+        <p:spPr>
+          <a:xfrm>
+            <a:off x="886968" y="2862072"/>
+            <a:ext cx="265176" cy="265176"/>
+          </a:xfrm>
+          <a:prstGeom prst="round2SameRect">
+            <a:avLst/>
+          </a:prstGeom>
+          <a:solidFill>
+            <a:srgbClr val="A6A6A6"/>
+          </a:solidFill>
+          <a:ln/>
+        </p:spPr>
+      </p:sp>
+      <p:sp>
+        <p:nvSpPr>
+          <p:cNvPr id="12" name="pict-2-head"/>
+          <p:cNvSpPr/>
+          <p:nvPr/>
+        </p:nvSpPr>
+        <p:spPr>
+          <a:xfrm>
+            <a:off x="1353312" y="2679192"/>
+            <a:ext cx="155448" cy="155448"/>
+          </a:xfrm>
+          <a:prstGeom prst="ellipse">
+            <a:avLst/>
+          </a:prstGeom>
+          <a:solidFill>
+            <a:srgbClr val="A6A6A6"/>
+          </a:solidFill>
+          <a:ln/>
+        </p:spPr>
+      </p:sp>
+      <p:sp>
+        <p:nvSpPr>
+          <p:cNvPr id="13" name="pict-2-body"/>
+          <p:cNvSpPr/>
+          <p:nvPr/>
+        </p:nvSpPr>
+        <p:spPr>
+          <a:xfrm>
+            <a:off x="1298448" y="2862072"/>
+            <a:ext cx="265176" cy="265176"/>
+          </a:xfrm>
+          <a:prstGeom prst="round2SameRect">
+            <a:avLst/>
+          </a:prstGeom>
+          <a:solidFill>
+            <a:srgbClr val="A6A6A6"/>
+          </a:solidFill>
+          <a:ln/>
+        </p:spPr>
+      </p:sp>
+      <p:sp>
+        <p:nvSpPr>
+          <p:cNvPr id="14" name="pict-3-head"/>
+          <p:cNvSpPr/>
+          <p:nvPr/>
+        </p:nvSpPr>
+        <p:spPr>
+          <a:xfrm>
+            <a:off x="1764792" y="2679192"/>
+            <a:ext cx="155448" cy="155448"/>
+          </a:xfrm>
+          <a:prstGeom prst="ellipse">
+            <a:avLst/>
+          </a:prstGeom>
+          <a:solidFill>
+            <a:srgbClr val="A6A6A6"/>
+          </a:solidFill>
+          <a:ln/>
+        </p:spPr>
+      </p:sp>
+      <p:sp>
+        <p:nvSpPr>
+          <p:cNvPr id="15" name="pict-3-body"/>
+          <p:cNvSpPr/>
+          <p:nvPr/>
+        </p:nvSpPr>
+        <p:spPr>
+          <a:xfrm>
+            <a:off x="1709928" y="2862072"/>
+            <a:ext cx="265176" cy="265176"/>
+          </a:xfrm>
+          <a:prstGeom prst="round2SameRect">
+            <a:avLst/>
+          </a:prstGeom>
+          <a:solidFill>
+            <a:srgbClr val="A6A6A6"/>
+          </a:solidFill>
+          <a:ln/>
+        </p:spPr>
+      </p:sp>
+      <p:sp>
+        <p:nvSpPr>
+          <p:cNvPr id="16" name="pict-4-head"/>
+          <p:cNvSpPr/>
+          <p:nvPr/>
+        </p:nvSpPr>
+        <p:spPr>
+          <a:xfrm>
+            <a:off x="2176272" y="2679192"/>
+            <a:ext cx="155448" cy="155448"/>
+          </a:xfrm>
+          <a:prstGeom prst="ellipse">
+            <a:avLst/>
+          </a:prstGeom>
+          <a:solidFill>
+            <a:srgbClr val="A6A6A6"/>
+          </a:solidFill>
+          <a:ln/>
+        </p:spPr>
+      </p:sp>
+      <p:sp>
+        <p:nvSpPr>
+          <p:cNvPr id="17" name="pict-4-body"/>
+          <p:cNvSpPr/>
+          <p:nvPr/>
+        </p:nvSpPr>
+        <p:spPr>
+          <a:xfrm>
+            <a:off x="2121408" y="2862072"/>
+            <a:ext cx="265176" cy="265176"/>
+          </a:xfrm>
+          <a:prstGeom prst="round2SameRect">
+            <a:avLst/>
+          </a:prstGeom>
+          <a:solidFill>
+            <a:srgbClr val="A6A6A6"/>
+          </a:solidFill>
+          <a:ln/>
+        </p:spPr>
+      </p:sp>
+      <p:sp>
+        <p:nvSpPr>
+          <p:cNvPr id="18" name="Text 16"/>
+          <p:cNvSpPr txBox="1"/>
+          <p:nvPr/>
+        </p:nvSpPr>
+        <p:spPr>
+          <a:xfrm>
+            <a:off x="457200" y="3218688"/>
+            <a:ext cx="2651760" cy="457200"/>
+          </a:xfrm>
+          <a:prstGeom prst="rect">
+            <a:avLst/>
+          </a:prstGeom>
+          <a:noFill/>
+          <a:ln/>
+        </p:spPr>
+        <p:txBody>
+          <a:bodyPr wrap="square" lIns="0" tIns="0" rIns="0" bIns="0" rtlCol="0" anchor="t"/>
+          <a:lstStyle/>
+          <a:p>
+            <a:pPr indent="0" marL="0">
+              <a:buNone/>
+            </a:pPr>
+            <a:r>
+              <a:rPr lang="en-US" sz="1200" dirty="0">
+                <a:solidFill>
+                  <a:schemeClr val="tx1"/>
+                </a:solidFill>
+              </a:rPr>
+              <a:t>日本のお産のうち帝王切開で生まれる割合（約20%）。年々増加している</a:t>
+            </a:r>
+            <a:endParaRPr lang="en-US" sz="1200" dirty="0"/>
+          </a:p>
+        </p:txBody>
+      </p:sp>
+      <p:sp>
+        <p:nvSpPr>
+          <p:cNvPr id="19" name="Text 17"/>
+          <p:cNvSpPr txBox="1"/>
+          <p:nvPr/>
+        </p:nvSpPr>
+        <p:spPr>
+          <a:xfrm>
+            <a:off x="457200" y="3767328"/>
             <a:ext cx="2651760" cy="548640"/>
           </a:xfrm>
           <a:prstGeom prst="rect">
@@ -1594,119 +1866,47 @@
           <a:ln/>
         </p:spPr>
         <p:txBody>
-          <a:bodyPr wrap="square" lIns="0" tIns="0" rIns="0" bIns="0" rtlCol="0" anchor="ctr"/>
+          <a:bodyPr wrap="square" lIns="0" tIns="0" rIns="0" bIns="0" rtlCol="0" anchor="t"/>
           <a:lstStyle/>
           <a:p>
             <a:pPr indent="0" marL="0">
               <a:buNone/>
             </a:pPr>
             <a:r>
-              <a:rPr lang="en-US" sz="3000" b="1" dirty="0">
-                <a:solidFill>
-                  <a:schemeClr val="tx2"/>
-                </a:solidFill>
-              </a:rPr>
-              <a:t>約5人に1人</a:t>
-            </a:r>
-            <a:endParaRPr lang="en-US" sz="3000" dirty="0"/>
-          </a:p>
-        </p:txBody>
-      </p:sp>
-      <p:sp>
-        <p:nvSpPr>
-          <p:cNvPr id="8" name="Text 6"/>
-          <p:cNvSpPr txBox="1"/>
-          <p:nvPr/>
-        </p:nvSpPr>
-        <p:spPr>
-          <a:xfrm>
-            <a:off x="457200" y="2743200"/>
-            <a:ext cx="2651760" cy="685800"/>
-          </a:xfrm>
-          <a:prstGeom prst="rect">
-            <a:avLst/>
-          </a:prstGeom>
-          <a:noFill/>
-          <a:ln/>
-        </p:spPr>
-        <p:txBody>
-          <a:bodyPr wrap="square" lIns="0" tIns="0" rIns="0" bIns="0" rtlCol="0" anchor="t"/>
-          <a:lstStyle/>
+              <a:rPr lang="en-US" sz="1300" dirty="0">
+                <a:solidFill>
+                  <a:schemeClr val="accent5"/>
+                </a:solidFill>
+              </a:rPr>
+              <a:t>一般病院 約27%・診療所 約15%</a:t>
+            </a:r>
+            <a:endParaRPr lang="en-US" sz="1300" dirty="0"/>
+          </a:p>
           <a:p>
             <a:pPr indent="0" marL="0">
               <a:buNone/>
             </a:pPr>
             <a:r>
-              <a:rPr lang="en-US" sz="1200" dirty="0">
-                <a:solidFill>
-                  <a:schemeClr val="tx1"/>
-                </a:solidFill>
-              </a:rPr>
-              <a:t>日本のお産のうち帝王切開で生まれる割合（約20%）。年々増加している</a:t>
-            </a:r>
-            <a:endParaRPr lang="en-US" sz="1200" dirty="0"/>
-          </a:p>
-        </p:txBody>
-      </p:sp>
-      <p:sp>
-        <p:nvSpPr>
-          <p:cNvPr id="9" name="Text 7"/>
-          <p:cNvSpPr txBox="1"/>
-          <p:nvPr/>
-        </p:nvSpPr>
-        <p:spPr>
-          <a:xfrm>
-            <a:off x="457200" y="3520440"/>
-            <a:ext cx="2651760" cy="685800"/>
-          </a:xfrm>
-          <a:prstGeom prst="rect">
-            <a:avLst/>
-          </a:prstGeom>
-          <a:noFill/>
-          <a:ln/>
-        </p:spPr>
-        <p:txBody>
-          <a:bodyPr wrap="square" lIns="0" tIns="0" rIns="0" bIns="0" rtlCol="0" anchor="t"/>
-          <a:lstStyle/>
-          <a:p>
-            <a:pPr indent="0" marL="0">
-              <a:buNone/>
-            </a:pPr>
-            <a:r>
               <a:rPr lang="en-US" sz="1300" dirty="0">
                 <a:solidFill>
                   <a:schemeClr val="accent5"/>
                 </a:solidFill>
               </a:rPr>
-              <a:t>一般病院 約27%・診療所 約15%</a:t>
+              <a:t>（2020年 医療施設調査）</a:t>
             </a:r>
             <a:endParaRPr lang="en-US" sz="1300" dirty="0"/>
           </a:p>
-          <a:p>
-            <a:pPr indent="0" marL="0">
-              <a:buNone/>
-            </a:pPr>
-            <a:r>
-              <a:rPr lang="en-US" sz="1300" dirty="0">
-                <a:solidFill>
-                  <a:schemeClr val="accent5"/>
-                </a:solidFill>
-              </a:rPr>
-              <a:t>（2020年 医療施設調査）</a:t>
-            </a:r>
-            <a:endParaRPr lang="en-US" sz="1300" dirty="0"/>
-          </a:p>
-        </p:txBody>
-      </p:sp>
-      <p:sp>
-        <p:nvSpPr>
-          <p:cNvPr id="10" name="type-0-decor"/>
+        </p:txBody>
+      </p:sp>
+      <p:sp>
+        <p:nvSpPr>
+          <p:cNvPr id="20" name="type-0-decor"/>
           <p:cNvSpPr/>
           <p:nvPr/>
         </p:nvSpPr>
         <p:spPr>
           <a:xfrm>
-            <a:off x="7818120" y="1737360"/>
+            <a:off x="7818120" y="1051560"/>
             <a:ext cx="822960" cy="822960"/>
           </a:xfrm>
           <a:prstGeom prst="triangle">
@@ -1722,7 +1922,7 @@
       </p:sp>
       <p:sp>
         <p:nvSpPr>
-          <p:cNvPr id="11" name="type-0-rule"/>
+          <p:cNvPr id="21" name="type-0-rule"/>
           <p:cNvSpPr/>
           <p:nvPr/>
         </p:nvSpPr>
@@ -1745,7 +1945,7 @@
       </p:sp>
       <p:sp>
         <p:nvSpPr>
-          <p:cNvPr id="12" name="Text 10"/>
+          <p:cNvPr id="22" name="Text 20"/>
           <p:cNvSpPr txBox="1"/>
           <p:nvPr/>
         </p:nvSpPr>
@@ -1781,7 +1981,7 @@
       </p:sp>
       <p:sp>
         <p:nvSpPr>
-          <p:cNvPr id="13" name="Text 11"/>
+          <p:cNvPr id="23" name="Text 21"/>
           <p:cNvSpPr txBox="1"/>
           <p:nvPr/>
         </p:nvSpPr>
@@ -1857,13 +2057,13 @@
       </p:sp>
       <p:sp>
         <p:nvSpPr>
-          <p:cNvPr id="14" name="type-1-decor"/>
+          <p:cNvPr id="24" name="type-1-decor"/>
           <p:cNvSpPr/>
           <p:nvPr/>
         </p:nvSpPr>
         <p:spPr>
           <a:xfrm>
-            <a:off x="7818120" y="3611880"/>
+            <a:off x="7818120" y="2926080"/>
             <a:ext cx="822960" cy="822960"/>
           </a:xfrm>
           <a:prstGeom prst="rect">
@@ -1879,7 +2079,7 @@
       </p:sp>
       <p:sp>
         <p:nvSpPr>
-          <p:cNvPr id="15" name="type-1-rule"/>
+          <p:cNvPr id="25" name="type-1-rule"/>
           <p:cNvSpPr/>
           <p:nvPr/>
         </p:nvSpPr>
@@ -1902,7 +2102,7 @@
       </p:sp>
       <p:sp>
         <p:nvSpPr>
-          <p:cNvPr id="16" name="Text 14"/>
+          <p:cNvPr id="26" name="Text 24"/>
           <p:cNvSpPr txBox="1"/>
           <p:nvPr/>
         </p:nvSpPr>
@@ -1938,7 +2138,7 @@
       </p:sp>
       <p:sp>
         <p:nvSpPr>
-          <p:cNvPr id="17" name="Text 15"/>
+          <p:cNvPr id="27" name="Text 25"/>
           <p:cNvSpPr txBox="1"/>
           <p:nvPr/>
         </p:nvSpPr>
@@ -2014,7 +2214,7 @@
       </p:sp>
       <p:sp>
         <p:nvSpPr>
-          <p:cNvPr id="18" name="source"/>
+          <p:cNvPr id="28" name="source"/>
           <p:cNvSpPr txBox="1"/>
           <p:nvPr/>
         </p:nvSpPr>
@@ -2164,7 +2364,7 @@
         </p:nvSpPr>
         <p:spPr>
           <a:xfrm>
-            <a:off x="2148840" y="3017520"/>
+            <a:off x="2148840" y="1051560"/>
             <a:ext cx="822960" cy="822960"/>
           </a:xfrm>
           <a:prstGeom prst="ellipse">
@@ -2357,7 +2557,7 @@
         </p:nvSpPr>
         <p:spPr>
           <a:xfrm>
-            <a:off x="4983480" y="3017520"/>
+            <a:off x="4983480" y="1051560"/>
             <a:ext cx="822960" cy="822960"/>
           </a:xfrm>
           <a:prstGeom prst="triangle">
@@ -2550,7 +2750,7 @@
         </p:nvSpPr>
         <p:spPr>
           <a:xfrm>
-            <a:off x="7818120" y="3017520"/>
+            <a:off x="7818120" y="1051560"/>
             <a:ext cx="822960" cy="822960"/>
           </a:xfrm>
           <a:prstGeom prst="rect">
@@ -3696,7 +3896,7 @@
         </p:nvSpPr>
         <p:spPr>
           <a:xfrm>
-            <a:off x="3566160" y="3611880"/>
+            <a:off x="3566160" y="2560320"/>
             <a:ext cx="822960" cy="822960"/>
           </a:xfrm>
           <a:prstGeom prst="ellipse">
@@ -3718,7 +3918,7 @@
         </p:nvSpPr>
         <p:spPr>
           <a:xfrm>
-            <a:off x="457200" y="4526280"/>
+            <a:off x="457200" y="4572000"/>
             <a:ext cx="3977640" cy="0"/>
           </a:xfrm>
           <a:prstGeom prst="line">
@@ -3741,8 +3941,8 @@
         </p:nvSpPr>
         <p:spPr>
           <a:xfrm>
-            <a:off x="457200" y="2715768"/>
-            <a:ext cx="3886200" cy="420624"/>
+            <a:off x="457200" y="2532888"/>
+            <a:ext cx="3886200" cy="384048"/>
           </a:xfrm>
           <a:prstGeom prst="rect">
             <a:avLst/>
@@ -3777,8 +3977,8 @@
         </p:nvSpPr>
         <p:spPr>
           <a:xfrm>
-            <a:off x="457200" y="3246120"/>
-            <a:ext cx="3840480" cy="1188720"/>
+            <a:off x="457200" y="3017520"/>
+            <a:ext cx="3840480" cy="1371600"/>
           </a:xfrm>
           <a:prstGeom prst="rect">
             <a:avLst/>
@@ -3858,7 +4058,7 @@
         </p:nvSpPr>
         <p:spPr>
           <a:xfrm>
-            <a:off x="7818120" y="3611880"/>
+            <a:off x="7818120" y="2560320"/>
             <a:ext cx="822960" cy="822960"/>
           </a:xfrm>
           <a:prstGeom prst="triangle">
@@ -3880,7 +4080,7 @@
         </p:nvSpPr>
         <p:spPr>
           <a:xfrm>
-            <a:off x="4709160" y="4526280"/>
+            <a:off x="4709160" y="4572000"/>
             <a:ext cx="3977640" cy="0"/>
           </a:xfrm>
           <a:prstGeom prst="line">
@@ -3903,8 +4103,8 @@
         </p:nvSpPr>
         <p:spPr>
           <a:xfrm>
-            <a:off x="4709160" y="2715768"/>
-            <a:ext cx="3886200" cy="420624"/>
+            <a:off x="4709160" y="2532888"/>
+            <a:ext cx="3886200" cy="384048"/>
           </a:xfrm>
           <a:prstGeom prst="rect">
             <a:avLst/>
@@ -3925,7 +4125,7 @@
                   <a:schemeClr val="tx2"/>
                 </a:solidFill>
               </a:rPr>
-              <a:t>切開の方法</a:t>
+              <a:t>切開の位置</a:t>
             </a:r>
             <a:endParaRPr lang="en-US" sz="1600" dirty="0"/>
           </a:p>
@@ -3939,17 +4139,301 @@
         </p:nvSpPr>
         <p:spPr>
           <a:xfrm>
-            <a:off x="4709160" y="3246120"/>
-            <a:ext cx="3840480" cy="1188720"/>
-          </a:xfrm>
-          <a:prstGeom prst="rect">
-            <a:avLst/>
-          </a:prstGeom>
-          <a:noFill/>
-          <a:ln/>
-        </p:spPr>
-        <p:txBody>
-          <a:bodyPr wrap="square" lIns="0" tIns="0" rIns="0" bIns="0" rtlCol="0" anchor="t"/>
+            <a:off x="4709160" y="2971800"/>
+            <a:ext cx="731520" cy="237744"/>
+          </a:xfrm>
+          <a:prstGeom prst="rect">
+            <a:avLst/>
+          </a:prstGeom>
+          <a:noFill/>
+          <a:ln/>
+        </p:spPr>
+        <p:txBody>
+          <a:bodyPr wrap="square" lIns="0" tIns="0" rIns="0" bIns="0" rtlCol="0" anchor="ctr"/>
+          <a:lstStyle/>
+          <a:p>
+            <a:pPr algn="ctr" indent="0" marL="0">
+              <a:buNone/>
+            </a:pPr>
+            <a:r>
+              <a:rPr lang="en-US" sz="1300" b="1" dirty="0">
+                <a:solidFill>
+                  <a:schemeClr val="tx1"/>
+                </a:solidFill>
+              </a:rPr>
+              <a:t>皮膚</a:t>
+            </a:r>
+            <a:endParaRPr lang="en-US" sz="1300" dirty="0"/>
+          </a:p>
+        </p:txBody>
+      </p:sp>
+      <p:sp>
+        <p:nvSpPr>
+          <p:cNvPr id="36" name="skin-torso"/>
+          <p:cNvSpPr/>
+          <p:nvPr/>
+        </p:nvSpPr>
+        <p:spPr>
+          <a:xfrm>
+            <a:off x="4709160" y="3291840"/>
+            <a:ext cx="731520" cy="1143000"/>
+          </a:xfrm>
+          <a:prstGeom prst="roundRect">
+            <a:avLst>
+              <a:gd name="adj" fmla="val 37500"/>
+            </a:avLst>
+          </a:prstGeom>
+          <a:solidFill>
+            <a:schemeClr val="bg1"/>
+          </a:solidFill>
+          <a:ln w="12700">
+            <a:solidFill>
+              <a:srgbClr val="A6A6A6"/>
+            </a:solidFill>
+            <a:prstDash val="solid"/>
+          </a:ln>
+        </p:spPr>
+      </p:sp>
+      <p:sp>
+        <p:nvSpPr>
+          <p:cNvPr id="37" name="skin-navel"/>
+          <p:cNvSpPr/>
+          <p:nvPr/>
+        </p:nvSpPr>
+        <p:spPr>
+          <a:xfrm>
+            <a:off x="5042916" y="3584448"/>
+            <a:ext cx="64008" cy="64008"/>
+          </a:xfrm>
+          <a:prstGeom prst="ellipse">
+            <a:avLst/>
+          </a:prstGeom>
+          <a:solidFill>
+            <a:srgbClr val="A6A6A6"/>
+          </a:solidFill>
+          <a:ln/>
+        </p:spPr>
+      </p:sp>
+      <p:sp>
+        <p:nvSpPr>
+          <p:cNvPr id="38" name="skin-vertical"/>
+          <p:cNvSpPr/>
+          <p:nvPr/>
+        </p:nvSpPr>
+        <p:spPr>
+          <a:xfrm>
+            <a:off x="5074920" y="3730752"/>
+            <a:ext cx="0" cy="530352"/>
+          </a:xfrm>
+          <a:prstGeom prst="line">
+            <a:avLst/>
+          </a:prstGeom>
+          <a:noFill/>
+          <a:ln w="31750">
+            <a:solidFill>
+              <a:srgbClr val="1F7A7A"/>
+            </a:solidFill>
+            <a:prstDash val="dash"/>
+          </a:ln>
+        </p:spPr>
+      </p:sp>
+      <p:sp>
+        <p:nvSpPr>
+          <p:cNvPr id="39" name="skin-transverse"/>
+          <p:cNvSpPr/>
+          <p:nvPr/>
+        </p:nvSpPr>
+        <p:spPr>
+          <a:xfrm>
+            <a:off x="4873752" y="4206240"/>
+            <a:ext cx="402336" cy="0"/>
+          </a:xfrm>
+          <a:prstGeom prst="line">
+            <a:avLst/>
+          </a:prstGeom>
+          <a:noFill/>
+          <a:ln w="31750">
+            <a:solidFill>
+              <a:srgbClr val="7A2048"/>
+            </a:solidFill>
+            <a:prstDash val="solid"/>
+          </a:ln>
+        </p:spPr>
+      </p:sp>
+      <p:sp>
+        <p:nvSpPr>
+          <p:cNvPr id="40" name="Text 38"/>
+          <p:cNvSpPr txBox="1"/>
+          <p:nvPr/>
+        </p:nvSpPr>
+        <p:spPr>
+          <a:xfrm>
+            <a:off x="5577840" y="2971800"/>
+            <a:ext cx="731520" cy="237744"/>
+          </a:xfrm>
+          <a:prstGeom prst="rect">
+            <a:avLst/>
+          </a:prstGeom>
+          <a:noFill/>
+          <a:ln/>
+        </p:spPr>
+        <p:txBody>
+          <a:bodyPr wrap="square" lIns="0" tIns="0" rIns="0" bIns="0" rtlCol="0" anchor="ctr"/>
+          <a:lstStyle/>
+          <a:p>
+            <a:pPr algn="ctr" indent="0" marL="0">
+              <a:buNone/>
+            </a:pPr>
+            <a:r>
+              <a:rPr lang="en-US" sz="1300" b="1" dirty="0">
+                <a:solidFill>
+                  <a:schemeClr val="tx1"/>
+                </a:solidFill>
+              </a:rPr>
+              <a:t>子宮</a:t>
+            </a:r>
+            <a:endParaRPr lang="en-US" sz="1300" dirty="0"/>
+          </a:p>
+        </p:txBody>
+      </p:sp>
+      <p:sp>
+        <p:nvSpPr>
+          <p:cNvPr id="41" name="ut-inc-cervix"/>
+          <p:cNvSpPr/>
+          <p:nvPr/>
+        </p:nvSpPr>
+        <p:spPr>
+          <a:xfrm>
+            <a:off x="5804611" y="4059022"/>
+            <a:ext cx="277978" cy="288036"/>
+          </a:xfrm>
+          <a:prstGeom prst="rect">
+            <a:avLst/>
+          </a:prstGeom>
+          <a:solidFill>
+            <a:schemeClr val="bg1"/>
+          </a:solidFill>
+          <a:ln w="12700">
+            <a:solidFill>
+              <a:srgbClr val="A6A6A6"/>
+            </a:solidFill>
+            <a:prstDash val="solid"/>
+          </a:ln>
+        </p:spPr>
+      </p:sp>
+      <p:sp>
+        <p:nvSpPr>
+          <p:cNvPr id="42" name="ut-inc-body"/>
+          <p:cNvSpPr/>
+          <p:nvPr/>
+        </p:nvSpPr>
+        <p:spPr>
+          <a:xfrm>
+            <a:off x="5577840" y="3310128"/>
+            <a:ext cx="731520" cy="844906"/>
+          </a:xfrm>
+          <a:prstGeom prst="ellipse">
+            <a:avLst/>
+          </a:prstGeom>
+          <a:solidFill>
+            <a:schemeClr val="bg1"/>
+          </a:solidFill>
+          <a:ln w="12700">
+            <a:solidFill>
+              <a:srgbClr val="A6A6A6"/>
+            </a:solidFill>
+            <a:prstDash val="solid"/>
+          </a:ln>
+        </p:spPr>
+      </p:sp>
+      <p:sp>
+        <p:nvSpPr>
+          <p:cNvPr id="43" name="ut-classical"/>
+          <p:cNvSpPr/>
+          <p:nvPr/>
+        </p:nvSpPr>
+        <p:spPr>
+          <a:xfrm>
+            <a:off x="5943600" y="3429000"/>
+            <a:ext cx="0" cy="411480"/>
+          </a:xfrm>
+          <a:prstGeom prst="line">
+            <a:avLst/>
+          </a:prstGeom>
+          <a:noFill/>
+          <a:ln w="31750">
+            <a:solidFill>
+              <a:srgbClr val="1F7A7A"/>
+            </a:solidFill>
+            <a:prstDash val="dash"/>
+          </a:ln>
+        </p:spPr>
+      </p:sp>
+      <p:sp>
+        <p:nvSpPr>
+          <p:cNvPr id="44" name="ut-lowtransverse"/>
+          <p:cNvSpPr/>
+          <p:nvPr/>
+        </p:nvSpPr>
+        <p:spPr>
+          <a:xfrm>
+            <a:off x="5733288" y="4005072"/>
+            <a:ext cx="420624" cy="0"/>
+          </a:xfrm>
+          <a:prstGeom prst="line">
+            <a:avLst/>
+          </a:prstGeom>
+          <a:noFill/>
+          <a:ln w="31750">
+            <a:solidFill>
+              <a:srgbClr val="7A2048"/>
+            </a:solidFill>
+            <a:prstDash val="solid"/>
+          </a:ln>
+        </p:spPr>
+      </p:sp>
+      <p:sp>
+        <p:nvSpPr>
+          <p:cNvPr id="45" name="leg-trans-key"/>
+          <p:cNvSpPr/>
+          <p:nvPr/>
+        </p:nvSpPr>
+        <p:spPr>
+          <a:xfrm>
+            <a:off x="6446520" y="3090672"/>
+            <a:ext cx="274320" cy="0"/>
+          </a:xfrm>
+          <a:prstGeom prst="line">
+            <a:avLst/>
+          </a:prstGeom>
+          <a:noFill/>
+          <a:ln w="31750">
+            <a:solidFill>
+              <a:srgbClr val="7A2048"/>
+            </a:solidFill>
+            <a:prstDash val="solid"/>
+          </a:ln>
+        </p:spPr>
+      </p:sp>
+      <p:sp>
+        <p:nvSpPr>
+          <p:cNvPr id="46" name="Text 44"/>
+          <p:cNvSpPr txBox="1"/>
+          <p:nvPr/>
+        </p:nvSpPr>
+        <p:spPr>
+          <a:xfrm>
+            <a:off x="6793992" y="2971800"/>
+            <a:ext cx="1892808" cy="237744"/>
+          </a:xfrm>
+          <a:prstGeom prst="rect">
+            <a:avLst/>
+          </a:prstGeom>
+          <a:noFill/>
+          <a:ln/>
+        </p:spPr>
+        <p:txBody>
+          <a:bodyPr wrap="square" lIns="0" tIns="0" rIns="0" bIns="0" rtlCol="0" anchor="ctr"/>
           <a:lstStyle/>
           <a:p>
             <a:pPr indent="0" marL="0">
@@ -3958,18 +4442,73 @@
             <a:r>
               <a:rPr lang="en-US" sz="1300" b="1" dirty="0">
                 <a:solidFill>
+                  <a:srgbClr val="7A2048"/>
+                </a:solidFill>
+              </a:rPr>
+              <a:t>横切開</a:t>
+            </a:r>
+            <a:endParaRPr lang="en-US" sz="1300" dirty="0"/>
+          </a:p>
+        </p:txBody>
+      </p:sp>
+      <p:sp>
+        <p:nvSpPr>
+          <p:cNvPr id="47" name="Text 45"/>
+          <p:cNvSpPr txBox="1"/>
+          <p:nvPr/>
+        </p:nvSpPr>
+        <p:spPr>
+          <a:xfrm>
+            <a:off x="6793992" y="3209544"/>
+            <a:ext cx="1892808" cy="237744"/>
+          </a:xfrm>
+          <a:prstGeom prst="rect">
+            <a:avLst/>
+          </a:prstGeom>
+          <a:noFill/>
+          <a:ln/>
+        </p:spPr>
+        <p:txBody>
+          <a:bodyPr wrap="square" lIns="0" tIns="0" rIns="0" bIns="0" rtlCol="0" anchor="ctr"/>
+          <a:lstStyle/>
+          <a:p>
+            <a:pPr indent="0" marL="0">
+              <a:buNone/>
+            </a:pPr>
+            <a:r>
+              <a:rPr lang="en-US" sz="1300" dirty="0">
+                <a:solidFill>
                   <a:schemeClr val="tx1"/>
                 </a:solidFill>
               </a:rPr>
-              <a:t>皮膚：横切開 or 縦切開</a:t>
+              <a:t>皮膚：目立ちにくい</a:t>
             </a:r>
             <a:endParaRPr lang="en-US" sz="1300" dirty="0"/>
           </a:p>
+        </p:txBody>
+      </p:sp>
+      <p:sp>
+        <p:nvSpPr>
+          <p:cNvPr id="48" name="Text 46"/>
+          <p:cNvSpPr txBox="1"/>
+          <p:nvPr/>
+        </p:nvSpPr>
+        <p:spPr>
+          <a:xfrm>
+            <a:off x="6793992" y="3447288"/>
+            <a:ext cx="1892808" cy="237744"/>
+          </a:xfrm>
+          <a:prstGeom prst="rect">
+            <a:avLst/>
+          </a:prstGeom>
+          <a:noFill/>
+          <a:ln/>
+        </p:spPr>
+        <p:txBody>
+          <a:bodyPr wrap="square" lIns="0" tIns="0" rIns="0" bIns="0" rtlCol="0" anchor="ctr"/>
+          <a:lstStyle/>
           <a:p>
             <a:pPr indent="0" marL="0">
-              <a:spcAft>
-                <a:spcPts val="600"/>
-              </a:spcAft>
               <a:buNone/>
             </a:pPr>
             <a:r>
@@ -3978,10 +4517,55 @@
                   <a:schemeClr val="tx1"/>
                 </a:solidFill>
               </a:rPr>
-              <a:t>横は傷が目立ちにくい／縦は速く広い視野</a:t>
+              <a:t>子宮：子宮下部（標準）</a:t>
             </a:r>
             <a:endParaRPr lang="en-US" sz="1300" dirty="0"/>
           </a:p>
+        </p:txBody>
+      </p:sp>
+      <p:sp>
+        <p:nvSpPr>
+          <p:cNvPr id="49" name="leg-vert-key"/>
+          <p:cNvSpPr/>
+          <p:nvPr/>
+        </p:nvSpPr>
+        <p:spPr>
+          <a:xfrm>
+            <a:off x="6446520" y="3886200"/>
+            <a:ext cx="274320" cy="0"/>
+          </a:xfrm>
+          <a:prstGeom prst="line">
+            <a:avLst/>
+          </a:prstGeom>
+          <a:noFill/>
+          <a:ln w="31750">
+            <a:solidFill>
+              <a:srgbClr val="1F7A7A"/>
+            </a:solidFill>
+            <a:prstDash val="sysDash"/>
+          </a:ln>
+        </p:spPr>
+      </p:sp>
+      <p:sp>
+        <p:nvSpPr>
+          <p:cNvPr id="50" name="Text 48"/>
+          <p:cNvSpPr txBox="1"/>
+          <p:nvPr/>
+        </p:nvSpPr>
+        <p:spPr>
+          <a:xfrm>
+            <a:off x="6793992" y="3767328"/>
+            <a:ext cx="1892808" cy="237744"/>
+          </a:xfrm>
+          <a:prstGeom prst="rect">
+            <a:avLst/>
+          </a:prstGeom>
+          <a:noFill/>
+          <a:ln/>
+        </p:spPr>
+        <p:txBody>
+          <a:bodyPr wrap="square" lIns="0" tIns="0" rIns="0" bIns="0" rtlCol="0" anchor="ctr"/>
+          <a:lstStyle/>
           <a:p>
             <a:pPr indent="0" marL="0">
               <a:buNone/>
@@ -3989,13 +4573,71 @@
             <a:r>
               <a:rPr lang="en-US" sz="1300" b="1" dirty="0">
                 <a:solidFill>
+                  <a:srgbClr val="1F7A7A"/>
+                </a:solidFill>
+              </a:rPr>
+              <a:t>縦切開</a:t>
+            </a:r>
+            <a:endParaRPr lang="en-US" sz="1300" dirty="0"/>
+          </a:p>
+        </p:txBody>
+      </p:sp>
+      <p:sp>
+        <p:nvSpPr>
+          <p:cNvPr id="51" name="Text 49"/>
+          <p:cNvSpPr txBox="1"/>
+          <p:nvPr/>
+        </p:nvSpPr>
+        <p:spPr>
+          <a:xfrm>
+            <a:off x="6793992" y="4005072"/>
+            <a:ext cx="1892808" cy="237744"/>
+          </a:xfrm>
+          <a:prstGeom prst="rect">
+            <a:avLst/>
+          </a:prstGeom>
+          <a:noFill/>
+          <a:ln/>
+        </p:spPr>
+        <p:txBody>
+          <a:bodyPr wrap="square" lIns="0" tIns="0" rIns="0" bIns="0" rtlCol="0" anchor="ctr"/>
+          <a:lstStyle/>
+          <a:p>
+            <a:pPr indent="0" marL="0">
+              <a:buNone/>
+            </a:pPr>
+            <a:r>
+              <a:rPr lang="en-US" sz="1300" dirty="0">
+                <a:solidFill>
                   <a:schemeClr val="tx1"/>
                 </a:solidFill>
               </a:rPr>
-              <a:t>子宮：子宮下部横切開が標準</a:t>
+              <a:t>皮膚：速く広い視野</a:t>
             </a:r>
             <a:endParaRPr lang="en-US" sz="1300" dirty="0"/>
           </a:p>
+        </p:txBody>
+      </p:sp>
+      <p:sp>
+        <p:nvSpPr>
+          <p:cNvPr id="52" name="Text 50"/>
+          <p:cNvSpPr txBox="1"/>
+          <p:nvPr/>
+        </p:nvSpPr>
+        <p:spPr>
+          <a:xfrm>
+            <a:off x="6793992" y="4242816"/>
+            <a:ext cx="1892808" cy="237744"/>
+          </a:xfrm>
+          <a:prstGeom prst="rect">
+            <a:avLst/>
+          </a:prstGeom>
+          <a:noFill/>
+          <a:ln/>
+        </p:spPr>
+        <p:txBody>
+          <a:bodyPr wrap="square" lIns="0" tIns="0" rIns="0" bIns="0" rtlCol="0" anchor="ctr"/>
+          <a:lstStyle/>
           <a:p>
             <a:pPr indent="0" marL="0">
               <a:buNone/>
@@ -4006,7 +4648,7 @@
                   <a:schemeClr val="tx1"/>
                 </a:solidFill>
               </a:rPr>
-              <a:t>次回妊娠時の子宮破裂リスクが低い</a:t>
+              <a:t>子宮：体部（古典的）</a:t>
             </a:r>
             <a:endParaRPr lang="en-US" sz="1300" dirty="0"/>
           </a:p>
@@ -4014,7 +4656,7 @@
       </p:sp>
       <p:sp>
         <p:nvSpPr>
-          <p:cNvPr id="36" name="source"/>
+          <p:cNvPr id="53" name="source"/>
           <p:cNvSpPr txBox="1"/>
           <p:nvPr/>
         </p:nvSpPr>
@@ -4488,7 +5130,7 @@
         </p:nvSpPr>
         <p:spPr>
           <a:xfrm>
-            <a:off x="7818120" y="2468880"/>
+            <a:off x="7818120" y="1051560"/>
             <a:ext cx="822960" cy="822960"/>
           </a:xfrm>
           <a:prstGeom prst="ellipse">
@@ -4510,7 +5152,7 @@
         </p:nvSpPr>
         <p:spPr>
           <a:xfrm>
-            <a:off x="5303520" y="3383280"/>
+            <a:off x="5303520" y="3703320"/>
             <a:ext cx="3383280" cy="0"/>
           </a:xfrm>
           <a:prstGeom prst="line">
@@ -4635,14 +5277,166 @@
       </p:sp>
       <p:sp>
         <p:nvSpPr>
-          <p:cNvPr id="17" name="Text 15"/>
-          <p:cNvSpPr txBox="1"/>
-          <p:nvPr/>
-        </p:nvSpPr>
-        <p:spPr>
-          <a:xfrm>
-            <a:off x="5303520" y="2514600"/>
-            <a:ext cx="3291840" cy="731520"/>
+          <p:cNvPr id="17" name="ut-scar-cervix"/>
+          <p:cNvSpPr/>
+          <p:nvPr/>
+        </p:nvSpPr>
+        <p:spPr>
+          <a:xfrm>
+            <a:off x="5530291" y="3199486"/>
+            <a:ext cx="277978" cy="288036"/>
+          </a:xfrm>
+          <a:prstGeom prst="rect">
+            <a:avLst/>
+          </a:prstGeom>
+          <a:solidFill>
+            <a:schemeClr val="bg1"/>
+          </a:solidFill>
+          <a:ln w="12700">
+            <a:solidFill>
+              <a:srgbClr val="A6A6A6"/>
+            </a:solidFill>
+            <a:prstDash val="solid"/>
+          </a:ln>
+        </p:spPr>
+      </p:sp>
+      <p:sp>
+        <p:nvSpPr>
+          <p:cNvPr id="18" name="ut-scar-body"/>
+          <p:cNvSpPr/>
+          <p:nvPr/>
+        </p:nvSpPr>
+        <p:spPr>
+          <a:xfrm>
+            <a:off x="5303520" y="2450592"/>
+            <a:ext cx="731520" cy="844906"/>
+          </a:xfrm>
+          <a:prstGeom prst="ellipse">
+            <a:avLst/>
+          </a:prstGeom>
+          <a:solidFill>
+            <a:schemeClr val="bg1"/>
+          </a:solidFill>
+          <a:ln w="12700">
+            <a:solidFill>
+              <a:srgbClr val="A6A6A6"/>
+            </a:solidFill>
+            <a:prstDash val="solid"/>
+          </a:ln>
+        </p:spPr>
+      </p:sp>
+      <p:sp>
+        <p:nvSpPr>
+          <p:cNvPr id="19" name="ut-scar-placenta"/>
+          <p:cNvSpPr/>
+          <p:nvPr/>
+        </p:nvSpPr>
+        <p:spPr>
+          <a:xfrm>
+            <a:off x="5468112" y="3072384"/>
+            <a:ext cx="402336" cy="182880"/>
+          </a:xfrm>
+          <a:prstGeom prst="ellipse">
+            <a:avLst/>
+          </a:prstGeom>
+          <a:solidFill>
+            <a:schemeClr val="accent2"/>
+          </a:solidFill>
+          <a:ln/>
+        </p:spPr>
+      </p:sp>
+      <p:sp>
+        <p:nvSpPr>
+          <p:cNvPr id="20" name="ut-scar-line"/>
+          <p:cNvSpPr/>
+          <p:nvPr/>
+        </p:nvSpPr>
+        <p:spPr>
+          <a:xfrm>
+            <a:off x="5449824" y="3200400"/>
+            <a:ext cx="438912" cy="0"/>
+          </a:xfrm>
+          <a:prstGeom prst="line">
+            <a:avLst/>
+          </a:prstGeom>
+          <a:noFill/>
+          <a:ln w="38100">
+            <a:solidFill>
+              <a:srgbClr val="7A2048"/>
+            </a:solidFill>
+            <a:prstDash val="solid"/>
+          </a:ln>
+        </p:spPr>
+      </p:sp>
+      <p:sp>
+        <p:nvSpPr>
+          <p:cNvPr id="21" name="scar-leg-key"/>
+          <p:cNvSpPr/>
+          <p:nvPr/>
+        </p:nvSpPr>
+        <p:spPr>
+          <a:xfrm>
+            <a:off x="6217920" y="2551176"/>
+            <a:ext cx="274320" cy="0"/>
+          </a:xfrm>
+          <a:prstGeom prst="line">
+            <a:avLst/>
+          </a:prstGeom>
+          <a:noFill/>
+          <a:ln w="31750">
+            <a:solidFill>
+              <a:srgbClr val="7A2048"/>
+            </a:solidFill>
+            <a:prstDash val="solid"/>
+          </a:ln>
+        </p:spPr>
+      </p:sp>
+      <p:sp>
+        <p:nvSpPr>
+          <p:cNvPr id="22" name="Text 20"/>
+          <p:cNvSpPr txBox="1"/>
+          <p:nvPr/>
+        </p:nvSpPr>
+        <p:spPr>
+          <a:xfrm>
+            <a:off x="6565392" y="2432304"/>
+            <a:ext cx="2121408" cy="237744"/>
+          </a:xfrm>
+          <a:prstGeom prst="rect">
+            <a:avLst/>
+          </a:prstGeom>
+          <a:noFill/>
+          <a:ln/>
+        </p:spPr>
+        <p:txBody>
+          <a:bodyPr wrap="square" lIns="0" tIns="0" rIns="0" bIns="0" rtlCol="0" anchor="ctr"/>
+          <a:lstStyle/>
+          <a:p>
+            <a:pPr indent="0" marL="0">
+              <a:buNone/>
+            </a:pPr>
+            <a:r>
+              <a:rPr lang="en-US" sz="1300" b="1" dirty="0">
+                <a:solidFill>
+                  <a:srgbClr val="7A2048"/>
+                </a:solidFill>
+              </a:rPr>
+              <a:t>前回の切開瘢痕</a:t>
+            </a:r>
+            <a:endParaRPr lang="en-US" sz="1300" dirty="0"/>
+          </a:p>
+        </p:txBody>
+      </p:sp>
+      <p:sp>
+        <p:nvSpPr>
+          <p:cNvPr id="23" name="Text 21"/>
+          <p:cNvSpPr txBox="1"/>
+          <p:nvPr/>
+        </p:nvSpPr>
+        <p:spPr>
+          <a:xfrm>
+            <a:off x="6217920" y="2743200"/>
+            <a:ext cx="2468880" cy="868680"/>
           </a:xfrm>
           <a:prstGeom prst="rect">
             <a:avLst/>
@@ -4662,14 +5456,14 @@
               <a:buChar char="•"/>
             </a:pPr>
             <a:r>
-              <a:rPr lang="en-US" sz="1400" dirty="0">
+              <a:rPr lang="en-US" sz="1300" dirty="0">
                 <a:solidFill>
                   <a:schemeClr val="tx1"/>
                 </a:solidFill>
               </a:rPr>
-              <a:t>前置胎盤・癒着胎盤が増える</a:t>
-            </a:r>
-            <a:endParaRPr lang="en-US" sz="1400" dirty="0"/>
+              <a:t>瘢痕が裂ける → 子宮破裂</a:t>
+            </a:r>
+            <a:endParaRPr lang="en-US" sz="1300" dirty="0"/>
           </a:p>
           <a:p>
             <a:pPr marL="152400" indent="-152400">
@@ -4680,26 +5474,44 @@
               <a:buChar char="•"/>
             </a:pPr>
             <a:r>
-              <a:rPr lang="en-US" sz="1400" dirty="0">
+              <a:rPr lang="en-US" sz="1300" dirty="0">
                 <a:solidFill>
                   <a:schemeClr val="tx1"/>
                 </a:solidFill>
               </a:rPr>
-              <a:t>帝王切開瘢痕部妊娠</a:t>
-            </a:r>
-            <a:endParaRPr lang="en-US" sz="1400" dirty="0"/>
-          </a:p>
-        </p:txBody>
-      </p:sp>
-      <p:sp>
-        <p:nvSpPr>
-          <p:cNvPr id="18" name="neonate-decor"/>
+              <a:t>瘢痕に胎盤 → 前置・癒着胎盤</a:t>
+            </a:r>
+            <a:endParaRPr lang="en-US" sz="1300" dirty="0"/>
+          </a:p>
+          <a:p>
+            <a:pPr marL="152400" indent="-152400">
+              <a:spcAft>
+                <a:spcPts val="200"/>
+              </a:spcAft>
+              <a:buSzPct val="100000"/>
+              <a:buChar char="•"/>
+            </a:pPr>
+            <a:r>
+              <a:rPr lang="en-US" sz="1300" dirty="0">
+                <a:solidFill>
+                  <a:schemeClr val="tx1"/>
+                </a:solidFill>
+              </a:rPr>
+              <a:t>瘢痕に着床 → 瘢痕部妊娠</a:t>
+            </a:r>
+            <a:endParaRPr lang="en-US" sz="1300" dirty="0"/>
+          </a:p>
+        </p:txBody>
+      </p:sp>
+      <p:sp>
+        <p:nvSpPr>
+          <p:cNvPr id="24" name="neonate-decor"/>
           <p:cNvSpPr/>
           <p:nvPr/>
         </p:nvSpPr>
         <p:spPr>
           <a:xfrm>
-            <a:off x="7818120" y="3611880"/>
+            <a:off x="7818120" y="3886200"/>
             <a:ext cx="822960" cy="822960"/>
           </a:xfrm>
           <a:prstGeom prst="triangle">
@@ -4715,7 +5527,7 @@
       </p:sp>
       <p:sp>
         <p:nvSpPr>
-          <p:cNvPr id="19" name="neonate-rule"/>
+          <p:cNvPr id="25" name="neonate-rule"/>
           <p:cNvSpPr/>
           <p:nvPr/>
         </p:nvSpPr>
@@ -4738,14 +5550,14 @@
       </p:sp>
       <p:sp>
         <p:nvSpPr>
-          <p:cNvPr id="20" name="Text 18"/>
-          <p:cNvSpPr txBox="1"/>
-          <p:nvPr/>
-        </p:nvSpPr>
-        <p:spPr>
-          <a:xfrm>
-            <a:off x="5303520" y="3566160"/>
-            <a:ext cx="3383280" cy="402336"/>
+          <p:cNvPr id="26" name="Text 24"/>
+          <p:cNvSpPr txBox="1"/>
+          <p:nvPr/>
+        </p:nvSpPr>
+        <p:spPr>
+          <a:xfrm>
+            <a:off x="5303520" y="3840480"/>
+            <a:ext cx="3383280" cy="320040"/>
           </a:xfrm>
           <a:prstGeom prst="rect">
             <a:avLst/>
@@ -4774,14 +5586,14 @@
       </p:sp>
       <p:sp>
         <p:nvSpPr>
-          <p:cNvPr id="21" name="Text 19"/>
-          <p:cNvSpPr txBox="1"/>
-          <p:nvPr/>
-        </p:nvSpPr>
-        <p:spPr>
-          <a:xfrm>
-            <a:off x="5303520" y="4005072"/>
-            <a:ext cx="3291840" cy="457200"/>
+          <p:cNvPr id="27" name="Text 25"/>
+          <p:cNvSpPr txBox="1"/>
+          <p:nvPr/>
+        </p:nvSpPr>
+        <p:spPr>
+          <a:xfrm>
+            <a:off x="5303520" y="4178808"/>
+            <a:ext cx="3291840" cy="274320"/>
           </a:xfrm>
           <a:prstGeom prst="rect">
             <a:avLst/>
@@ -4802,7 +5614,7 @@
                   <a:schemeClr val="tx1"/>
                 </a:solidFill>
               </a:rPr>
-              <a:t>陣痛を経ずに生まれると肺の水の吸収が遅れやすい</a:t>
+              <a:t>陣痛なしの出生で肺の水の吸収が遅れる</a:t>
             </a:r>
             <a:endParaRPr lang="en-US" sz="1200" dirty="0"/>
           </a:p>
@@ -4810,7 +5622,7 @@
       </p:sp>
       <p:sp>
         <p:nvSpPr>
-          <p:cNvPr id="22" name="source"/>
+          <p:cNvPr id="28" name="source"/>
           <p:cNvSpPr txBox="1"/>
           <p:nvPr/>
         </p:nvSpPr>
@@ -4960,8 +5772,8 @@
         </p:nvSpPr>
         <p:spPr>
           <a:xfrm>
-            <a:off x="457200" y="941832"/>
-            <a:ext cx="8229600" cy="658368"/>
+            <a:off x="457200" y="896112"/>
+            <a:ext cx="8229600" cy="347472"/>
           </a:xfrm>
           <a:prstGeom prst="rect">
             <a:avLst/>
@@ -4984,33 +5796,254 @@
               </a:rPr>
               <a:t>先天性疾患 ＝ 帝王切開、ではない</a:t>
             </a:r>
+            <a:pPr indent="0" marL="0">
+              <a:buNone/>
+            </a:pPr>
+            <a:r>
+              <a:rPr lang="en-US" sz="1300" dirty="0">
+                <a:solidFill>
+                  <a:schemeClr val="tx1"/>
+                </a:solidFill>
+              </a:rPr>
+              <a:t>　分娩方法は原則、産科的適応で決める</a:t>
+            </a:r>
             <a:endParaRPr lang="en-US" sz="1700" dirty="0"/>
           </a:p>
-          <a:p>
-            <a:pPr indent="0" marL="0">
-              <a:buNone/>
-            </a:pPr>
-            <a:r>
-              <a:rPr lang="en-US" sz="1300" dirty="0">
-                <a:solidFill>
-                  <a:schemeClr val="tx1"/>
-                </a:solidFill>
-              </a:rPr>
-              <a:t>分娩方法は原則として産科的適応で決める。大切なのは「どこで・いつ産むか」（計画分娩）</a:t>
-            </a:r>
-            <a:endParaRPr lang="en-US" sz="1700" dirty="0"/>
-          </a:p>
-        </p:txBody>
-      </p:sp>
-      <p:sp>
-        <p:nvSpPr>
-          <p:cNvPr id="4" name="fetal-banner-rule"/>
+        </p:txBody>
+      </p:sp>
+      <p:sp>
+        <p:nvSpPr>
+          <p:cNvPr id="4" name="plan-step-0"/>
           <p:cNvSpPr/>
           <p:nvPr/>
         </p:nvSpPr>
         <p:spPr>
           <a:xfrm>
-            <a:off x="457200" y="1691640"/>
+            <a:off x="457200" y="1316736"/>
+            <a:ext cx="2011680" cy="329184"/>
+          </a:xfrm>
+          <a:prstGeom prst="homePlate">
+            <a:avLst/>
+          </a:prstGeom>
+          <a:solidFill>
+            <a:schemeClr val="tx2"/>
+          </a:solidFill>
+          <a:ln/>
+        </p:spPr>
+      </p:sp>
+      <p:sp>
+        <p:nvSpPr>
+          <p:cNvPr id="5" name="Text 3"/>
+          <p:cNvSpPr txBox="1"/>
+          <p:nvPr/>
+        </p:nvSpPr>
+        <p:spPr>
+          <a:xfrm>
+            <a:off x="457200" y="1316736"/>
+            <a:ext cx="1847088" cy="329184"/>
+          </a:xfrm>
+          <a:prstGeom prst="rect">
+            <a:avLst/>
+          </a:prstGeom>
+          <a:noFill/>
+          <a:ln/>
+        </p:spPr>
+        <p:txBody>
+          <a:bodyPr wrap="square" lIns="0" tIns="0" rIns="0" bIns="0" rtlCol="0" anchor="ctr"/>
+          <a:lstStyle/>
+          <a:p>
+            <a:pPr algn="ctr" indent="0" marL="0">
+              <a:buNone/>
+            </a:pPr>
+            <a:r>
+              <a:rPr lang="en-US" sz="1300" b="1" dirty="0">
+                <a:solidFill>
+                  <a:schemeClr val="bg1"/>
+                </a:solidFill>
+              </a:rPr>
+              <a:t>胎児診断</a:t>
+            </a:r>
+            <a:endParaRPr lang="en-US" sz="1300" dirty="0"/>
+          </a:p>
+        </p:txBody>
+      </p:sp>
+      <p:sp>
+        <p:nvSpPr>
+          <p:cNvPr id="6" name="plan-step-1"/>
+          <p:cNvSpPr/>
+          <p:nvPr/>
+        </p:nvSpPr>
+        <p:spPr>
+          <a:xfrm>
+            <a:off x="2532888" y="1316736"/>
+            <a:ext cx="2011680" cy="329184"/>
+          </a:xfrm>
+          <a:prstGeom prst="chevron">
+            <a:avLst/>
+          </a:prstGeom>
+          <a:solidFill>
+            <a:schemeClr val="tx2"/>
+          </a:solidFill>
+          <a:ln/>
+        </p:spPr>
+      </p:sp>
+      <p:sp>
+        <p:nvSpPr>
+          <p:cNvPr id="7" name="Text 5"/>
+          <p:cNvSpPr txBox="1"/>
+          <p:nvPr/>
+        </p:nvSpPr>
+        <p:spPr>
+          <a:xfrm>
+            <a:off x="2697480" y="1316736"/>
+            <a:ext cx="1682496" cy="329184"/>
+          </a:xfrm>
+          <a:prstGeom prst="rect">
+            <a:avLst/>
+          </a:prstGeom>
+          <a:noFill/>
+          <a:ln/>
+        </p:spPr>
+        <p:txBody>
+          <a:bodyPr wrap="square" lIns="0" tIns="0" rIns="0" bIns="0" rtlCol="0" anchor="ctr"/>
+          <a:lstStyle/>
+          <a:p>
+            <a:pPr algn="ctr" indent="0" marL="0">
+              <a:buNone/>
+            </a:pPr>
+            <a:r>
+              <a:rPr lang="en-US" sz="1300" b="1" dirty="0">
+                <a:solidFill>
+                  <a:schemeClr val="bg1"/>
+                </a:solidFill>
+              </a:rPr>
+              <a:t>周産期センターへ</a:t>
+            </a:r>
+            <a:endParaRPr lang="en-US" sz="1300" dirty="0"/>
+          </a:p>
+        </p:txBody>
+      </p:sp>
+      <p:sp>
+        <p:nvSpPr>
+          <p:cNvPr id="8" name="plan-step-2"/>
+          <p:cNvSpPr/>
+          <p:nvPr/>
+        </p:nvSpPr>
+        <p:spPr>
+          <a:xfrm>
+            <a:off x="4608576" y="1316736"/>
+            <a:ext cx="2011680" cy="329184"/>
+          </a:xfrm>
+          <a:prstGeom prst="chevron">
+            <a:avLst/>
+          </a:prstGeom>
+          <a:solidFill>
+            <a:schemeClr val="tx2"/>
+          </a:solidFill>
+          <a:ln/>
+        </p:spPr>
+      </p:sp>
+      <p:sp>
+        <p:nvSpPr>
+          <p:cNvPr id="9" name="Text 7"/>
+          <p:cNvSpPr txBox="1"/>
+          <p:nvPr/>
+        </p:nvSpPr>
+        <p:spPr>
+          <a:xfrm>
+            <a:off x="4773168" y="1316736"/>
+            <a:ext cx="1682496" cy="329184"/>
+          </a:xfrm>
+          <a:prstGeom prst="rect">
+            <a:avLst/>
+          </a:prstGeom>
+          <a:noFill/>
+          <a:ln/>
+        </p:spPr>
+        <p:txBody>
+          <a:bodyPr wrap="square" lIns="0" tIns="0" rIns="0" bIns="0" rtlCol="0" anchor="ctr"/>
+          <a:lstStyle/>
+          <a:p>
+            <a:pPr algn="ctr" indent="0" marL="0">
+              <a:buNone/>
+            </a:pPr>
+            <a:r>
+              <a:rPr lang="en-US" sz="1300" b="1" dirty="0">
+                <a:solidFill>
+                  <a:schemeClr val="bg1"/>
+                </a:solidFill>
+              </a:rPr>
+              <a:t>日時を決めて分娩</a:t>
+            </a:r>
+            <a:endParaRPr lang="en-US" sz="1300" dirty="0"/>
+          </a:p>
+        </p:txBody>
+      </p:sp>
+      <p:sp>
+        <p:nvSpPr>
+          <p:cNvPr id="10" name="plan-step-3"/>
+          <p:cNvSpPr/>
+          <p:nvPr/>
+        </p:nvSpPr>
+        <p:spPr>
+          <a:xfrm>
+            <a:off x="6684264" y="1316736"/>
+            <a:ext cx="2011680" cy="329184"/>
+          </a:xfrm>
+          <a:prstGeom prst="chevron">
+            <a:avLst/>
+          </a:prstGeom>
+          <a:solidFill>
+            <a:schemeClr val="accent2"/>
+          </a:solidFill>
+          <a:ln/>
+        </p:spPr>
+      </p:sp>
+      <p:sp>
+        <p:nvSpPr>
+          <p:cNvPr id="11" name="Text 9"/>
+          <p:cNvSpPr txBox="1"/>
+          <p:nvPr/>
+        </p:nvSpPr>
+        <p:spPr>
+          <a:xfrm>
+            <a:off x="6848856" y="1316736"/>
+            <a:ext cx="1682496" cy="329184"/>
+          </a:xfrm>
+          <a:prstGeom prst="rect">
+            <a:avLst/>
+          </a:prstGeom>
+          <a:noFill/>
+          <a:ln/>
+        </p:spPr>
+        <p:txBody>
+          <a:bodyPr wrap="square" lIns="0" tIns="0" rIns="0" bIns="0" rtlCol="0" anchor="ctr"/>
+          <a:lstStyle/>
+          <a:p>
+            <a:pPr algn="ctr" indent="0" marL="0">
+              <a:buNone/>
+            </a:pPr>
+            <a:r>
+              <a:rPr lang="en-US" sz="1300" b="1" dirty="0">
+                <a:solidFill>
+                  <a:schemeClr val="bg1"/>
+                </a:solidFill>
+              </a:rPr>
+              <a:t>出生直後から治療</a:t>
+            </a:r>
+            <a:endParaRPr lang="en-US" sz="1300" dirty="0"/>
+          </a:p>
+        </p:txBody>
+      </p:sp>
+      <p:sp>
+        <p:nvSpPr>
+          <p:cNvPr id="12" name="fetal-banner-rule"/>
+          <p:cNvSpPr/>
+          <p:nvPr/>
+        </p:nvSpPr>
+        <p:spPr>
+          <a:xfrm>
+            <a:off x="457200" y="1755648"/>
             <a:ext cx="8229600" cy="0"/>
           </a:xfrm>
           <a:prstGeom prst="line">
@@ -5027,13 +6060,13 @@
       </p:sp>
       <p:sp>
         <p:nvSpPr>
-          <p:cNvPr id="5" name="fetal-0-decor"/>
+          <p:cNvPr id="13" name="fetal-0-decor"/>
           <p:cNvSpPr/>
           <p:nvPr/>
         </p:nvSpPr>
         <p:spPr>
           <a:xfrm>
-            <a:off x="2148840" y="3154680"/>
+            <a:off x="2148840" y="1920240"/>
             <a:ext cx="822960" cy="822960"/>
           </a:xfrm>
           <a:prstGeom prst="ellipse">
@@ -5049,7 +6082,7 @@
       </p:sp>
       <p:sp>
         <p:nvSpPr>
-          <p:cNvPr id="6" name="fetal-0-rule"/>
+          <p:cNvPr id="14" name="fetal-0-rule"/>
           <p:cNvSpPr/>
           <p:nvPr/>
         </p:nvSpPr>
@@ -5072,7 +6105,7 @@
       </p:sp>
       <p:sp>
         <p:nvSpPr>
-          <p:cNvPr id="7" name="Text 5"/>
+          <p:cNvPr id="15" name="Text 13"/>
           <p:cNvSpPr txBox="1"/>
           <p:nvPr/>
         </p:nvSpPr>
@@ -5108,7 +6141,7 @@
       </p:sp>
       <p:sp>
         <p:nvSpPr>
-          <p:cNvPr id="8" name="Text 6"/>
+          <p:cNvPr id="16" name="Text 14"/>
           <p:cNvSpPr txBox="1"/>
           <p:nvPr/>
         </p:nvSpPr>
@@ -5184,13 +6217,13 @@
       </p:sp>
       <p:sp>
         <p:nvSpPr>
-          <p:cNvPr id="9" name="fetal-1-decor"/>
+          <p:cNvPr id="17" name="fetal-1-decor"/>
           <p:cNvSpPr/>
           <p:nvPr/>
         </p:nvSpPr>
         <p:spPr>
           <a:xfrm>
-            <a:off x="4983480" y="3154680"/>
+            <a:off x="4983480" y="1920240"/>
             <a:ext cx="822960" cy="822960"/>
           </a:xfrm>
           <a:prstGeom prst="triangle">
@@ -5206,7 +6239,7 @@
       </p:sp>
       <p:sp>
         <p:nvSpPr>
-          <p:cNvPr id="10" name="fetal-1-rule"/>
+          <p:cNvPr id="18" name="fetal-1-rule"/>
           <p:cNvSpPr/>
           <p:nvPr/>
         </p:nvSpPr>
@@ -5229,7 +6262,7 @@
       </p:sp>
       <p:sp>
         <p:nvSpPr>
-          <p:cNvPr id="11" name="Text 9"/>
+          <p:cNvPr id="19" name="Text 17"/>
           <p:cNvSpPr txBox="1"/>
           <p:nvPr/>
         </p:nvSpPr>
@@ -5265,7 +6298,7 @@
       </p:sp>
       <p:sp>
         <p:nvSpPr>
-          <p:cNvPr id="12" name="Text 10"/>
+          <p:cNvPr id="20" name="Text 18"/>
           <p:cNvSpPr txBox="1"/>
           <p:nvPr/>
         </p:nvSpPr>
@@ -5341,13 +6374,13 @@
       </p:sp>
       <p:sp>
         <p:nvSpPr>
-          <p:cNvPr id="13" name="fetal-2-decor"/>
+          <p:cNvPr id="21" name="fetal-2-decor"/>
           <p:cNvSpPr/>
           <p:nvPr/>
         </p:nvSpPr>
         <p:spPr>
           <a:xfrm>
-            <a:off x="7818120" y="3154680"/>
+            <a:off x="7818120" y="1920240"/>
             <a:ext cx="822960" cy="822960"/>
           </a:xfrm>
           <a:prstGeom prst="rect">
@@ -5363,7 +6396,7 @@
       </p:sp>
       <p:sp>
         <p:nvSpPr>
-          <p:cNvPr id="14" name="fetal-2-rule"/>
+          <p:cNvPr id="22" name="fetal-2-rule"/>
           <p:cNvSpPr/>
           <p:nvPr/>
         </p:nvSpPr>
@@ -5386,7 +6419,7 @@
       </p:sp>
       <p:sp>
         <p:nvSpPr>
-          <p:cNvPr id="15" name="Text 13"/>
+          <p:cNvPr id="23" name="Text 21"/>
           <p:cNvSpPr txBox="1"/>
           <p:nvPr/>
         </p:nvSpPr>
@@ -5422,7 +6455,7 @@
       </p:sp>
       <p:sp>
         <p:nvSpPr>
-          <p:cNvPr id="16" name="Text 14"/>
+          <p:cNvPr id="24" name="Text 22"/>
           <p:cNvSpPr txBox="1"/>
           <p:nvPr/>
         </p:nvSpPr>
@@ -5480,7 +6513,7 @@
       </p:sp>
       <p:sp>
         <p:nvSpPr>
-          <p:cNvPr id="17" name="Text 15"/>
+          <p:cNvPr id="25" name="Text 23"/>
           <p:cNvSpPr txBox="1"/>
           <p:nvPr/>
         </p:nvSpPr>
@@ -5527,7 +6560,7 @@
       </p:sp>
       <p:sp>
         <p:nvSpPr>
-          <p:cNvPr id="18" name="source"/>
+          <p:cNvPr id="26" name="source"/>
           <p:cNvSpPr txBox="1"/>
           <p:nvPr/>
         </p:nvSpPr>

</xml_diff>

<commit_message>
Redraw cesarean diagrams as anatomical freeform shapes
Co-Authored-By: Claude Opus 5.5 <noreply@anthropic.com>
Claude-Session: https://claude.ai/code/session_017AawXZuegeVsAfmgt6D2q5
</commit_message>
<xml_diff>
--- a/slides/⑤帝王切開.pptx
+++ b/slides/⑤帝王切開.pptx
@@ -111,7 +111,7 @@
   <p:extLst>
     <p:ext uri="{521415D9-36F7-43E2-AB2F-B90AF26B5E84}">
       <p14:sectionLst xmlns:p14="http://schemas.microsoft.com/office/powerpoint/2010/main">
-        <p14:section name="⑤ 帝王切開" id="{eba56d53-10e0-4721-bb42-8b4229815822}">
+        <p14:section name="⑤ 帝王切開" id="{ffed8d54-4567-c319-91d1-49ba2e48d90f}">
           <p14:sldIdLst>
             <p14:sldId id="256"/>
             <p14:sldId id="257"/>
@@ -799,7 +799,7 @@
               <a:rPr lang="en-US" dirty="0"/>
               <a:t>帝王切開は安全性が高くなった手術ですが、開腹手術である以上、経腟分娩にはないリスクがあります。
 母体では、出血、創部感染や子宮内膜炎、そして特に重要なのが静脈血栓塞栓症です。妊娠中は血液が固まりやすく、術後の安静でさらにリスクが上がるため、早期離床・弾性ストッキング・間欠的空気圧迫法、必要に応じて抗凝固療法で予防します。また癒着や術後の麻痺性イレウスもみられます。
-次回の妊娠では、帝王切開後に経腟分娩を試みる（TOLAC）と約0.5〜1%で子宮破裂が起こるとされ、十分な説明と体制のもとで行います。また前置胎盤・癒着胎盤や、帝王切開の傷あとに着床する瘢痕部妊娠のリスクも高まります。
+次回の妊娠では、帝王切開後に経腟分娩を試みる（TOLAC）と約0.5〜1%で子宮破裂が起こるとされ、十分な説明と体制のもとで行います。また前置胎盤・癒着胎盤や、帝王切開の傷あとに着床する瘢痕部妊娠のリスクも高まります。右の図は次の妊娠の子宮の断面で、お腹側の子宮下部にある前回の傷あと（瘢痕）に胎盤が付着し、薄くなった筋層に入り込んでいる状態（前置癒着胎盤）を示しています。膀胱にまで及ぶと大量出血や膀胱損傷の危険があります。
 赤ちゃん側では、陣痛を経ずに生まれると肺の水の吸収が遅れ、新生児一過性多呼吸が起こりやすくなります。予定帝王切開を38週前後まで待つ理由の一つです。</a:t>
             </a:r>
             <a:endParaRPr lang="en-US" dirty="0"/>
@@ -1640,12 +1640,34 @@
         </p:nvSpPr>
         <p:spPr>
           <a:xfrm>
-            <a:off x="475488" y="2862072"/>
-            <a:ext cx="265176" cy="265176"/>
-          </a:xfrm>
-          <a:prstGeom prst="round2SameRect">
-            <a:avLst/>
-          </a:prstGeom>
+            <a:off x="466344" y="2852928"/>
+            <a:ext cx="283464" cy="274320"/>
+          </a:xfrm>
+          <a:custGeom>
+            <a:avLst/>
+            <a:gdLst/>
+            <a:ahLst/>
+            <a:cxnLst/>
+            <a:rect l="l" t="t" r="r" b="b"/>
+            <a:pathLst>
+              <a:path w="283464" h="274320">
+                <a:moveTo>
+                  <a:pt x="0" y="274320"/>
+                </a:moveTo>
+                <a:cubicBezTo>
+                  <a:pt x="0" y="96012"/>
+                  <a:pt x="56693" y="13716"/>
+                  <a:pt x="141732" y="13716"/>
+                </a:cubicBezTo>
+                <a:cubicBezTo>
+                  <a:pt x="226771" y="13716"/>
+                  <a:pt x="283464" y="96012"/>
+                  <a:pt x="283464" y="274320"/>
+                </a:cubicBezTo>
+                <a:close/>
+              </a:path>
+            </a:pathLst>
+          </a:custGeom>
           <a:solidFill>
             <a:schemeClr val="tx2"/>
           </a:solidFill>
@@ -1680,12 +1702,34 @@
         </p:nvSpPr>
         <p:spPr>
           <a:xfrm>
-            <a:off x="886968" y="2862072"/>
-            <a:ext cx="265176" cy="265176"/>
-          </a:xfrm>
-          <a:prstGeom prst="round2SameRect">
-            <a:avLst/>
-          </a:prstGeom>
+            <a:off x="877824" y="2852928"/>
+            <a:ext cx="283464" cy="274320"/>
+          </a:xfrm>
+          <a:custGeom>
+            <a:avLst/>
+            <a:gdLst/>
+            <a:ahLst/>
+            <a:cxnLst/>
+            <a:rect l="l" t="t" r="r" b="b"/>
+            <a:pathLst>
+              <a:path w="283464" h="274320">
+                <a:moveTo>
+                  <a:pt x="0" y="274320"/>
+                </a:moveTo>
+                <a:cubicBezTo>
+                  <a:pt x="0" y="96012"/>
+                  <a:pt x="56693" y="13716"/>
+                  <a:pt x="141732" y="13716"/>
+                </a:cubicBezTo>
+                <a:cubicBezTo>
+                  <a:pt x="226771" y="13716"/>
+                  <a:pt x="283464" y="96012"/>
+                  <a:pt x="283464" y="274320"/>
+                </a:cubicBezTo>
+                <a:close/>
+              </a:path>
+            </a:pathLst>
+          </a:custGeom>
           <a:solidFill>
             <a:srgbClr val="A6A6A6"/>
           </a:solidFill>
@@ -1720,12 +1764,34 @@
         </p:nvSpPr>
         <p:spPr>
           <a:xfrm>
-            <a:off x="1298448" y="2862072"/>
-            <a:ext cx="265176" cy="265176"/>
-          </a:xfrm>
-          <a:prstGeom prst="round2SameRect">
-            <a:avLst/>
-          </a:prstGeom>
+            <a:off x="1289304" y="2852928"/>
+            <a:ext cx="283464" cy="274320"/>
+          </a:xfrm>
+          <a:custGeom>
+            <a:avLst/>
+            <a:gdLst/>
+            <a:ahLst/>
+            <a:cxnLst/>
+            <a:rect l="l" t="t" r="r" b="b"/>
+            <a:pathLst>
+              <a:path w="283464" h="274320">
+                <a:moveTo>
+                  <a:pt x="0" y="274320"/>
+                </a:moveTo>
+                <a:cubicBezTo>
+                  <a:pt x="0" y="96012"/>
+                  <a:pt x="56693" y="13716"/>
+                  <a:pt x="141732" y="13716"/>
+                </a:cubicBezTo>
+                <a:cubicBezTo>
+                  <a:pt x="226771" y="13716"/>
+                  <a:pt x="283464" y="96012"/>
+                  <a:pt x="283464" y="274320"/>
+                </a:cubicBezTo>
+                <a:close/>
+              </a:path>
+            </a:pathLst>
+          </a:custGeom>
           <a:solidFill>
             <a:srgbClr val="A6A6A6"/>
           </a:solidFill>
@@ -1760,12 +1826,34 @@
         </p:nvSpPr>
         <p:spPr>
           <a:xfrm>
-            <a:off x="1709928" y="2862072"/>
-            <a:ext cx="265176" cy="265176"/>
-          </a:xfrm>
-          <a:prstGeom prst="round2SameRect">
-            <a:avLst/>
-          </a:prstGeom>
+            <a:off x="1700784" y="2852928"/>
+            <a:ext cx="283464" cy="274320"/>
+          </a:xfrm>
+          <a:custGeom>
+            <a:avLst/>
+            <a:gdLst/>
+            <a:ahLst/>
+            <a:cxnLst/>
+            <a:rect l="l" t="t" r="r" b="b"/>
+            <a:pathLst>
+              <a:path w="283464" h="274320">
+                <a:moveTo>
+                  <a:pt x="0" y="274320"/>
+                </a:moveTo>
+                <a:cubicBezTo>
+                  <a:pt x="0" y="96012"/>
+                  <a:pt x="56693" y="13716"/>
+                  <a:pt x="141732" y="13716"/>
+                </a:cubicBezTo>
+                <a:cubicBezTo>
+                  <a:pt x="226771" y="13716"/>
+                  <a:pt x="283464" y="96012"/>
+                  <a:pt x="283464" y="274320"/>
+                </a:cubicBezTo>
+                <a:close/>
+              </a:path>
+            </a:pathLst>
+          </a:custGeom>
           <a:solidFill>
             <a:srgbClr val="A6A6A6"/>
           </a:solidFill>
@@ -1800,12 +1888,34 @@
         </p:nvSpPr>
         <p:spPr>
           <a:xfrm>
-            <a:off x="2121408" y="2862072"/>
-            <a:ext cx="265176" cy="265176"/>
-          </a:xfrm>
-          <a:prstGeom prst="round2SameRect">
-            <a:avLst/>
-          </a:prstGeom>
+            <a:off x="2112264" y="2852928"/>
+            <a:ext cx="283464" cy="274320"/>
+          </a:xfrm>
+          <a:custGeom>
+            <a:avLst/>
+            <a:gdLst/>
+            <a:ahLst/>
+            <a:cxnLst/>
+            <a:rect l="l" t="t" r="r" b="b"/>
+            <a:pathLst>
+              <a:path w="283464" h="274320">
+                <a:moveTo>
+                  <a:pt x="0" y="274320"/>
+                </a:moveTo>
+                <a:cubicBezTo>
+                  <a:pt x="0" y="96012"/>
+                  <a:pt x="56693" y="13716"/>
+                  <a:pt x="141732" y="13716"/>
+                </a:cubicBezTo>
+                <a:cubicBezTo>
+                  <a:pt x="226771" y="13716"/>
+                  <a:pt x="283464" y="96012"/>
+                  <a:pt x="283464" y="274320"/>
+                </a:cubicBezTo>
+                <a:close/>
+              </a:path>
+            </a:pathLst>
+          </a:custGeom>
           <a:solidFill>
             <a:srgbClr val="A6A6A6"/>
           </a:solidFill>
@@ -3896,7 +4006,7 @@
         </p:nvSpPr>
         <p:spPr>
           <a:xfrm>
-            <a:off x="3566160" y="2560320"/>
+            <a:off x="2651760" y="2560320"/>
             <a:ext cx="822960" cy="822960"/>
           </a:xfrm>
           <a:prstGeom prst="ellipse">
@@ -3919,7 +4029,7 @@
         <p:spPr>
           <a:xfrm>
             <a:off x="457200" y="4572000"/>
-            <a:ext cx="3977640" cy="0"/>
+            <a:ext cx="3063240" cy="0"/>
           </a:xfrm>
           <a:prstGeom prst="line">
             <a:avLst/>
@@ -3942,7 +4052,7 @@
         <p:spPr>
           <a:xfrm>
             <a:off x="457200" y="2532888"/>
-            <a:ext cx="3886200" cy="384048"/>
+            <a:ext cx="2971800" cy="384048"/>
           </a:xfrm>
           <a:prstGeom prst="rect">
             <a:avLst/>
@@ -3978,7 +4088,7 @@
         <p:spPr>
           <a:xfrm>
             <a:off x="457200" y="3017520"/>
-            <a:ext cx="3840480" cy="1371600"/>
+            <a:ext cx="3017520" cy="1463040"/>
           </a:xfrm>
           <a:prstGeom prst="rect">
             <a:avLst/>
@@ -4080,8 +4190,8 @@
         </p:nvSpPr>
         <p:spPr>
           <a:xfrm>
-            <a:off x="4709160" y="4572000"/>
-            <a:ext cx="3977640" cy="0"/>
+            <a:off x="3749040" y="4572000"/>
+            <a:ext cx="4937760" cy="0"/>
           </a:xfrm>
           <a:prstGeom prst="line">
             <a:avLst/>
@@ -4103,8 +4213,8 @@
         </p:nvSpPr>
         <p:spPr>
           <a:xfrm>
-            <a:off x="4709160" y="2532888"/>
-            <a:ext cx="3886200" cy="384048"/>
+            <a:off x="3749040" y="2532888"/>
+            <a:ext cx="4846320" cy="384048"/>
           </a:xfrm>
           <a:prstGeom prst="rect">
             <a:avLst/>
@@ -4139,8 +4249,8 @@
         </p:nvSpPr>
         <p:spPr>
           <a:xfrm>
-            <a:off x="4709160" y="2971800"/>
-            <a:ext cx="731520" cy="237744"/>
+            <a:off x="3794760" y="2944368"/>
+            <a:ext cx="1051560" cy="219456"/>
           </a:xfrm>
           <a:prstGeom prst="rect">
             <a:avLst/>
@@ -4175,20 +4285,72 @@
         </p:nvSpPr>
         <p:spPr>
           <a:xfrm>
-            <a:off x="4709160" y="3291840"/>
-            <a:ext cx="731520" cy="1143000"/>
-          </a:xfrm>
-          <a:prstGeom prst="roundRect">
-            <a:avLst>
-              <a:gd name="adj" fmla="val 37500"/>
-            </a:avLst>
-          </a:prstGeom>
+            <a:off x="3794760" y="3200400"/>
+            <a:ext cx="1051560" cy="1325880"/>
+          </a:xfrm>
+          <a:custGeom>
+            <a:avLst/>
+            <a:gdLst/>
+            <a:ahLst/>
+            <a:cxnLst/>
+            <a:rect l="l" t="t" r="r" b="b"/>
+            <a:pathLst>
+              <a:path w="1051560" h="1325880">
+                <a:moveTo>
+                  <a:pt x="157734" y="0"/>
+                </a:moveTo>
+                <a:cubicBezTo>
+                  <a:pt x="126187" y="159106"/>
+                  <a:pt x="94640" y="291694"/>
+                  <a:pt x="105156" y="424282"/>
+                </a:cubicBezTo>
+                <a:cubicBezTo>
+                  <a:pt x="105156" y="596646"/>
+                  <a:pt x="0" y="769010"/>
+                  <a:pt x="10516" y="981151"/>
+                </a:cubicBezTo>
+                <a:lnTo>
+                  <a:pt x="42062" y="1325880"/>
+                </a:lnTo>
+                <a:lnTo>
+                  <a:pt x="494233" y="1325880"/>
+                </a:lnTo>
+                <a:cubicBezTo>
+                  <a:pt x="504749" y="1233068"/>
+                  <a:pt x="515264" y="1166774"/>
+                  <a:pt x="525780" y="1153516"/>
+                </a:cubicBezTo>
+                <a:cubicBezTo>
+                  <a:pt x="536296" y="1166774"/>
+                  <a:pt x="546811" y="1233068"/>
+                  <a:pt x="557327" y="1325880"/>
+                </a:cubicBezTo>
+                <a:lnTo>
+                  <a:pt x="1009498" y="1325880"/>
+                </a:lnTo>
+                <a:lnTo>
+                  <a:pt x="1041044" y="981151"/>
+                </a:lnTo>
+                <a:cubicBezTo>
+                  <a:pt x="1051560" y="769010"/>
+                  <a:pt x="946404" y="596646"/>
+                  <a:pt x="946404" y="424282"/>
+                </a:cubicBezTo>
+                <a:cubicBezTo>
+                  <a:pt x="956920" y="291694"/>
+                  <a:pt x="925373" y="159106"/>
+                  <a:pt x="893826" y="0"/>
+                </a:cubicBezTo>
+                <a:close/>
+              </a:path>
+            </a:pathLst>
+          </a:custGeom>
           <a:solidFill>
-            <a:schemeClr val="bg1"/>
+            <a:srgbClr val="EDCBB2"/>
           </a:solidFill>
-          <a:ln w="12700">
+          <a:ln w="9525">
             <a:solidFill>
-              <a:srgbClr val="A6A6A6"/>
+              <a:srgbClr val="B5876C"/>
             </a:solidFill>
             <a:prstDash val="solid"/>
           </a:ln>
@@ -4196,62 +4358,166 @@
       </p:sp>
       <p:sp>
         <p:nvSpPr>
-          <p:cNvPr id="37" name="skin-navel"/>
-          <p:cNvSpPr/>
-          <p:nvPr/>
-        </p:nvSpPr>
-        <p:spPr>
-          <a:xfrm>
-            <a:off x="5042916" y="3584448"/>
-            <a:ext cx="64008" cy="64008"/>
+          <p:cNvPr id="37" name="skin-groin-l"/>
+          <p:cNvSpPr/>
+          <p:nvPr/>
+        </p:nvSpPr>
+        <p:spPr>
+          <a:xfrm>
+            <a:off x="3794760" y="3200400"/>
+            <a:ext cx="1051560" cy="1325880"/>
+          </a:xfrm>
+          <a:custGeom>
+            <a:avLst/>
+            <a:gdLst/>
+            <a:ahLst/>
+            <a:cxnLst/>
+            <a:rect l="l" t="t" r="r" b="b"/>
+            <a:pathLst>
+              <a:path w="1051560" h="1325880">
+                <a:moveTo>
+                  <a:pt x="52578" y="822046"/>
+                </a:moveTo>
+                <a:cubicBezTo>
+                  <a:pt x="210312" y="928116"/>
+                  <a:pt x="378562" y="1034186"/>
+                  <a:pt x="494233" y="1193292"/>
+                </a:cubicBezTo>
+              </a:path>
+            </a:pathLst>
+          </a:custGeom>
+          <a:ln w="9525">
+            <a:solidFill>
+              <a:srgbClr val="B5876C"/>
+            </a:solidFill>
+            <a:prstDash val="solid"/>
+          </a:ln>
+        </p:spPr>
+      </p:sp>
+      <p:sp>
+        <p:nvSpPr>
+          <p:cNvPr id="38" name="skin-groin-r"/>
+          <p:cNvSpPr/>
+          <p:nvPr/>
+        </p:nvSpPr>
+        <p:spPr>
+          <a:xfrm>
+            <a:off x="3794760" y="3200400"/>
+            <a:ext cx="1051560" cy="1325880"/>
+          </a:xfrm>
+          <a:custGeom>
+            <a:avLst/>
+            <a:gdLst/>
+            <a:ahLst/>
+            <a:cxnLst/>
+            <a:rect l="l" t="t" r="r" b="b"/>
+            <a:pathLst>
+              <a:path w="1051560" h="1325880">
+                <a:moveTo>
+                  <a:pt x="998982" y="822046"/>
+                </a:moveTo>
+                <a:cubicBezTo>
+                  <a:pt x="841248" y="928116"/>
+                  <a:pt x="672998" y="1034186"/>
+                  <a:pt x="557327" y="1193292"/>
+                </a:cubicBezTo>
+              </a:path>
+            </a:pathLst>
+          </a:custGeom>
+          <a:ln w="9525">
+            <a:solidFill>
+              <a:srgbClr val="B5876C"/>
+            </a:solidFill>
+            <a:prstDash val="solid"/>
+          </a:ln>
+        </p:spPr>
+      </p:sp>
+      <p:sp>
+        <p:nvSpPr>
+          <p:cNvPr id="39" name="skin-navel"/>
+          <p:cNvSpPr/>
+          <p:nvPr/>
+        </p:nvSpPr>
+        <p:spPr>
+          <a:xfrm>
+            <a:off x="4288536" y="3598164"/>
+            <a:ext cx="64008" cy="73152"/>
           </a:xfrm>
           <a:prstGeom prst="ellipse">
             <a:avLst/>
           </a:prstGeom>
           <a:solidFill>
-            <a:srgbClr val="A6A6A6"/>
+            <a:srgbClr val="B5876C"/>
           </a:solidFill>
           <a:ln/>
         </p:spPr>
       </p:sp>
       <p:sp>
         <p:nvSpPr>
-          <p:cNvPr id="38" name="skin-vertical"/>
-          <p:cNvSpPr/>
-          <p:nvPr/>
-        </p:nvSpPr>
-        <p:spPr>
-          <a:xfrm>
-            <a:off x="5074920" y="3730752"/>
-            <a:ext cx="0" cy="530352"/>
-          </a:xfrm>
-          <a:prstGeom prst="line">
-            <a:avLst/>
-          </a:prstGeom>
-          <a:noFill/>
+          <p:cNvPr id="40" name="skin-vertical"/>
+          <p:cNvSpPr/>
+          <p:nvPr/>
+        </p:nvSpPr>
+        <p:spPr>
+          <a:xfrm>
+            <a:off x="3794760" y="3200400"/>
+            <a:ext cx="1051560" cy="1325880"/>
+          </a:xfrm>
+          <a:custGeom>
+            <a:avLst/>
+            <a:gdLst/>
+            <a:ahLst/>
+            <a:cxnLst/>
+            <a:rect l="l" t="t" r="r" b="b"/>
+            <a:pathLst>
+              <a:path w="1051560" h="1325880">
+                <a:moveTo>
+                  <a:pt x="525780" y="503834"/>
+                </a:moveTo>
+                <a:lnTo>
+                  <a:pt x="525780" y="1060704"/>
+                </a:lnTo>
+              </a:path>
+            </a:pathLst>
+          </a:custGeom>
           <a:ln w="31750">
             <a:solidFill>
               <a:srgbClr val="1F7A7A"/>
             </a:solidFill>
-            <a:prstDash val="dash"/>
+            <a:prstDash val="sysDash"/>
           </a:ln>
         </p:spPr>
       </p:sp>
       <p:sp>
         <p:nvSpPr>
-          <p:cNvPr id="39" name="skin-transverse"/>
-          <p:cNvSpPr/>
-          <p:nvPr/>
-        </p:nvSpPr>
-        <p:spPr>
-          <a:xfrm>
-            <a:off x="4873752" y="4206240"/>
-            <a:ext cx="402336" cy="0"/>
-          </a:xfrm>
-          <a:prstGeom prst="line">
-            <a:avLst/>
-          </a:prstGeom>
-          <a:noFill/>
+          <p:cNvPr id="41" name="skin-transverse"/>
+          <p:cNvSpPr/>
+          <p:nvPr/>
+        </p:nvSpPr>
+        <p:spPr>
+          <a:xfrm>
+            <a:off x="3794760" y="3200400"/>
+            <a:ext cx="1051560" cy="1325880"/>
+          </a:xfrm>
+          <a:custGeom>
+            <a:avLst/>
+            <a:gdLst/>
+            <a:ahLst/>
+            <a:cxnLst/>
+            <a:rect l="l" t="t" r="r" b="b"/>
+            <a:pathLst>
+              <a:path w="1051560" h="1325880">
+                <a:moveTo>
+                  <a:pt x="315468" y="928116"/>
+                </a:moveTo>
+                <a:cubicBezTo>
+                  <a:pt x="420624" y="1007669"/>
+                  <a:pt x="630936" y="1007669"/>
+                  <a:pt x="736092" y="928116"/>
+                </a:cubicBezTo>
+              </a:path>
+            </a:pathLst>
+          </a:custGeom>
           <a:ln w="31750">
             <a:solidFill>
               <a:srgbClr val="7A2048"/>
@@ -4262,14 +4528,14 @@
       </p:sp>
       <p:sp>
         <p:nvSpPr>
-          <p:cNvPr id="40" name="Text 38"/>
-          <p:cNvSpPr txBox="1"/>
-          <p:nvPr/>
-        </p:nvSpPr>
-        <p:spPr>
-          <a:xfrm>
-            <a:off x="5577840" y="2971800"/>
-            <a:ext cx="731520" cy="237744"/>
+          <p:cNvPr id="42" name="Text 40"/>
+          <p:cNvSpPr txBox="1"/>
+          <p:nvPr/>
+        </p:nvSpPr>
+        <p:spPr>
+          <a:xfrm>
+            <a:off x="5029200" y="2944368"/>
+            <a:ext cx="1051560" cy="219456"/>
           </a:xfrm>
           <a:prstGeom prst="rect">
             <a:avLst/>
@@ -4298,24 +4564,37 @@
       </p:sp>
       <p:sp>
         <p:nvSpPr>
-          <p:cNvPr id="41" name="ut-inc-cervix"/>
-          <p:cNvSpPr/>
-          <p:nvPr/>
-        </p:nvSpPr>
-        <p:spPr>
-          <a:xfrm>
-            <a:off x="5804611" y="4059022"/>
-            <a:ext cx="277978" cy="288036"/>
-          </a:xfrm>
-          <a:prstGeom prst="rect">
-            <a:avLst/>
-          </a:prstGeom>
-          <a:solidFill>
-            <a:schemeClr val="bg1"/>
-          </a:solidFill>
-          <a:ln w="12700">
+          <p:cNvPr id="43" name="ut-tube-l"/>
+          <p:cNvSpPr/>
+          <p:nvPr/>
+        </p:nvSpPr>
+        <p:spPr>
+          <a:xfrm>
+            <a:off x="5029200" y="3200400"/>
+            <a:ext cx="1051560" cy="1325880"/>
+          </a:xfrm>
+          <a:custGeom>
+            <a:avLst/>
+            <a:gdLst/>
+            <a:ahLst/>
+            <a:cxnLst/>
+            <a:rect l="l" t="t" r="r" b="b"/>
+            <a:pathLst>
+              <a:path w="1051560" h="1325880">
+                <a:moveTo>
+                  <a:pt x="168250" y="238658"/>
+                </a:moveTo>
+                <a:cubicBezTo>
+                  <a:pt x="105156" y="172364"/>
+                  <a:pt x="63094" y="198882"/>
+                  <a:pt x="31547" y="291694"/>
+                </a:cubicBezTo>
+              </a:path>
+            </a:pathLst>
+          </a:custGeom>
+          <a:ln w="19050">
             <a:solidFill>
-              <a:srgbClr val="A6A6A6"/>
+              <a:srgbClr val="8E4F57"/>
             </a:solidFill>
             <a:prstDash val="solid"/>
           </a:ln>
@@ -4323,24 +4602,37 @@
       </p:sp>
       <p:sp>
         <p:nvSpPr>
-          <p:cNvPr id="42" name="ut-inc-body"/>
-          <p:cNvSpPr/>
-          <p:nvPr/>
-        </p:nvSpPr>
-        <p:spPr>
-          <a:xfrm>
-            <a:off x="5577840" y="3310128"/>
-            <a:ext cx="731520" cy="844906"/>
-          </a:xfrm>
-          <a:prstGeom prst="ellipse">
-            <a:avLst/>
-          </a:prstGeom>
-          <a:solidFill>
-            <a:schemeClr val="bg1"/>
-          </a:solidFill>
-          <a:ln w="12700">
+          <p:cNvPr id="44" name="ut-tube-r"/>
+          <p:cNvSpPr/>
+          <p:nvPr/>
+        </p:nvSpPr>
+        <p:spPr>
+          <a:xfrm>
+            <a:off x="5029200" y="3200400"/>
+            <a:ext cx="1051560" cy="1325880"/>
+          </a:xfrm>
+          <a:custGeom>
+            <a:avLst/>
+            <a:gdLst/>
+            <a:ahLst/>
+            <a:cxnLst/>
+            <a:rect l="l" t="t" r="r" b="b"/>
+            <a:pathLst>
+              <a:path w="1051560" h="1325880">
+                <a:moveTo>
+                  <a:pt x="883310" y="238658"/>
+                </a:moveTo>
+                <a:cubicBezTo>
+                  <a:pt x="946404" y="172364"/>
+                  <a:pt x="988466" y="198882"/>
+                  <a:pt x="1020013" y="291694"/>
+                </a:cubicBezTo>
+              </a:path>
+            </a:pathLst>
+          </a:custGeom>
+          <a:ln w="19050">
             <a:solidFill>
-              <a:srgbClr val="A6A6A6"/>
+              <a:srgbClr val="8E4F57"/>
             </a:solidFill>
             <a:prstDash val="solid"/>
           </a:ln>
@@ -4348,42 +4640,224 @@
       </p:sp>
       <p:sp>
         <p:nvSpPr>
-          <p:cNvPr id="43" name="ut-classical"/>
-          <p:cNvSpPr/>
-          <p:nvPr/>
-        </p:nvSpPr>
-        <p:spPr>
-          <a:xfrm>
-            <a:off x="5943600" y="3429000"/>
-            <a:ext cx="0" cy="411480"/>
-          </a:xfrm>
-          <a:prstGeom prst="line">
-            <a:avLst/>
-          </a:prstGeom>
-          <a:noFill/>
+          <p:cNvPr id="45" name="ut-body"/>
+          <p:cNvSpPr/>
+          <p:nvPr/>
+        </p:nvSpPr>
+        <p:spPr>
+          <a:xfrm>
+            <a:off x="5029200" y="3200400"/>
+            <a:ext cx="1051560" cy="1325880"/>
+          </a:xfrm>
+          <a:custGeom>
+            <a:avLst/>
+            <a:gdLst/>
+            <a:ahLst/>
+            <a:cxnLst/>
+            <a:rect l="l" t="t" r="r" b="b"/>
+            <a:pathLst>
+              <a:path w="1051560" h="1325880">
+                <a:moveTo>
+                  <a:pt x="525780" y="53035"/>
+                </a:moveTo>
+                <a:cubicBezTo>
+                  <a:pt x="820217" y="53035"/>
+                  <a:pt x="946404" y="265176"/>
+                  <a:pt x="935888" y="556870"/>
+                </a:cubicBezTo>
+                <a:cubicBezTo>
+                  <a:pt x="925373" y="795528"/>
+                  <a:pt x="841248" y="954634"/>
+                  <a:pt x="694030" y="1060704"/>
+                </a:cubicBezTo>
+                <a:cubicBezTo>
+                  <a:pt x="630936" y="1100480"/>
+                  <a:pt x="609905" y="1153516"/>
+                  <a:pt x="609905" y="1206551"/>
+                </a:cubicBezTo>
+                <a:lnTo>
+                  <a:pt x="609905" y="1312621"/>
+                </a:lnTo>
+                <a:lnTo>
+                  <a:pt x="441655" y="1312621"/>
+                </a:lnTo>
+                <a:lnTo>
+                  <a:pt x="441655" y="1206551"/>
+                </a:lnTo>
+                <a:cubicBezTo>
+                  <a:pt x="441655" y="1153516"/>
+                  <a:pt x="420624" y="1100480"/>
+                  <a:pt x="357530" y="1060704"/>
+                </a:cubicBezTo>
+                <a:cubicBezTo>
+                  <a:pt x="210312" y="954634"/>
+                  <a:pt x="126187" y="795528"/>
+                  <a:pt x="115672" y="556870"/>
+                </a:cubicBezTo>
+                <a:cubicBezTo>
+                  <a:pt x="105156" y="265176"/>
+                  <a:pt x="231343" y="53035"/>
+                  <a:pt x="525780" y="53035"/>
+                </a:cubicBezTo>
+                <a:close/>
+              </a:path>
+            </a:pathLst>
+          </a:custGeom>
+          <a:solidFill>
+            <a:srgbClr val="D49498"/>
+          </a:solidFill>
+          <a:ln w="9525">
+            <a:solidFill>
+              <a:srgbClr val="8E4F57"/>
+            </a:solidFill>
+            <a:prstDash val="solid"/>
+          </a:ln>
+        </p:spPr>
+      </p:sp>
+      <p:sp>
+        <p:nvSpPr>
+          <p:cNvPr id="46" name="ut-bladder"/>
+          <p:cNvSpPr/>
+          <p:nvPr/>
+        </p:nvSpPr>
+        <p:spPr>
+          <a:xfrm>
+            <a:off x="5029200" y="3200400"/>
+            <a:ext cx="1051560" cy="1325880"/>
+          </a:xfrm>
+          <a:custGeom>
+            <a:avLst/>
+            <a:gdLst/>
+            <a:ahLst/>
+            <a:cxnLst/>
+            <a:rect l="l" t="t" r="r" b="b"/>
+            <a:pathLst>
+              <a:path w="1051560" h="1325880">
+                <a:moveTo>
+                  <a:pt x="294437" y="1325880"/>
+                </a:moveTo>
+                <a:cubicBezTo>
+                  <a:pt x="294437" y="1140257"/>
+                  <a:pt x="757123" y="1140257"/>
+                  <a:pt x="757123" y="1325880"/>
+                </a:cubicBezTo>
+                <a:close/>
+              </a:path>
+            </a:pathLst>
+          </a:custGeom>
+          <a:solidFill>
+            <a:srgbClr val="E2C46E"/>
+          </a:solidFill>
+          <a:ln w="9525">
+            <a:solidFill>
+              <a:srgbClr val="A88A3A"/>
+            </a:solidFill>
+            <a:prstDash val="solid"/>
+          </a:ln>
+        </p:spPr>
+      </p:sp>
+      <p:sp>
+        <p:nvSpPr>
+          <p:cNvPr id="47" name="Text 45"/>
+          <p:cNvSpPr txBox="1"/>
+          <p:nvPr/>
+        </p:nvSpPr>
+        <p:spPr>
+          <a:xfrm>
+            <a:off x="5344668" y="4380433"/>
+            <a:ext cx="420624" cy="145847"/>
+          </a:xfrm>
+          <a:prstGeom prst="rect">
+            <a:avLst/>
+          </a:prstGeom>
+          <a:noFill/>
+          <a:ln/>
+        </p:spPr>
+        <p:txBody>
+          <a:bodyPr wrap="square" lIns="0" tIns="0" rIns="0" bIns="0" rtlCol="0" anchor="ctr"/>
+          <a:lstStyle/>
+          <a:p>
+            <a:pPr algn="ctr" indent="0" marL="0">
+              <a:buNone/>
+            </a:pPr>
+            <a:r>
+              <a:rPr lang="en-US" sz="1200" dirty="0">
+                <a:solidFill>
+                  <a:schemeClr val="tx1"/>
+                </a:solidFill>
+              </a:rPr>
+              <a:t>膀胱</a:t>
+            </a:r>
+            <a:endParaRPr lang="en-US" sz="1200" dirty="0"/>
+          </a:p>
+        </p:txBody>
+      </p:sp>
+      <p:sp>
+        <p:nvSpPr>
+          <p:cNvPr id="48" name="ut-classical"/>
+          <p:cNvSpPr/>
+          <p:nvPr/>
+        </p:nvSpPr>
+        <p:spPr>
+          <a:xfrm>
+            <a:off x="5029200" y="3200400"/>
+            <a:ext cx="1051560" cy="1325880"/>
+          </a:xfrm>
+          <a:custGeom>
+            <a:avLst/>
+            <a:gdLst/>
+            <a:ahLst/>
+            <a:cxnLst/>
+            <a:rect l="l" t="t" r="r" b="b"/>
+            <a:pathLst>
+              <a:path w="1051560" h="1325880">
+                <a:moveTo>
+                  <a:pt x="525780" y="185623"/>
+                </a:moveTo>
+                <a:lnTo>
+                  <a:pt x="525780" y="742493"/>
+                </a:lnTo>
+              </a:path>
+            </a:pathLst>
+          </a:custGeom>
           <a:ln w="31750">
             <a:solidFill>
               <a:srgbClr val="1F7A7A"/>
             </a:solidFill>
-            <a:prstDash val="dash"/>
+            <a:prstDash val="sysDash"/>
           </a:ln>
         </p:spPr>
       </p:sp>
       <p:sp>
         <p:nvSpPr>
-          <p:cNvPr id="44" name="ut-lowtransverse"/>
-          <p:cNvSpPr/>
-          <p:nvPr/>
-        </p:nvSpPr>
-        <p:spPr>
-          <a:xfrm>
-            <a:off x="5733288" y="4005072"/>
-            <a:ext cx="420624" cy="0"/>
-          </a:xfrm>
-          <a:prstGeom prst="line">
-            <a:avLst/>
-          </a:prstGeom>
-          <a:noFill/>
+          <p:cNvPr id="49" name="ut-lowtransverse"/>
+          <p:cNvSpPr/>
+          <p:nvPr/>
+        </p:nvSpPr>
+        <p:spPr>
+          <a:xfrm>
+            <a:off x="5029200" y="3200400"/>
+            <a:ext cx="1051560" cy="1325880"/>
+          </a:xfrm>
+          <a:custGeom>
+            <a:avLst/>
+            <a:gdLst/>
+            <a:ahLst/>
+            <a:cxnLst/>
+            <a:rect l="l" t="t" r="r" b="b"/>
+            <a:pathLst>
+              <a:path w="1051560" h="1325880">
+                <a:moveTo>
+                  <a:pt x="304952" y="981151"/>
+                </a:moveTo>
+                <a:cubicBezTo>
+                  <a:pt x="420624" y="1047445"/>
+                  <a:pt x="630936" y="1047445"/>
+                  <a:pt x="746608" y="981151"/>
+                </a:cubicBezTo>
+              </a:path>
+            </a:pathLst>
+          </a:custGeom>
           <a:ln w="31750">
             <a:solidFill>
               <a:srgbClr val="7A2048"/>
@@ -4394,13 +4868,13 @@
       </p:sp>
       <p:sp>
         <p:nvSpPr>
-          <p:cNvPr id="45" name="leg-trans-key"/>
-          <p:cNvSpPr/>
-          <p:nvPr/>
-        </p:nvSpPr>
-        <p:spPr>
-          <a:xfrm>
-            <a:off x="6446520" y="3090672"/>
+          <p:cNvPr id="50" name="leg-trans-key"/>
+          <p:cNvSpPr/>
+          <p:nvPr/>
+        </p:nvSpPr>
+        <p:spPr>
+          <a:xfrm>
+            <a:off x="6263640" y="3090672"/>
             <a:ext cx="274320" cy="0"/>
           </a:xfrm>
           <a:prstGeom prst="line">
@@ -4417,14 +4891,14 @@
       </p:sp>
       <p:sp>
         <p:nvSpPr>
-          <p:cNvPr id="46" name="Text 44"/>
-          <p:cNvSpPr txBox="1"/>
-          <p:nvPr/>
-        </p:nvSpPr>
-        <p:spPr>
-          <a:xfrm>
-            <a:off x="6793992" y="2971800"/>
-            <a:ext cx="1892808" cy="237744"/>
+          <p:cNvPr id="51" name="Text 49"/>
+          <p:cNvSpPr txBox="1"/>
+          <p:nvPr/>
+        </p:nvSpPr>
+        <p:spPr>
+          <a:xfrm>
+            <a:off x="6611112" y="2971800"/>
+            <a:ext cx="2075688" cy="237744"/>
           </a:xfrm>
           <a:prstGeom prst="rect">
             <a:avLst/>
@@ -4453,14 +4927,14 @@
       </p:sp>
       <p:sp>
         <p:nvSpPr>
-          <p:cNvPr id="47" name="Text 45"/>
-          <p:cNvSpPr txBox="1"/>
-          <p:nvPr/>
-        </p:nvSpPr>
-        <p:spPr>
-          <a:xfrm>
-            <a:off x="6793992" y="3209544"/>
-            <a:ext cx="1892808" cy="237744"/>
+          <p:cNvPr id="52" name="Text 50"/>
+          <p:cNvSpPr txBox="1"/>
+          <p:nvPr/>
+        </p:nvSpPr>
+        <p:spPr>
+          <a:xfrm>
+            <a:off x="6611112" y="3209544"/>
+            <a:ext cx="2075688" cy="237744"/>
           </a:xfrm>
           <a:prstGeom prst="rect">
             <a:avLst/>
@@ -4489,14 +4963,14 @@
       </p:sp>
       <p:sp>
         <p:nvSpPr>
-          <p:cNvPr id="48" name="Text 46"/>
-          <p:cNvSpPr txBox="1"/>
-          <p:nvPr/>
-        </p:nvSpPr>
-        <p:spPr>
-          <a:xfrm>
-            <a:off x="6793992" y="3447288"/>
-            <a:ext cx="1892808" cy="237744"/>
+          <p:cNvPr id="53" name="Text 51"/>
+          <p:cNvSpPr txBox="1"/>
+          <p:nvPr/>
+        </p:nvSpPr>
+        <p:spPr>
+          <a:xfrm>
+            <a:off x="6611112" y="3447288"/>
+            <a:ext cx="2075688" cy="237744"/>
           </a:xfrm>
           <a:prstGeom prst="rect">
             <a:avLst/>
@@ -4525,13 +4999,13 @@
       </p:sp>
       <p:sp>
         <p:nvSpPr>
-          <p:cNvPr id="49" name="leg-vert-key"/>
-          <p:cNvSpPr/>
-          <p:nvPr/>
-        </p:nvSpPr>
-        <p:spPr>
-          <a:xfrm>
-            <a:off x="6446520" y="3886200"/>
+          <p:cNvPr id="54" name="leg-vert-key"/>
+          <p:cNvSpPr/>
+          <p:nvPr/>
+        </p:nvSpPr>
+        <p:spPr>
+          <a:xfrm>
+            <a:off x="6263640" y="3886200"/>
             <a:ext cx="274320" cy="0"/>
           </a:xfrm>
           <a:prstGeom prst="line">
@@ -4548,14 +5022,14 @@
       </p:sp>
       <p:sp>
         <p:nvSpPr>
-          <p:cNvPr id="50" name="Text 48"/>
-          <p:cNvSpPr txBox="1"/>
-          <p:nvPr/>
-        </p:nvSpPr>
-        <p:spPr>
-          <a:xfrm>
-            <a:off x="6793992" y="3767328"/>
-            <a:ext cx="1892808" cy="237744"/>
+          <p:cNvPr id="55" name="Text 53"/>
+          <p:cNvSpPr txBox="1"/>
+          <p:nvPr/>
+        </p:nvSpPr>
+        <p:spPr>
+          <a:xfrm>
+            <a:off x="6611112" y="3767328"/>
+            <a:ext cx="2075688" cy="237744"/>
           </a:xfrm>
           <a:prstGeom prst="rect">
             <a:avLst/>
@@ -4584,14 +5058,14 @@
       </p:sp>
       <p:sp>
         <p:nvSpPr>
-          <p:cNvPr id="51" name="Text 49"/>
-          <p:cNvSpPr txBox="1"/>
-          <p:nvPr/>
-        </p:nvSpPr>
-        <p:spPr>
-          <a:xfrm>
-            <a:off x="6793992" y="4005072"/>
-            <a:ext cx="1892808" cy="237744"/>
+          <p:cNvPr id="56" name="Text 54"/>
+          <p:cNvSpPr txBox="1"/>
+          <p:nvPr/>
+        </p:nvSpPr>
+        <p:spPr>
+          <a:xfrm>
+            <a:off x="6611112" y="4005072"/>
+            <a:ext cx="2075688" cy="237744"/>
           </a:xfrm>
           <a:prstGeom prst="rect">
             <a:avLst/>
@@ -4620,14 +5094,14 @@
       </p:sp>
       <p:sp>
         <p:nvSpPr>
-          <p:cNvPr id="52" name="Text 50"/>
-          <p:cNvSpPr txBox="1"/>
-          <p:nvPr/>
-        </p:nvSpPr>
-        <p:spPr>
-          <a:xfrm>
-            <a:off x="6793992" y="4242816"/>
-            <a:ext cx="1892808" cy="237744"/>
+          <p:cNvPr id="57" name="Text 55"/>
+          <p:cNvSpPr txBox="1"/>
+          <p:nvPr/>
+        </p:nvSpPr>
+        <p:spPr>
+          <a:xfrm>
+            <a:off x="6611112" y="4242816"/>
+            <a:ext cx="2075688" cy="237744"/>
           </a:xfrm>
           <a:prstGeom prst="rect">
             <a:avLst/>
@@ -4656,7 +5130,7 @@
       </p:sp>
       <p:sp>
         <p:nvSpPr>
-          <p:cNvPr id="53" name="source"/>
+          <p:cNvPr id="58" name="source"/>
           <p:cNvSpPr txBox="1"/>
           <p:nvPr/>
         </p:nvSpPr>
@@ -4807,7 +5281,7 @@
         <p:spPr>
           <a:xfrm>
             <a:off x="457200" y="960120"/>
-            <a:ext cx="4572000" cy="320040"/>
+            <a:ext cx="3383280" cy="320040"/>
           </a:xfrm>
           <a:prstGeom prst="rect">
             <a:avLst/>
@@ -4843,7 +5317,7 @@
         <p:spPr>
           <a:xfrm>
             <a:off x="457200" y="1380744"/>
-            <a:ext cx="4480560" cy="274320"/>
+            <a:ext cx="3383280" cy="274320"/>
           </a:xfrm>
           <a:prstGeom prst="rect">
             <a:avLst/>
@@ -4879,7 +5353,7 @@
         <p:spPr>
           <a:xfrm>
             <a:off x="457200" y="1664208"/>
-            <a:ext cx="4526280" cy="457200"/>
+            <a:ext cx="3383280" cy="457200"/>
           </a:xfrm>
           <a:prstGeom prst="rect">
             <a:avLst/>
@@ -4915,7 +5389,7 @@
         <p:spPr>
           <a:xfrm>
             <a:off x="457200" y="2203704"/>
-            <a:ext cx="4480560" cy="274320"/>
+            <a:ext cx="3383280" cy="274320"/>
           </a:xfrm>
           <a:prstGeom prst="rect">
             <a:avLst/>
@@ -4951,7 +5425,7 @@
         <p:spPr>
           <a:xfrm>
             <a:off x="457200" y="2487168"/>
-            <a:ext cx="4526280" cy="457200"/>
+            <a:ext cx="3383280" cy="457200"/>
           </a:xfrm>
           <a:prstGeom prst="rect">
             <a:avLst/>
@@ -4987,7 +5461,7 @@
         <p:spPr>
           <a:xfrm>
             <a:off x="457200" y="3026664"/>
-            <a:ext cx="4480560" cy="274320"/>
+            <a:ext cx="3383280" cy="274320"/>
           </a:xfrm>
           <a:prstGeom prst="rect">
             <a:avLst/>
@@ -5023,7 +5497,7 @@
         <p:spPr>
           <a:xfrm>
             <a:off x="457200" y="3310128"/>
-            <a:ext cx="4526280" cy="457200"/>
+            <a:ext cx="3383280" cy="457200"/>
           </a:xfrm>
           <a:prstGeom prst="rect">
             <a:avLst/>
@@ -5059,7 +5533,7 @@
         <p:spPr>
           <a:xfrm>
             <a:off x="457200" y="3849624"/>
-            <a:ext cx="4480560" cy="274320"/>
+            <a:ext cx="3383280" cy="274320"/>
           </a:xfrm>
           <a:prstGeom prst="rect">
             <a:avLst/>
@@ -5095,7 +5569,7 @@
         <p:spPr>
           <a:xfrm>
             <a:off x="457200" y="4133088"/>
-            <a:ext cx="4526280" cy="457200"/>
+            <a:ext cx="3383280" cy="457200"/>
           </a:xfrm>
           <a:prstGeom prst="rect">
             <a:avLst/>
@@ -5152,8 +5626,8 @@
         </p:nvSpPr>
         <p:spPr>
           <a:xfrm>
-            <a:off x="5303520" y="3703320"/>
-            <a:ext cx="3383280" cy="0"/>
+            <a:off x="4114800" y="3703320"/>
+            <a:ext cx="4572000" cy="0"/>
           </a:xfrm>
           <a:prstGeom prst="line">
             <a:avLst/>
@@ -5175,8 +5649,8 @@
         </p:nvSpPr>
         <p:spPr>
           <a:xfrm>
-            <a:off x="5303520" y="1005840"/>
-            <a:ext cx="3383280" cy="320040"/>
+            <a:off x="4114800" y="1005840"/>
+            <a:ext cx="2194560" cy="320040"/>
           </a:xfrm>
           <a:prstGeom prst="rect">
             <a:avLst/>
@@ -5211,8 +5685,8 @@
         </p:nvSpPr>
         <p:spPr>
           <a:xfrm>
-            <a:off x="5303520" y="1371600"/>
-            <a:ext cx="3383280" cy="548640"/>
+            <a:off x="4114800" y="1325880"/>
+            <a:ext cx="2240280" cy="548640"/>
           </a:xfrm>
           <a:prstGeom prst="rect">
             <a:avLst/>
@@ -5228,14 +5702,14 @@
               <a:buNone/>
             </a:pPr>
             <a:r>
-              <a:rPr lang="en-US" sz="3200" b="1" dirty="0">
+              <a:rPr lang="en-US" sz="2800" b="1" dirty="0">
                 <a:solidFill>
                   <a:schemeClr val="accent3"/>
                 </a:solidFill>
               </a:rPr>
               <a:t>約0.5〜1%</a:t>
             </a:r>
-            <a:endParaRPr lang="en-US" sz="3200" dirty="0"/>
+            <a:endParaRPr lang="en-US" sz="2800" dirty="0"/>
           </a:p>
         </p:txBody>
       </p:sp>
@@ -5247,8 +5721,8 @@
         </p:nvSpPr>
         <p:spPr>
           <a:xfrm>
-            <a:off x="5303520" y="1920240"/>
-            <a:ext cx="3291840" cy="457200"/>
+            <a:off x="4114800" y="1874520"/>
+            <a:ext cx="2194560" cy="457200"/>
           </a:xfrm>
           <a:prstGeom prst="rect">
             <a:avLst/>
@@ -5269,32 +5743,173 @@
                   <a:schemeClr val="tx1"/>
                 </a:solidFill>
               </a:rPr>
-              <a:t>帝王切開後に経腟分娩を試みた時（TOLAC）の子宮破裂</a:t>
+              <a:t>TOLAC（帝王切開後の</a:t>
             </a:r>
             <a:endParaRPr lang="en-US" sz="1300" dirty="0"/>
           </a:p>
-        </p:txBody>
-      </p:sp>
-      <p:sp>
-        <p:nvSpPr>
-          <p:cNvPr id="17" name="ut-scar-cervix"/>
-          <p:cNvSpPr/>
-          <p:nvPr/>
-        </p:nvSpPr>
-        <p:spPr>
-          <a:xfrm>
-            <a:off x="5530291" y="3199486"/>
-            <a:ext cx="277978" cy="288036"/>
-          </a:xfrm>
-          <a:prstGeom prst="rect">
-            <a:avLst/>
-          </a:prstGeom>
+          <a:p>
+            <a:pPr indent="0" marL="0">
+              <a:buNone/>
+            </a:pPr>
+            <a:r>
+              <a:rPr lang="en-US" sz="1300" dirty="0">
+                <a:solidFill>
+                  <a:schemeClr val="tx1"/>
+                </a:solidFill>
+              </a:rPr>
+              <a:t>経腟分娩）での子宮破裂</a:t>
+            </a:r>
+            <a:endParaRPr lang="en-US" sz="1300" dirty="0"/>
+          </a:p>
+        </p:txBody>
+      </p:sp>
+      <p:sp>
+        <p:nvSpPr>
+          <p:cNvPr id="17" name="Text 15"/>
+          <p:cNvSpPr txBox="1"/>
+          <p:nvPr/>
+        </p:nvSpPr>
+        <p:spPr>
+          <a:xfrm>
+            <a:off x="4114800" y="2450592"/>
+            <a:ext cx="2194560" cy="1188720"/>
+          </a:xfrm>
+          <a:prstGeom prst="rect">
+            <a:avLst/>
+          </a:prstGeom>
+          <a:noFill/>
+          <a:ln/>
+        </p:spPr>
+        <p:txBody>
+          <a:bodyPr wrap="square" lIns="0" tIns="0" rIns="0" bIns="0" rtlCol="0" anchor="t"/>
+          <a:lstStyle/>
+          <a:p>
+            <a:pPr marL="152400" indent="-152400">
+              <a:spcAft>
+                <a:spcPts val="300"/>
+              </a:spcAft>
+              <a:buSzPct val="100000"/>
+              <a:buChar char="•"/>
+            </a:pPr>
+            <a:r>
+              <a:rPr lang="en-US" sz="1300" dirty="0">
+                <a:solidFill>
+                  <a:schemeClr val="tx1"/>
+                </a:solidFill>
+              </a:rPr>
+              <a:t>瘢痕が裂ける→子宮破裂</a:t>
+            </a:r>
+            <a:endParaRPr lang="en-US" sz="1300" dirty="0"/>
+          </a:p>
+          <a:p>
+            <a:pPr marL="152400" indent="-152400">
+              <a:spcAft>
+                <a:spcPts val="300"/>
+              </a:spcAft>
+              <a:buSzPct val="100000"/>
+              <a:buChar char="•"/>
+            </a:pPr>
+            <a:r>
+              <a:rPr lang="en-US" sz="1300" dirty="0">
+                <a:solidFill>
+                  <a:schemeClr val="tx1"/>
+                </a:solidFill>
+              </a:rPr>
+              <a:t>瘢痕に胎盤→前置癒着胎盤</a:t>
+            </a:r>
+            <a:endParaRPr lang="en-US" sz="1300" dirty="0"/>
+          </a:p>
+          <a:p>
+            <a:pPr marL="152400" indent="-152400">
+              <a:spcAft>
+                <a:spcPts val="300"/>
+              </a:spcAft>
+              <a:buSzPct val="100000"/>
+              <a:buChar char="•"/>
+            </a:pPr>
+            <a:r>
+              <a:rPr lang="en-US" sz="1300" dirty="0">
+                <a:solidFill>
+                  <a:schemeClr val="tx1"/>
+                </a:solidFill>
+              </a:rPr>
+              <a:t>瘢痕に着床→瘢痕部妊娠</a:t>
+            </a:r>
+            <a:endParaRPr lang="en-US" sz="1300" dirty="0"/>
+          </a:p>
+        </p:txBody>
+      </p:sp>
+      <p:sp>
+        <p:nvSpPr>
+          <p:cNvPr id="18" name="sag-wall"/>
+          <p:cNvSpPr/>
+          <p:nvPr/>
+        </p:nvSpPr>
+        <p:spPr>
+          <a:xfrm>
+            <a:off x="6355080" y="1051560"/>
+            <a:ext cx="1417320" cy="2578608"/>
+          </a:xfrm>
+          <a:custGeom>
+            <a:avLst/>
+            <a:gdLst/>
+            <a:ahLst/>
+            <a:cxnLst/>
+            <a:rect l="l" t="t" r="r" b="b"/>
+            <a:pathLst>
+              <a:path w="1417320" h="2578608">
+                <a:moveTo>
+                  <a:pt x="680314" y="51572"/>
+                </a:moveTo>
+                <a:cubicBezTo>
+                  <a:pt x="1162202" y="51572"/>
+                  <a:pt x="1403147" y="567294"/>
+                  <a:pt x="1374800" y="1237732"/>
+                </a:cubicBezTo>
+                <a:cubicBezTo>
+                  <a:pt x="1360627" y="1598737"/>
+                  <a:pt x="1303934" y="1908170"/>
+                  <a:pt x="1162202" y="2114459"/>
+                </a:cubicBezTo>
+                <a:cubicBezTo>
+                  <a:pt x="1020470" y="2294961"/>
+                  <a:pt x="907085" y="2372319"/>
+                  <a:pt x="850392" y="2449678"/>
+                </a:cubicBezTo>
+                <a:lnTo>
+                  <a:pt x="822046" y="2578608"/>
+                </a:lnTo>
+                <a:lnTo>
+                  <a:pt x="623621" y="2578608"/>
+                </a:lnTo>
+                <a:lnTo>
+                  <a:pt x="609448" y="2449678"/>
+                </a:lnTo>
+                <a:cubicBezTo>
+                  <a:pt x="566928" y="2346533"/>
+                  <a:pt x="453542" y="2269175"/>
+                  <a:pt x="340157" y="2166031"/>
+                </a:cubicBezTo>
+                <a:cubicBezTo>
+                  <a:pt x="141732" y="1959742"/>
+                  <a:pt x="28346" y="1598737"/>
+                  <a:pt x="28346" y="1186160"/>
+                </a:cubicBezTo>
+                <a:cubicBezTo>
+                  <a:pt x="28346" y="515722"/>
+                  <a:pt x="255118" y="51572"/>
+                  <a:pt x="680314" y="51572"/>
+                </a:cubicBezTo>
+                <a:close/>
+              </a:path>
+            </a:pathLst>
+          </a:custGeom>
           <a:solidFill>
-            <a:schemeClr val="bg1"/>
+            <a:srgbClr val="D49498"/>
           </a:solidFill>
-          <a:ln w="12700">
+          <a:ln w="9525">
             <a:solidFill>
-              <a:srgbClr val="A6A6A6"/>
+              <a:srgbClr val="8E4F57"/>
             </a:solidFill>
             <a:prstDash val="solid"/>
           </a:ln>
@@ -5302,24 +5917,69 @@
       </p:sp>
       <p:sp>
         <p:nvSpPr>
-          <p:cNvPr id="18" name="ut-scar-body"/>
-          <p:cNvSpPr/>
-          <p:nvPr/>
-        </p:nvSpPr>
-        <p:spPr>
-          <a:xfrm>
-            <a:off x="5303520" y="2450592"/>
-            <a:ext cx="731520" cy="844906"/>
-          </a:xfrm>
-          <a:prstGeom prst="ellipse">
-            <a:avLst/>
-          </a:prstGeom>
+          <p:cNvPr id="19" name="sag-cavity"/>
+          <p:cNvSpPr/>
+          <p:nvPr/>
+        </p:nvSpPr>
+        <p:spPr>
+          <a:xfrm>
+            <a:off x="6355080" y="1051560"/>
+            <a:ext cx="1417320" cy="2578608"/>
+          </a:xfrm>
+          <a:custGeom>
+            <a:avLst/>
+            <a:gdLst/>
+            <a:ahLst/>
+            <a:cxnLst/>
+            <a:rect l="l" t="t" r="r" b="b"/>
+            <a:pathLst>
+              <a:path w="1417320" h="2578608">
+                <a:moveTo>
+                  <a:pt x="680314" y="206289"/>
+                </a:moveTo>
+                <a:cubicBezTo>
+                  <a:pt x="1105510" y="206289"/>
+                  <a:pt x="1289761" y="644652"/>
+                  <a:pt x="1275588" y="1237732"/>
+                </a:cubicBezTo>
+                <a:cubicBezTo>
+                  <a:pt x="1261415" y="1572951"/>
+                  <a:pt x="1204722" y="1830812"/>
+                  <a:pt x="1091336" y="2037100"/>
+                </a:cubicBezTo>
+                <a:cubicBezTo>
+                  <a:pt x="977951" y="2191817"/>
+                  <a:pt x="850392" y="2269175"/>
+                  <a:pt x="751180" y="2346533"/>
+                </a:cubicBezTo>
+                <a:lnTo>
+                  <a:pt x="708660" y="2346533"/>
+                </a:lnTo>
+                <a:cubicBezTo>
+                  <a:pt x="623621" y="2294961"/>
+                  <a:pt x="510235" y="2191817"/>
+                  <a:pt x="425196" y="2088672"/>
+                </a:cubicBezTo>
+                <a:cubicBezTo>
+                  <a:pt x="240944" y="1908170"/>
+                  <a:pt x="127559" y="1598737"/>
+                  <a:pt x="127559" y="1186160"/>
+                </a:cubicBezTo>
+                <a:cubicBezTo>
+                  <a:pt x="127559" y="618866"/>
+                  <a:pt x="311810" y="206289"/>
+                  <a:pt x="680314" y="206289"/>
+                </a:cubicBezTo>
+                <a:close/>
+              </a:path>
+            </a:pathLst>
+          </a:custGeom>
           <a:solidFill>
-            <a:schemeClr val="bg1"/>
+            <a:srgbClr val="F7F2EC"/>
           </a:solidFill>
-          <a:ln w="12700">
+          <a:ln w="6350">
             <a:solidFill>
-              <a:srgbClr val="A6A6A6"/>
+              <a:srgbClr val="8E4F57"/>
             </a:solidFill>
             <a:prstDash val="solid"/>
           </a:ln>
@@ -5327,42 +5987,35 @@
       </p:sp>
       <p:sp>
         <p:nvSpPr>
-          <p:cNvPr id="19" name="ut-scar-placenta"/>
-          <p:cNvSpPr/>
-          <p:nvPr/>
-        </p:nvSpPr>
-        <p:spPr>
-          <a:xfrm>
-            <a:off x="5468112" y="3072384"/>
-            <a:ext cx="402336" cy="182880"/>
-          </a:xfrm>
-          <a:prstGeom prst="ellipse">
-            <a:avLst/>
-          </a:prstGeom>
-          <a:solidFill>
-            <a:schemeClr val="accent2"/>
-          </a:solidFill>
-          <a:ln/>
-        </p:spPr>
-      </p:sp>
-      <p:sp>
-        <p:nvSpPr>
-          <p:cNvPr id="20" name="ut-scar-line"/>
-          <p:cNvSpPr/>
-          <p:nvPr/>
-        </p:nvSpPr>
-        <p:spPr>
-          <a:xfrm>
-            <a:off x="5449824" y="3200400"/>
-            <a:ext cx="438912" cy="0"/>
-          </a:xfrm>
-          <a:prstGeom prst="line">
-            <a:avLst/>
-          </a:prstGeom>
-          <a:noFill/>
-          <a:ln w="38100">
+          <p:cNvPr id="20" name="sag-canal"/>
+          <p:cNvSpPr/>
+          <p:nvPr/>
+        </p:nvSpPr>
+        <p:spPr>
+          <a:xfrm>
+            <a:off x="6355080" y="1051560"/>
+            <a:ext cx="1417320" cy="2578608"/>
+          </a:xfrm>
+          <a:custGeom>
+            <a:avLst/>
+            <a:gdLst/>
+            <a:ahLst/>
+            <a:cxnLst/>
+            <a:rect l="l" t="t" r="r" b="b"/>
+            <a:pathLst>
+              <a:path w="1417320" h="2578608">
+                <a:moveTo>
+                  <a:pt x="729920" y="2346533"/>
+                </a:moveTo>
+                <a:lnTo>
+                  <a:pt x="729920" y="2578608"/>
+                </a:lnTo>
+              </a:path>
+            </a:pathLst>
+          </a:custGeom>
+          <a:ln w="19050">
             <a:solidFill>
-              <a:srgbClr val="7A2048"/>
+              <a:srgbClr val="8E4F57"/>
             </a:solidFill>
             <a:prstDash val="solid"/>
           </a:ln>
@@ -5370,22 +6023,24 @@
       </p:sp>
       <p:sp>
         <p:nvSpPr>
-          <p:cNvPr id="21" name="scar-leg-key"/>
-          <p:cNvSpPr/>
-          <p:nvPr/>
-        </p:nvSpPr>
-        <p:spPr>
-          <a:xfrm>
-            <a:off x="6217920" y="2551176"/>
-            <a:ext cx="274320" cy="0"/>
-          </a:xfrm>
-          <a:prstGeom prst="line">
-            <a:avLst/>
-          </a:prstGeom>
-          <a:noFill/>
-          <a:ln w="31750">
+          <p:cNvPr id="21" name="sag-fetus-body"/>
+          <p:cNvSpPr/>
+          <p:nvPr/>
+        </p:nvSpPr>
+        <p:spPr>
+          <a:xfrm rot="-720000">
+            <a:off x="6610198" y="1567282"/>
+            <a:ext cx="708660" cy="979871"/>
+          </a:xfrm>
+          <a:prstGeom prst="ellipse">
+            <a:avLst/>
+          </a:prstGeom>
+          <a:solidFill>
+            <a:srgbClr val="EDCBB2"/>
+          </a:solidFill>
+          <a:ln w="9525">
             <a:solidFill>
-              <a:srgbClr val="7A2048"/>
+              <a:srgbClr val="B5876C"/>
             </a:solidFill>
             <a:prstDash val="solid"/>
           </a:ln>
@@ -5393,14 +6048,39 @@
       </p:sp>
       <p:sp>
         <p:nvSpPr>
-          <p:cNvPr id="22" name="Text 20"/>
-          <p:cNvSpPr txBox="1"/>
-          <p:nvPr/>
-        </p:nvSpPr>
-        <p:spPr>
-          <a:xfrm>
-            <a:off x="6565392" y="2432304"/>
-            <a:ext cx="2121408" cy="237744"/>
+          <p:cNvPr id="22" name="sag-fetus-head"/>
+          <p:cNvSpPr/>
+          <p:nvPr/>
+        </p:nvSpPr>
+        <p:spPr>
+          <a:xfrm>
+            <a:off x="6709410" y="2418222"/>
+            <a:ext cx="510235" cy="541508"/>
+          </a:xfrm>
+          <a:prstGeom prst="ellipse">
+            <a:avLst/>
+          </a:prstGeom>
+          <a:solidFill>
+            <a:srgbClr val="EDCBB2"/>
+          </a:solidFill>
+          <a:ln w="9525">
+            <a:solidFill>
+              <a:srgbClr val="B5876C"/>
+            </a:solidFill>
+            <a:prstDash val="solid"/>
+          </a:ln>
+        </p:spPr>
+      </p:sp>
+      <p:sp>
+        <p:nvSpPr>
+          <p:cNvPr id="23" name="Text 21"/>
+          <p:cNvSpPr txBox="1"/>
+          <p:nvPr/>
+        </p:nvSpPr>
+        <p:spPr>
+          <a:xfrm>
+            <a:off x="6610198" y="1876715"/>
+            <a:ext cx="651967" cy="237744"/>
           </a:xfrm>
           <a:prstGeom prst="rect">
             <a:avLst/>
@@ -5412,16 +6092,231 @@
           <a:bodyPr wrap="square" lIns="0" tIns="0" rIns="0" bIns="0" rtlCol="0" anchor="ctr"/>
           <a:lstStyle/>
           <a:p>
+            <a:pPr algn="ctr" indent="0" marL="0">
+              <a:buNone/>
+            </a:pPr>
+            <a:r>
+              <a:rPr lang="en-US" sz="1200" dirty="0">
+                <a:solidFill>
+                  <a:schemeClr val="tx1"/>
+                </a:solidFill>
+              </a:rPr>
+              <a:t>胎児</a:t>
+            </a:r>
+            <a:endParaRPr lang="en-US" sz="1200" dirty="0"/>
+          </a:p>
+        </p:txBody>
+      </p:sp>
+      <p:sp>
+        <p:nvSpPr>
+          <p:cNvPr id="24" name="sag-placenta"/>
+          <p:cNvSpPr/>
+          <p:nvPr/>
+        </p:nvSpPr>
+        <p:spPr>
+          <a:xfrm>
+            <a:off x="6355080" y="1051560"/>
+            <a:ext cx="1417320" cy="2578608"/>
+          </a:xfrm>
+          <a:custGeom>
+            <a:avLst/>
+            <a:gdLst/>
+            <a:ahLst/>
+            <a:cxnLst/>
+            <a:rect l="l" t="t" r="r" b="b"/>
+            <a:pathLst>
+              <a:path w="1417320" h="2578608">
+                <a:moveTo>
+                  <a:pt x="1275588" y="1186160"/>
+                </a:moveTo>
+                <a:cubicBezTo>
+                  <a:pt x="1275588" y="1547165"/>
+                  <a:pt x="1218895" y="1805026"/>
+                  <a:pt x="1091336" y="2037100"/>
+                </a:cubicBezTo>
+                <a:cubicBezTo>
+                  <a:pt x="977951" y="2191817"/>
+                  <a:pt x="864565" y="2269175"/>
+                  <a:pt x="765353" y="2346533"/>
+                </a:cubicBezTo>
+                <a:lnTo>
+                  <a:pt x="779526" y="2217603"/>
+                </a:lnTo>
+                <a:cubicBezTo>
+                  <a:pt x="878738" y="2140245"/>
+                  <a:pt x="977951" y="2011314"/>
+                  <a:pt x="1048817" y="1856598"/>
+                </a:cubicBezTo>
+                <a:cubicBezTo>
+                  <a:pt x="1119683" y="1650309"/>
+                  <a:pt x="1148029" y="1418234"/>
+                  <a:pt x="1133856" y="1186160"/>
+                </a:cubicBezTo>
+                <a:close/>
+              </a:path>
+            </a:pathLst>
+          </a:custGeom>
+          <a:solidFill>
+            <a:srgbClr val="8B2E3B"/>
+          </a:solidFill>
+          <a:ln/>
+        </p:spPr>
+      </p:sp>
+      <p:sp>
+        <p:nvSpPr>
+          <p:cNvPr id="25" name="sag-placenta-invasion"/>
+          <p:cNvSpPr/>
+          <p:nvPr/>
+        </p:nvSpPr>
+        <p:spPr>
+          <a:xfrm>
+            <a:off x="6355080" y="1051560"/>
+            <a:ext cx="1417320" cy="2578608"/>
+          </a:xfrm>
+          <a:custGeom>
+            <a:avLst/>
+            <a:gdLst/>
+            <a:ahLst/>
+            <a:cxnLst/>
+            <a:rect l="l" t="t" r="r" b="b"/>
+            <a:pathLst>
+              <a:path w="1417320" h="2578608">
+                <a:moveTo>
+                  <a:pt x="1077163" y="1908170"/>
+                </a:moveTo>
+                <a:lnTo>
+                  <a:pt x="1233068" y="2037100"/>
+                </a:lnTo>
+                <a:lnTo>
+                  <a:pt x="1133856" y="2166031"/>
+                </a:lnTo>
+                <a:close/>
+              </a:path>
+            </a:pathLst>
+          </a:custGeom>
+          <a:solidFill>
+            <a:srgbClr val="8B2E3B"/>
+          </a:solidFill>
+          <a:ln/>
+        </p:spPr>
+      </p:sp>
+      <p:sp>
+        <p:nvSpPr>
+          <p:cNvPr id="26" name="sag-scar"/>
+          <p:cNvSpPr/>
+          <p:nvPr/>
+        </p:nvSpPr>
+        <p:spPr>
+          <a:xfrm>
+            <a:off x="6355080" y="1051560"/>
+            <a:ext cx="1417320" cy="2578608"/>
+          </a:xfrm>
+          <a:custGeom>
+            <a:avLst/>
+            <a:gdLst/>
+            <a:ahLst/>
+            <a:cxnLst/>
+            <a:rect l="l" t="t" r="r" b="b"/>
+            <a:pathLst>
+              <a:path w="1417320" h="2578608">
+                <a:moveTo>
+                  <a:pt x="1233068" y="1959742"/>
+                </a:moveTo>
+                <a:cubicBezTo>
+                  <a:pt x="1218895" y="2037100"/>
+                  <a:pt x="1204722" y="2088672"/>
+                  <a:pt x="1176376" y="2140245"/>
+                </a:cubicBezTo>
+              </a:path>
+            </a:pathLst>
+          </a:custGeom>
+          <a:ln w="38100">
+            <a:solidFill>
+              <a:srgbClr val="2B1B1E"/>
+            </a:solidFill>
+            <a:prstDash val="solid"/>
+          </a:ln>
+        </p:spPr>
+      </p:sp>
+      <p:sp>
+        <p:nvSpPr>
+          <p:cNvPr id="27" name="sag-bladder"/>
+          <p:cNvSpPr/>
+          <p:nvPr/>
+        </p:nvSpPr>
+        <p:spPr>
+          <a:xfrm>
+            <a:off x="7375550" y="3217591"/>
+            <a:ext cx="382676" cy="335219"/>
+          </a:xfrm>
+          <a:prstGeom prst="ellipse">
+            <a:avLst/>
+          </a:prstGeom>
+          <a:solidFill>
+            <a:srgbClr val="E2C46E"/>
+          </a:solidFill>
+          <a:ln w="9525">
+            <a:solidFill>
+              <a:srgbClr val="A88A3A"/>
+            </a:solidFill>
+            <a:prstDash val="solid"/>
+          </a:ln>
+        </p:spPr>
+      </p:sp>
+      <p:sp>
+        <p:nvSpPr>
+          <p:cNvPr id="28" name="sag-l1-leader"/>
+          <p:cNvSpPr/>
+          <p:nvPr/>
+        </p:nvSpPr>
+        <p:spPr>
+          <a:xfrm>
+            <a:off x="7573975" y="2547153"/>
+            <a:ext cx="308153" cy="-96561"/>
+          </a:xfrm>
+          <a:prstGeom prst="line">
+            <a:avLst/>
+          </a:prstGeom>
+          <a:noFill/>
+          <a:ln w="9525">
+            <a:solidFill>
+              <a:schemeClr val="tx1"/>
+            </a:solidFill>
+            <a:prstDash val="solid"/>
+          </a:ln>
+        </p:spPr>
+      </p:sp>
+      <p:sp>
+        <p:nvSpPr>
+          <p:cNvPr id="29" name="Text 27"/>
+          <p:cNvSpPr txBox="1"/>
+          <p:nvPr/>
+        </p:nvSpPr>
+        <p:spPr>
+          <a:xfrm>
+            <a:off x="7927848" y="2331720"/>
+            <a:ext cx="758952" cy="237744"/>
+          </a:xfrm>
+          <a:prstGeom prst="rect">
+            <a:avLst/>
+          </a:prstGeom>
+          <a:noFill/>
+          <a:ln/>
+        </p:spPr>
+        <p:txBody>
+          <a:bodyPr wrap="square" lIns="0" tIns="0" rIns="0" bIns="0" rtlCol="0" anchor="ctr"/>
+          <a:lstStyle/>
+          <a:p>
             <a:pPr indent="0" marL="0">
               <a:buNone/>
             </a:pPr>
             <a:r>
-              <a:rPr lang="en-US" sz="1300" b="1" dirty="0">
-                <a:solidFill>
-                  <a:srgbClr val="7A2048"/>
-                </a:solidFill>
-              </a:rPr>
-              <a:t>前回の切開瘢痕</a:t>
+              <a:rPr lang="en-US" sz="1300" dirty="0">
+                <a:solidFill>
+                  <a:schemeClr val="tx1"/>
+                </a:solidFill>
+              </a:rPr>
+              <a:t>胎盤</a:t>
             </a:r>
             <a:endParaRPr lang="en-US" sz="1300" dirty="0"/>
           </a:p>
@@ -5429,31 +6324,50 @@
       </p:sp>
       <p:sp>
         <p:nvSpPr>
-          <p:cNvPr id="23" name="Text 21"/>
-          <p:cNvSpPr txBox="1"/>
-          <p:nvPr/>
-        </p:nvSpPr>
-        <p:spPr>
-          <a:xfrm>
-            <a:off x="6217920" y="2743200"/>
-            <a:ext cx="2468880" cy="868680"/>
-          </a:xfrm>
-          <a:prstGeom prst="rect">
-            <a:avLst/>
-          </a:prstGeom>
-          <a:noFill/>
-          <a:ln/>
-        </p:spPr>
-        <p:txBody>
-          <a:bodyPr wrap="square" lIns="0" tIns="0" rIns="0" bIns="0" rtlCol="0" anchor="t"/>
-          <a:lstStyle/>
-          <a:p>
-            <a:pPr marL="152400" indent="-152400">
-              <a:spcAft>
-                <a:spcPts val="200"/>
-              </a:spcAft>
-              <a:buSzPct val="100000"/>
-              <a:buChar char="•"/>
+          <p:cNvPr id="30" name="sag-l2-leader"/>
+          <p:cNvSpPr/>
+          <p:nvPr/>
+        </p:nvSpPr>
+        <p:spPr>
+          <a:xfrm>
+            <a:off x="7588148" y="3062874"/>
+            <a:ext cx="293980" cy="-246522"/>
+          </a:xfrm>
+          <a:prstGeom prst="line">
+            <a:avLst/>
+          </a:prstGeom>
+          <a:noFill/>
+          <a:ln w="9525">
+            <a:solidFill>
+              <a:schemeClr val="tx1"/>
+            </a:solidFill>
+            <a:prstDash val="solid"/>
+          </a:ln>
+        </p:spPr>
+      </p:sp>
+      <p:sp>
+        <p:nvSpPr>
+          <p:cNvPr id="31" name="Text 29"/>
+          <p:cNvSpPr txBox="1"/>
+          <p:nvPr/>
+        </p:nvSpPr>
+        <p:spPr>
+          <a:xfrm>
+            <a:off x="7927848" y="2697480"/>
+            <a:ext cx="758952" cy="237744"/>
+          </a:xfrm>
+          <a:prstGeom prst="rect">
+            <a:avLst/>
+          </a:prstGeom>
+          <a:noFill/>
+          <a:ln/>
+        </p:spPr>
+        <p:txBody>
+          <a:bodyPr wrap="square" lIns="0" tIns="0" rIns="0" bIns="0" rtlCol="0" anchor="ctr"/>
+          <a:lstStyle/>
+          <a:p>
+            <a:pPr indent="0" marL="0">
+              <a:buNone/>
             </a:pPr>
             <a:r>
               <a:rPr lang="en-US" sz="1300" dirty="0">
@@ -5461,17 +6375,58 @@
                   <a:schemeClr val="tx1"/>
                 </a:solidFill>
               </a:rPr>
-              <a:t>瘢痕が裂ける → 子宮破裂</a:t>
+              <a:t>瘢痕</a:t>
             </a:r>
             <a:endParaRPr lang="en-US" sz="1300" dirty="0"/>
           </a:p>
-          <a:p>
-            <a:pPr marL="152400" indent="-152400">
-              <a:spcAft>
-                <a:spcPts val="200"/>
-              </a:spcAft>
-              <a:buSzPct val="100000"/>
-              <a:buChar char="•"/>
+        </p:txBody>
+      </p:sp>
+      <p:sp>
+        <p:nvSpPr>
+          <p:cNvPr id="32" name="sag-l3-leader"/>
+          <p:cNvSpPr/>
+          <p:nvPr/>
+        </p:nvSpPr>
+        <p:spPr>
+          <a:xfrm>
+            <a:off x="7659014" y="3372307"/>
+            <a:ext cx="223114" cy="-190195"/>
+          </a:xfrm>
+          <a:prstGeom prst="line">
+            <a:avLst/>
+          </a:prstGeom>
+          <a:noFill/>
+          <a:ln w="9525">
+            <a:solidFill>
+              <a:schemeClr val="tx1"/>
+            </a:solidFill>
+            <a:prstDash val="solid"/>
+          </a:ln>
+        </p:spPr>
+      </p:sp>
+      <p:sp>
+        <p:nvSpPr>
+          <p:cNvPr id="33" name="Text 31"/>
+          <p:cNvSpPr txBox="1"/>
+          <p:nvPr/>
+        </p:nvSpPr>
+        <p:spPr>
+          <a:xfrm>
+            <a:off x="7927848" y="3063240"/>
+            <a:ext cx="758952" cy="237744"/>
+          </a:xfrm>
+          <a:prstGeom prst="rect">
+            <a:avLst/>
+          </a:prstGeom>
+          <a:noFill/>
+          <a:ln/>
+        </p:spPr>
+        <p:txBody>
+          <a:bodyPr wrap="square" lIns="0" tIns="0" rIns="0" bIns="0" rtlCol="0" anchor="ctr"/>
+          <a:lstStyle/>
+          <a:p>
+            <a:pPr indent="0" marL="0">
+              <a:buNone/>
             </a:pPr>
             <a:r>
               <a:rPr lang="en-US" sz="1300" dirty="0">
@@ -5479,17 +6434,58 @@
                   <a:schemeClr val="tx1"/>
                 </a:solidFill>
               </a:rPr>
-              <a:t>瘢痕に胎盤 → 前置・癒着胎盤</a:t>
+              <a:t>膀胱</a:t>
             </a:r>
             <a:endParaRPr lang="en-US" sz="1300" dirty="0"/>
           </a:p>
-          <a:p>
-            <a:pPr marL="152400" indent="-152400">
-              <a:spcAft>
-                <a:spcPts val="200"/>
-              </a:spcAft>
-              <a:buSzPct val="100000"/>
-              <a:buChar char="•"/>
+        </p:txBody>
+      </p:sp>
+      <p:sp>
+        <p:nvSpPr>
+          <p:cNvPr id="34" name="sag-l4-leader"/>
+          <p:cNvSpPr/>
+          <p:nvPr/>
+        </p:nvSpPr>
+        <p:spPr>
+          <a:xfrm>
+            <a:off x="7092086" y="3578596"/>
+            <a:ext cx="790042" cy="-58156"/>
+          </a:xfrm>
+          <a:prstGeom prst="line">
+            <a:avLst/>
+          </a:prstGeom>
+          <a:noFill/>
+          <a:ln w="9525">
+            <a:solidFill>
+              <a:schemeClr val="tx1"/>
+            </a:solidFill>
+            <a:prstDash val="solid"/>
+          </a:ln>
+        </p:spPr>
+      </p:sp>
+      <p:sp>
+        <p:nvSpPr>
+          <p:cNvPr id="35" name="Text 33"/>
+          <p:cNvSpPr txBox="1"/>
+          <p:nvPr/>
+        </p:nvSpPr>
+        <p:spPr>
+          <a:xfrm>
+            <a:off x="7927848" y="3401568"/>
+            <a:ext cx="758952" cy="237744"/>
+          </a:xfrm>
+          <a:prstGeom prst="rect">
+            <a:avLst/>
+          </a:prstGeom>
+          <a:noFill/>
+          <a:ln/>
+        </p:spPr>
+        <p:txBody>
+          <a:bodyPr wrap="square" lIns="0" tIns="0" rIns="0" bIns="0" rtlCol="0" anchor="ctr"/>
+          <a:lstStyle/>
+          <a:p>
+            <a:pPr indent="0" marL="0">
+              <a:buNone/>
             </a:pPr>
             <a:r>
               <a:rPr lang="en-US" sz="1300" dirty="0">
@@ -5497,7 +6493,7 @@
                   <a:schemeClr val="tx1"/>
                 </a:solidFill>
               </a:rPr>
-              <a:t>瘢痕に着床 → 瘢痕部妊娠</a:t>
+              <a:t>子宮頸部</a:t>
             </a:r>
             <a:endParaRPr lang="en-US" sz="1300" dirty="0"/>
           </a:p>
@@ -5505,7 +6501,43 @@
       </p:sp>
       <p:sp>
         <p:nvSpPr>
-          <p:cNvPr id="24" name="neonate-decor"/>
+          <p:cNvPr id="36" name="Text 34"/>
+          <p:cNvSpPr txBox="1"/>
+          <p:nvPr/>
+        </p:nvSpPr>
+        <p:spPr>
+          <a:xfrm>
+            <a:off x="7882128" y="1097280"/>
+            <a:ext cx="804672" cy="237744"/>
+          </a:xfrm>
+          <a:prstGeom prst="rect">
+            <a:avLst/>
+          </a:prstGeom>
+          <a:noFill/>
+          <a:ln/>
+        </p:spPr>
+        <p:txBody>
+          <a:bodyPr wrap="square" lIns="0" tIns="0" rIns="0" bIns="0" rtlCol="0" anchor="ctr"/>
+          <a:lstStyle/>
+          <a:p>
+            <a:pPr indent="0" marL="0">
+              <a:buNone/>
+            </a:pPr>
+            <a:r>
+              <a:rPr lang="en-US" sz="1200" dirty="0">
+                <a:solidFill>
+                  <a:schemeClr val="accent5"/>
+                </a:solidFill>
+              </a:rPr>
+              <a:t>お腹側 →</a:t>
+            </a:r>
+            <a:endParaRPr lang="en-US" sz="1200" dirty="0"/>
+          </a:p>
+        </p:txBody>
+      </p:sp>
+      <p:sp>
+        <p:nvSpPr>
+          <p:cNvPr id="37" name="neonate-decor"/>
           <p:cNvSpPr/>
           <p:nvPr/>
         </p:nvSpPr>
@@ -5527,14 +6559,14 @@
       </p:sp>
       <p:sp>
         <p:nvSpPr>
-          <p:cNvPr id="25" name="neonate-rule"/>
-          <p:cNvSpPr/>
-          <p:nvPr/>
-        </p:nvSpPr>
-        <p:spPr>
-          <a:xfrm>
-            <a:off x="5303520" y="4526280"/>
-            <a:ext cx="3383280" cy="0"/>
+          <p:cNvPr id="38" name="neonate-rule"/>
+          <p:cNvSpPr/>
+          <p:nvPr/>
+        </p:nvSpPr>
+        <p:spPr>
+          <a:xfrm>
+            <a:off x="4114800" y="4526280"/>
+            <a:ext cx="4572000" cy="0"/>
           </a:xfrm>
           <a:prstGeom prst="line">
             <a:avLst/>
@@ -5550,14 +6582,14 @@
       </p:sp>
       <p:sp>
         <p:nvSpPr>
-          <p:cNvPr id="26" name="Text 24"/>
-          <p:cNvSpPr txBox="1"/>
-          <p:nvPr/>
-        </p:nvSpPr>
-        <p:spPr>
-          <a:xfrm>
-            <a:off x="5303520" y="3840480"/>
-            <a:ext cx="3383280" cy="320040"/>
+          <p:cNvPr id="39" name="Text 37"/>
+          <p:cNvSpPr txBox="1"/>
+          <p:nvPr/>
+        </p:nvSpPr>
+        <p:spPr>
+          <a:xfrm>
+            <a:off x="4114800" y="3840480"/>
+            <a:ext cx="4572000" cy="320040"/>
           </a:xfrm>
           <a:prstGeom prst="rect">
             <a:avLst/>
@@ -5586,14 +6618,14 @@
       </p:sp>
       <p:sp>
         <p:nvSpPr>
-          <p:cNvPr id="27" name="Text 25"/>
-          <p:cNvSpPr txBox="1"/>
-          <p:nvPr/>
-        </p:nvSpPr>
-        <p:spPr>
-          <a:xfrm>
-            <a:off x="5303520" y="4178808"/>
-            <a:ext cx="3291840" cy="274320"/>
+          <p:cNvPr id="40" name="Text 38"/>
+          <p:cNvSpPr txBox="1"/>
+          <p:nvPr/>
+        </p:nvSpPr>
+        <p:spPr>
+          <a:xfrm>
+            <a:off x="4114800" y="4178808"/>
+            <a:ext cx="4572000" cy="274320"/>
           </a:xfrm>
           <a:prstGeom prst="rect">
             <a:avLst/>
@@ -5614,7 +6646,7 @@
                   <a:schemeClr val="tx1"/>
                 </a:solidFill>
               </a:rPr>
-              <a:t>陣痛なしの出生で肺の水の吸収が遅れる</a:t>
+              <a:t>陣痛を経ずに生まれると、肺の水の吸収が遅れやすい</a:t>
             </a:r>
             <a:endParaRPr lang="en-US" sz="1200" dirty="0"/>
           </a:p>
@@ -5622,7 +6654,7 @@
       </p:sp>
       <p:sp>
         <p:nvSpPr>
-          <p:cNvPr id="28" name="source"/>
+          <p:cNvPr id="41" name="source"/>
           <p:cNvSpPr txBox="1"/>
           <p:nvPr/>
         </p:nvSpPr>

</xml_diff>